<commit_message>
feat(prep): record doc-length covariate for all datasets
</commit_message>
<xml_diff>
--- a/docs/ThinkConflict_연구보고.pptx
+++ b/docs/ThinkConflict_연구보고.pptx
@@ -15,16 +15,16 @@
     <p:sldId id="654" r:id="rId6"/>
     <p:sldId id="658" r:id="rId7"/>
     <p:sldId id="660" r:id="rId8"/>
-    <p:sldId id="666" r:id="rId9"/>
+    <p:sldId id="678" r:id="rId9"/>
     <p:sldId id="406" r:id="rId10"/>
     <p:sldId id="667" r:id="rId11"/>
-    <p:sldId id="675" r:id="rId12"/>
+    <p:sldId id="679" r:id="rId12"/>
     <p:sldId id="569" r:id="rId13"/>
     <p:sldId id="570" r:id="rId14"/>
     <p:sldId id="571" r:id="rId15"/>
     <p:sldId id="599" r:id="rId16"/>
     <p:sldId id="676" r:id="rId17"/>
-    <p:sldId id="640" r:id="rId18"/>
+    <p:sldId id="681" r:id="rId18"/>
     <p:sldId id="595" r:id="rId19"/>
     <p:sldId id="644" r:id="rId20"/>
     <p:sldId id="645" r:id="rId21"/>
@@ -4450,7 +4450,13 @@
           <p:cNvGraphicFramePr>
             <a:graphicFrameLocks noGrp="1"/>
           </p:cNvGraphicFramePr>
-          <p:nvPr/>
+          <p:nvPr>
+            <p:extLst>
+              <p:ext uri="{D42A27DB-BD31-4B8C-83A1-F6EECF244321}">
+                <p14:modId xmlns:p14="http://schemas.microsoft.com/office/powerpoint/2010/main" val="1687911412"/>
+              </p:ext>
+            </p:extLst>
+          </p:nvPr>
         </p:nvGraphicFramePr>
         <p:xfrm>
           <a:off x="548640" y="2550160"/>
@@ -4484,7 +4490,7 @@
                     <a:bodyPr/>
                     <a:lstStyle/>
                     <a:p>
-                      <a:pPr algn="l">
+                      <a:pPr algn="ctr">
                         <a:lnSpc>
                           <a:spcPct val="114000"/>
                         </a:lnSpc>
@@ -4493,15 +4499,22 @@
                         </a:spcAft>
                       </a:pPr>
                       <a:r>
-                        <a:rPr sz="960" b="1">
+                        <a:rPr lang="ko-KR" altLang="en-US" sz="960" b="1" dirty="0">
                           <a:solidFill>
                             <a:srgbClr val="FFFFFF"/>
                           </a:solidFill>
                           <a:latin typeface="맑은 고딕"/>
                           <a:ea typeface="맑은 고딕"/>
                         </a:rPr>
-                        <a:t>Conflict type (충돌 유형)</a:t>
-                      </a:r>
+                        <a:t>충돌 유형</a:t>
+                      </a:r>
+                      <a:endParaRPr sz="960" b="1" dirty="0">
+                        <a:solidFill>
+                          <a:srgbClr val="FFFFFF"/>
+                        </a:solidFill>
+                        <a:latin typeface="맑은 고딕"/>
+                        <a:ea typeface="맑은 고딕"/>
+                      </a:endParaRPr>
                     </a:p>
                   </a:txBody>
                   <a:tcPr marL="82296" marR="82296" marT="36576" marB="36576" anchor="ctr">
@@ -4515,7 +4528,7 @@
                     <a:bodyPr/>
                     <a:lstStyle/>
                     <a:p>
-                      <a:pPr algn="l">
+                      <a:pPr algn="ctr">
                         <a:lnSpc>
                           <a:spcPct val="114000"/>
                         </a:lnSpc>
@@ -4524,7 +4537,7 @@
                         </a:spcAft>
                       </a:pPr>
                       <a:r>
-                        <a:rPr sz="960" b="1">
+                        <a:rPr sz="960" b="1" dirty="0" err="1">
                           <a:solidFill>
                             <a:srgbClr val="FFFFFF"/>
                           </a:solidFill>
@@ -4533,6 +4546,13 @@
                         </a:rPr>
                         <a:t>건수</a:t>
                       </a:r>
+                      <a:endParaRPr sz="960" b="1" dirty="0">
+                        <a:solidFill>
+                          <a:srgbClr val="FFFFFF"/>
+                        </a:solidFill>
+                        <a:latin typeface="맑은 고딕"/>
+                        <a:ea typeface="맑은 고딕"/>
+                      </a:endParaRPr>
                     </a:p>
                   </a:txBody>
                   <a:tcPr marL="82296" marR="82296" marT="36576" marB="36576" anchor="ctr">
@@ -4938,7 +4958,7 @@
                         </a:spcAft>
                       </a:pPr>
                       <a:r>
-                        <a:rPr lang="ko-KR" sz="960" b="0">
+                        <a:rPr lang="ko-KR" sz="960" b="0" dirty="0">
                           <a:solidFill>
                             <a:srgbClr val="1E2227"/>
                           </a:solidFill>
@@ -5077,7 +5097,13 @@
           <p:cNvGraphicFramePr>
             <a:graphicFrameLocks noGrp="1"/>
           </p:cNvGraphicFramePr>
-          <p:nvPr/>
+          <p:nvPr>
+            <p:extLst>
+              <p:ext uri="{D42A27DB-BD31-4B8C-83A1-F6EECF244321}">
+                <p14:modId xmlns:p14="http://schemas.microsoft.com/office/powerpoint/2010/main" val="2692243962"/>
+              </p:ext>
+            </p:extLst>
+          </p:nvPr>
         </p:nvGraphicFramePr>
         <p:xfrm>
           <a:off x="4329684" y="2550160"/>
@@ -5111,7 +5137,7 @@
                     <a:bodyPr/>
                     <a:lstStyle/>
                     <a:p>
-                      <a:pPr algn="l">
+                      <a:pPr algn="ctr">
                         <a:lnSpc>
                           <a:spcPct val="110000"/>
                         </a:lnSpc>
@@ -5142,7 +5168,7 @@
                     <a:bodyPr/>
                     <a:lstStyle/>
                     <a:p>
-                      <a:pPr algn="l">
+                      <a:pPr algn="ctr">
                         <a:lnSpc>
                           <a:spcPct val="110000"/>
                         </a:lnSpc>
@@ -5151,7 +5177,7 @@
                         </a:spcAft>
                       </a:pPr>
                       <a:r>
-                        <a:rPr lang="ko-KR" sz="960" b="1">
+                        <a:rPr lang="ko-KR" sz="960" b="1" dirty="0">
                           <a:solidFill>
                             <a:srgbClr val="FFFFFF"/>
                           </a:solidFill>
@@ -5569,7 +5595,7 @@
           <p:nvPr>
             <p:extLst>
               <p:ext uri="{D42A27DB-BD31-4B8C-83A1-F6EECF244321}">
-                <p14:modId xmlns:p14="http://schemas.microsoft.com/office/powerpoint/2010/main" val="205680314"/>
+                <p14:modId xmlns:p14="http://schemas.microsoft.com/office/powerpoint/2010/main" val="2252924889"/>
               </p:ext>
             </p:extLst>
           </p:nvPr>
@@ -5606,7 +5632,7 @@
                     <a:bodyPr/>
                     <a:lstStyle/>
                     <a:p>
-                      <a:pPr algn="l">
+                      <a:pPr algn="ctr">
                         <a:lnSpc>
                           <a:spcPct val="114000"/>
                         </a:lnSpc>
@@ -5615,15 +5641,22 @@
                         </a:spcAft>
                       </a:pPr>
                       <a:r>
-                        <a:rPr lang="ko-KR" sz="960" b="1">
+                        <a:rPr lang="ko-KR" altLang="en-US" sz="960" b="1" dirty="0">
                           <a:solidFill>
                             <a:srgbClr val="FFFFFF"/>
                           </a:solidFill>
                           <a:latin typeface="맑은 고딕"/>
                           <a:ea typeface="맑은 고딕"/>
                         </a:rPr>
-                        <a:t>충돌 요인 (Factor)</a:t>
-                      </a:r>
+                        <a:t>충돌 유형</a:t>
+                      </a:r>
+                      <a:endParaRPr lang="ko-KR" sz="960" b="1" dirty="0">
+                        <a:solidFill>
+                          <a:srgbClr val="FFFFFF"/>
+                        </a:solidFill>
+                        <a:latin typeface="맑은 고딕"/>
+                        <a:ea typeface="맑은 고딕"/>
+                      </a:endParaRPr>
                     </a:p>
                   </a:txBody>
                   <a:tcPr marL="82296" marR="82296" marT="36576" marB="36576" anchor="ctr">
@@ -5637,7 +5670,7 @@
                     <a:bodyPr/>
                     <a:lstStyle/>
                     <a:p>
-                      <a:pPr algn="l">
+                      <a:pPr algn="ctr">
                         <a:lnSpc>
                           <a:spcPct val="114000"/>
                         </a:lnSpc>
@@ -5646,7 +5679,7 @@
                         </a:spcAft>
                       </a:pPr>
                       <a:r>
-                        <a:rPr lang="ko-KR" sz="960" b="1">
+                        <a:rPr lang="ko-KR" sz="960" b="1" dirty="0">
                           <a:solidFill>
                             <a:srgbClr val="FFFFFF"/>
                           </a:solidFill>
@@ -7616,7 +7649,7 @@
                 <a:latin typeface="Consolas"/>
                 <a:ea typeface="맑은 고딕"/>
               </a:rPr>
-              <a:t>  // 데이터셋 원본 유형 문자열 그대로</a:t>
+              <a:t>  // 5개 라벨 중 하나로 통일 부여</a:t>
             </a:r>
           </a:p>
           <a:p>
@@ -8276,7 +8309,7 @@
     </p:spTree>
     <p:extLst>
       <p:ext uri="{BB962C8B-B14F-4D97-AF65-F5344CB8AC3E}">
-        <p14:creationId xmlns:p14="http://schemas.microsoft.com/office/powerpoint/2010/main" val="435341352"/>
+        <p14:creationId xmlns:p14="http://schemas.microsoft.com/office/powerpoint/2010/main" val="1257862925"/>
       </p:ext>
     </p:extLst>
   </p:cSld>
@@ -8697,7 +8730,27 @@
                 <a:latin typeface="Consolas"/>
                 <a:ea typeface="맑은 고딕"/>
               </a:rPr>
-              <a:t>: "Conflict due to outdated info",</a:t>
+              <a:t>: "</a:t>
+            </a:r>
+            <a:r>
+              <a:rPr lang="en" sz="1120" b="0" dirty="0">
+                <a:solidFill>
+                  <a:srgbClr val="1E2227"/>
+                </a:solidFill>
+                <a:latin typeface="Consolas"/>
+                <a:ea typeface="맑은 고딕"/>
+              </a:rPr>
+              <a:t>Conflict due to outdated info</a:t>
+            </a:r>
+            <a:r>
+              <a:rPr sz="1120" b="0" dirty="0">
+                <a:solidFill>
+                  <a:srgbClr val="1E2227"/>
+                </a:solidFill>
+                <a:latin typeface="Consolas"/>
+                <a:ea typeface="맑은 고딕"/>
+              </a:rPr>
+              <a:t>",</a:t>
             </a:r>
             <a:r>
               <a:rPr sz="1120" b="0" dirty="0">
@@ -9044,7 +9097,7 @@
           <p:nvPr>
             <p:extLst>
               <p:ext uri="{D42A27DB-BD31-4B8C-83A1-F6EECF244321}">
-                <p14:modId xmlns:p14="http://schemas.microsoft.com/office/powerpoint/2010/main" val="523532445"/>
+                <p14:modId xmlns:p14="http://schemas.microsoft.com/office/powerpoint/2010/main" val="715480937"/>
               </p:ext>
             </p:extLst>
           </p:nvPr>
@@ -9081,7 +9134,7 @@
                     <a:bodyPr/>
                     <a:lstStyle/>
                     <a:p>
-                      <a:pPr algn="l">
+                      <a:pPr algn="ctr">
                         <a:lnSpc>
                           <a:spcPct val="114000"/>
                         </a:lnSpc>
@@ -9112,7 +9165,7 @@
                     <a:bodyPr/>
                     <a:lstStyle/>
                     <a:p>
-                      <a:pPr algn="l">
+                      <a:pPr algn="ctr">
                         <a:lnSpc>
                           <a:spcPct val="114000"/>
                         </a:lnSpc>
@@ -10288,7 +10341,7 @@
           <p:nvPr>
             <p:extLst>
               <p:ext uri="{D42A27DB-BD31-4B8C-83A1-F6EECF244321}">
-                <p14:modId xmlns:p14="http://schemas.microsoft.com/office/powerpoint/2010/main" val="3868300476"/>
+                <p14:modId xmlns:p14="http://schemas.microsoft.com/office/powerpoint/2010/main" val="1493033670"/>
               </p:ext>
             </p:extLst>
           </p:nvPr>
@@ -10325,7 +10378,7 @@
                     <a:bodyPr/>
                     <a:lstStyle/>
                     <a:p>
-                      <a:pPr algn="l">
+                      <a:pPr algn="ctr">
                         <a:lnSpc>
                           <a:spcPct val="114000"/>
                         </a:lnSpc>
@@ -10356,7 +10409,7 @@
                     <a:bodyPr/>
                     <a:lstStyle/>
                     <a:p>
-                      <a:pPr algn="l">
+                      <a:pPr algn="ctr">
                         <a:lnSpc>
                           <a:spcPct val="114000"/>
                         </a:lnSpc>
@@ -10365,7 +10418,7 @@
                         </a:spcAft>
                       </a:pPr>
                       <a:r>
-                        <a:rPr sz="1150" b="1">
+                        <a:rPr sz="1150" b="1" dirty="0" err="1">
                           <a:solidFill>
                             <a:srgbClr val="FFFFFF"/>
                           </a:solidFill>
@@ -10374,6 +10427,13 @@
                         </a:rPr>
                         <a:t>내용</a:t>
                       </a:r>
+                      <a:endParaRPr sz="1150" b="1" dirty="0">
+                        <a:solidFill>
+                          <a:srgbClr val="FFFFFF"/>
+                        </a:solidFill>
+                        <a:latin typeface="맑은 고딕"/>
+                        <a:ea typeface="맑은 고딕"/>
+                      </a:endParaRPr>
                     </a:p>
                   </a:txBody>
                   <a:tcPr anchor="ctr">
@@ -11659,13 +11719,13 @@
           <p:nvPr>
             <p:extLst>
               <p:ext uri="{D42A27DB-BD31-4B8C-83A1-F6EECF244321}">
-                <p14:modId xmlns:p14="http://schemas.microsoft.com/office/powerpoint/2010/main" val="603137116"/>
+                <p14:modId xmlns:p14="http://schemas.microsoft.com/office/powerpoint/2010/main" val="1932797181"/>
               </p:ext>
             </p:extLst>
           </p:nvPr>
         </p:nvGraphicFramePr>
         <p:xfrm>
-          <a:off x="548640" y="4191000"/>
+          <a:off x="548640" y="4266542"/>
           <a:ext cx="11086800" cy="1840000"/>
         </p:xfrm>
         <a:graphic>
@@ -11696,7 +11756,7 @@
                     <a:bodyPr/>
                     <a:lstStyle/>
                     <a:p>
-                      <a:pPr algn="l">
+                      <a:pPr algn="ctr">
                         <a:lnSpc>
                           <a:spcPct val="112000"/>
                         </a:lnSpc>
@@ -11727,7 +11787,7 @@
                     <a:bodyPr/>
                     <a:lstStyle/>
                     <a:p>
-                      <a:pPr algn="l">
+                      <a:pPr algn="ctr">
                         <a:lnSpc>
                           <a:spcPct val="112000"/>
                         </a:lnSpc>
@@ -13166,7 +13226,7 @@
           <p:nvPr>
             <p:extLst>
               <p:ext uri="{D42A27DB-BD31-4B8C-83A1-F6EECF244321}">
-                <p14:modId xmlns:p14="http://schemas.microsoft.com/office/powerpoint/2010/main" val="912537024"/>
+                <p14:modId xmlns:p14="http://schemas.microsoft.com/office/powerpoint/2010/main" val="3527199713"/>
               </p:ext>
             </p:extLst>
           </p:nvPr>
@@ -13234,7 +13294,7 @@
                     <a:bodyPr/>
                     <a:lstStyle/>
                     <a:p>
-                      <a:pPr algn="l"/>
+                      <a:pPr algn="ctr"/>
                       <a:r>
                         <a:rPr lang="ko-KR" altLang="en-US" sz="1100" b="1" dirty="0">
                           <a:solidFill>
@@ -13258,9 +13318,9 @@
                     <a:bodyPr/>
                     <a:lstStyle/>
                     <a:p>
-                      <a:pPr algn="l"/>
-                      <a:r>
-                        <a:rPr lang="ko-KR" altLang="en-US" sz="1100" b="1">
+                      <a:pPr algn="ctr"/>
+                      <a:r>
+                        <a:rPr lang="ko-KR" altLang="en-US" sz="1100" b="1" dirty="0">
                           <a:solidFill>
                             <a:srgbClr val="FFFFFF"/>
                           </a:solidFill>
@@ -14153,7 +14213,7 @@
           <p:nvPr>
             <p:extLst>
               <p:ext uri="{D42A27DB-BD31-4B8C-83A1-F6EECF244321}">
-                <p14:modId xmlns:p14="http://schemas.microsoft.com/office/powerpoint/2010/main" val="435940414"/>
+                <p14:modId xmlns:p14="http://schemas.microsoft.com/office/powerpoint/2010/main" val="1273095724"/>
               </p:ext>
             </p:extLst>
           </p:nvPr>
@@ -14211,7 +14271,7 @@
                     <a:bodyPr/>
                     <a:lstStyle/>
                     <a:p>
-                      <a:pPr algn="l">
+                      <a:pPr algn="ctr">
                         <a:lnSpc>
                           <a:spcPct val="114000"/>
                         </a:lnSpc>
@@ -14220,7 +14280,7 @@
                         </a:spcAft>
                       </a:pPr>
                       <a:r>
-                        <a:rPr sz="1150" b="1">
+                        <a:rPr sz="1120" b="1" dirty="0" err="1">
                           <a:solidFill>
                             <a:srgbClr val="FFFFFF"/>
                           </a:solidFill>
@@ -14229,6 +14289,13 @@
                         </a:rPr>
                         <a:t>경로</a:t>
                       </a:r>
+                      <a:endParaRPr sz="1120" b="1" dirty="0">
+                        <a:solidFill>
+                          <a:srgbClr val="FFFFFF"/>
+                        </a:solidFill>
+                        <a:latin typeface="맑은 고딕"/>
+                        <a:ea typeface="맑은 고딕"/>
+                      </a:endParaRPr>
                     </a:p>
                   </a:txBody>
                   <a:tcPr marL="82296" marR="82296" marT="36576" marB="36576" anchor="ctr">
@@ -14242,7 +14309,7 @@
                     <a:bodyPr/>
                     <a:lstStyle/>
                     <a:p>
-                      <a:pPr algn="l">
+                      <a:pPr algn="ctr">
                         <a:lnSpc>
                           <a:spcPct val="114000"/>
                         </a:lnSpc>
@@ -14251,7 +14318,7 @@
                         </a:spcAft>
                       </a:pPr>
                       <a:r>
-                        <a:rPr sz="1150" b="1">
+                        <a:rPr sz="1120" b="1" dirty="0">
                           <a:solidFill>
                             <a:srgbClr val="FFFFFF"/>
                           </a:solidFill>
@@ -14273,7 +14340,7 @@
                     <a:bodyPr/>
                     <a:lstStyle/>
                     <a:p>
-                      <a:pPr algn="l">
+                      <a:pPr algn="ctr">
                         <a:lnSpc>
                           <a:spcPct val="114000"/>
                         </a:lnSpc>
@@ -14282,7 +14349,7 @@
                         </a:spcAft>
                       </a:pPr>
                       <a:r>
-                        <a:rPr sz="1150" b="1">
+                        <a:rPr sz="1120" b="1" dirty="0">
                           <a:solidFill>
                             <a:srgbClr val="FFFFFF"/>
                           </a:solidFill>
@@ -14304,7 +14371,7 @@
                     <a:bodyPr/>
                     <a:lstStyle/>
                     <a:p>
-                      <a:pPr algn="l">
+                      <a:pPr algn="ctr">
                         <a:lnSpc>
                           <a:spcPct val="114000"/>
                         </a:lnSpc>
@@ -14313,7 +14380,7 @@
                         </a:spcAft>
                       </a:pPr>
                       <a:r>
-                        <a:rPr sz="1150" b="1">
+                        <a:rPr sz="1120" b="1" dirty="0">
                           <a:solidFill>
                             <a:srgbClr val="FFFFFF"/>
                           </a:solidFill>
@@ -14335,7 +14402,7 @@
                     <a:bodyPr/>
                     <a:lstStyle/>
                     <a:p>
-                      <a:pPr algn="l">
+                      <a:pPr algn="ctr">
                         <a:lnSpc>
                           <a:spcPct val="114000"/>
                         </a:lnSpc>
@@ -14344,7 +14411,7 @@
                         </a:spcAft>
                       </a:pPr>
                       <a:r>
-                        <a:rPr sz="1150" b="1">
+                        <a:rPr sz="1120" b="1" dirty="0" err="1">
                           <a:solidFill>
                             <a:srgbClr val="FFFFFF"/>
                           </a:solidFill>
@@ -14353,6 +14420,13 @@
                         </a:rPr>
                         <a:t>해석</a:t>
                       </a:r>
+                      <a:endParaRPr sz="1120" b="1" dirty="0">
+                        <a:solidFill>
+                          <a:srgbClr val="FFFFFF"/>
+                        </a:solidFill>
+                        <a:latin typeface="맑은 고딕"/>
+                        <a:ea typeface="맑은 고딕"/>
+                      </a:endParaRPr>
                     </a:p>
                   </a:txBody>
                   <a:tcPr marL="82296" marR="82296" marT="36576" marB="36576" anchor="ctr">
@@ -15162,7 +15236,7 @@
                         <a:t>지식·우연</a:t>
                       </a:r>
                       <a:r>
-                        <a:rPr lang="ko-KR" sz="1040" b="0" dirty="0">
+                        <a:rPr lang="ko-KR" sz="1120" b="0" dirty="0">
                           <a:solidFill>
                             <a:srgbClr val="6B7480"/>
                           </a:solidFill>
@@ -15273,11 +15347,17 @@
           <p:cNvGraphicFramePr>
             <a:graphicFrameLocks noGrp="1"/>
           </p:cNvGraphicFramePr>
-          <p:nvPr/>
+          <p:nvPr>
+            <p:extLst>
+              <p:ext uri="{D42A27DB-BD31-4B8C-83A1-F6EECF244321}">
+                <p14:modId xmlns:p14="http://schemas.microsoft.com/office/powerpoint/2010/main" val="2982391881"/>
+              </p:ext>
+            </p:extLst>
+          </p:nvPr>
         </p:nvGraphicFramePr>
         <p:xfrm>
           <a:off x="548640" y="4440936"/>
-          <a:ext cx="11087100" cy="1321181"/>
+          <a:ext cx="11087100" cy="1326706"/>
         </p:xfrm>
         <a:graphic>
           <a:graphicData uri="http://schemas.openxmlformats.org/drawingml/2006/table">
@@ -15316,7 +15396,7 @@
                     <a:p>
                       <a:pPr algn="ctr"/>
                       <a:r>
-                        <a:rPr lang="ko-KR" altLang="en-US" sz="1200" b="1">
+                        <a:rPr lang="ko-KR" altLang="en-US" sz="1120" b="1">
                           <a:solidFill>
                             <a:srgbClr val="FFFFFF"/>
                           </a:solidFill>
@@ -15342,7 +15422,7 @@
                     <a:p>
                       <a:pPr algn="ctr"/>
                       <a:r>
-                        <a:rPr lang="ko-KR" altLang="en-US" sz="1200" b="1">
+                        <a:rPr lang="ko-KR" altLang="en-US" sz="1120" b="1">
                           <a:solidFill>
                             <a:srgbClr val="FFFFFF"/>
                           </a:solidFill>
@@ -15368,7 +15448,7 @@
                     <a:p>
                       <a:pPr algn="ctr"/>
                       <a:r>
-                        <a:rPr lang="ko-KR" altLang="en-US" sz="1200" b="1">
+                        <a:rPr lang="ko-KR" altLang="en-US" sz="1120" b="1">
                           <a:solidFill>
                             <a:srgbClr val="FFFFFF"/>
                           </a:solidFill>
@@ -15401,7 +15481,7 @@
                     <a:p>
                       <a:pPr algn="l"/>
                       <a:r>
-                        <a:rPr lang="ko-KR" altLang="en-US" sz="1200" b="1" dirty="0">
+                        <a:rPr lang="ko-KR" altLang="en-US" sz="1120" b="1" dirty="0">
                           <a:solidFill>
                             <a:srgbClr val="1E2227"/>
                           </a:solidFill>
@@ -15427,7 +15507,7 @@
                     <a:p>
                       <a:pPr algn="l"/>
                       <a:r>
-                        <a:rPr lang="ko-KR" altLang="en-US" sz="1200" b="0">
+                        <a:rPr lang="ko-KR" altLang="en-US" sz="1120" b="0">
                           <a:solidFill>
                             <a:srgbClr val="1E2227"/>
                           </a:solidFill>
@@ -15453,7 +15533,7 @@
                     <a:p>
                       <a:pPr algn="l"/>
                       <a:r>
-                        <a:rPr lang="ko-KR" altLang="en-US" sz="1200" b="1" dirty="0">
+                        <a:rPr lang="ko-KR" altLang="en-US" sz="1120" b="1" dirty="0">
                           <a:solidFill>
                             <a:srgbClr val="273A52"/>
                           </a:solidFill>
@@ -15463,7 +15543,7 @@
                         <a:t>탐지</a:t>
                       </a:r>
                       <a:r>
-                        <a:rPr lang="ko-KR" altLang="en-US" sz="1200" b="0" dirty="0">
+                        <a:rPr lang="ko-KR" altLang="en-US" sz="1120" b="0" dirty="0">
                           <a:solidFill>
                             <a:srgbClr val="1E2227"/>
                           </a:solidFill>
@@ -15496,7 +15576,7 @@
                     <a:p>
                       <a:pPr algn="l"/>
                       <a:r>
-                        <a:rPr lang="ko-KR" altLang="en-US" sz="1200" b="1" dirty="0">
+                        <a:rPr lang="ko-KR" altLang="en-US" sz="1120" b="1" dirty="0">
                           <a:solidFill>
                             <a:srgbClr val="1E2227"/>
                           </a:solidFill>
@@ -15522,7 +15602,7 @@
                     <a:p>
                       <a:pPr algn="l"/>
                       <a:r>
-                        <a:rPr lang="ko-KR" altLang="en-US" sz="1200" b="0" dirty="0" err="1">
+                        <a:rPr lang="ko-KR" altLang="en-US" sz="1120" b="0" dirty="0" err="1">
                           <a:solidFill>
                             <a:srgbClr val="1E2227"/>
                           </a:solidFill>
@@ -15532,7 +15612,7 @@
                         <a:t>P</a:t>
                       </a:r>
                       <a:r>
-                        <a:rPr lang="ko-KR" altLang="en-US" sz="1200" b="0" dirty="0">
+                        <a:rPr lang="ko-KR" altLang="en-US" sz="1120" b="0" dirty="0">
                           <a:solidFill>
                             <a:srgbClr val="1E2227"/>
                           </a:solidFill>
@@ -15542,7 +15622,7 @@
                         <a:t>(L2 ≠ </a:t>
                       </a:r>
                       <a:r>
-                        <a:rPr lang="ko-KR" altLang="en-US" sz="1200" b="0" dirty="0" err="1">
+                        <a:rPr lang="ko-KR" altLang="en-US" sz="1120" b="0" dirty="0" err="1">
                           <a:solidFill>
                             <a:srgbClr val="1E2227"/>
                           </a:solidFill>
@@ -15552,7 +15632,7 @@
                         <a:t>correct</a:t>
                       </a:r>
                       <a:r>
-                        <a:rPr lang="ko-KR" altLang="en-US" sz="1200" b="0" dirty="0">
+                        <a:rPr lang="ko-KR" altLang="en-US" sz="1120" b="0" dirty="0">
                           <a:solidFill>
                             <a:srgbClr val="1E2227"/>
                           </a:solidFill>
@@ -15562,7 +15642,7 @@
                         <a:t> | L1 = </a:t>
                       </a:r>
                       <a:r>
-                        <a:rPr lang="ko-KR" altLang="en-US" sz="1200" b="0" dirty="0" err="1">
+                        <a:rPr lang="ko-KR" altLang="en-US" sz="1120" b="0" dirty="0" err="1">
                           <a:solidFill>
                             <a:srgbClr val="1E2227"/>
                           </a:solidFill>
@@ -15572,7 +15652,7 @@
                         <a:t>detected</a:t>
                       </a:r>
                       <a:r>
-                        <a:rPr lang="ko-KR" altLang="en-US" sz="1200" b="0" dirty="0">
+                        <a:rPr lang="ko-KR" altLang="en-US" sz="1120" b="0" dirty="0">
                           <a:solidFill>
                             <a:srgbClr val="1E2227"/>
                           </a:solidFill>
@@ -15598,7 +15678,7 @@
                     <a:p>
                       <a:pPr algn="l"/>
                       <a:r>
-                        <a:rPr lang="ko-KR" altLang="en-US" sz="1200" b="1" dirty="0">
+                        <a:rPr lang="ko-KR" altLang="en-US" sz="1120" b="1" dirty="0">
                           <a:solidFill>
                             <a:srgbClr val="273A52"/>
                           </a:solidFill>
@@ -15608,7 +15688,7 @@
                         <a:t>해소</a:t>
                       </a:r>
                       <a:r>
-                        <a:rPr lang="ko-KR" altLang="en-US" sz="1200" b="0" dirty="0">
+                        <a:rPr lang="ko-KR" altLang="en-US" sz="1120" b="0" dirty="0">
                           <a:solidFill>
                             <a:srgbClr val="1E2227"/>
                           </a:solidFill>
@@ -15641,7 +15721,7 @@
                     <a:p>
                       <a:pPr algn="l"/>
                       <a:r>
-                        <a:rPr lang="en-US" altLang="en-US" sz="1200" b="1" dirty="0">
+                        <a:rPr lang="en-US" altLang="en-US" sz="1120" b="1" dirty="0">
                           <a:solidFill>
                             <a:srgbClr val="1E2227"/>
                           </a:solidFill>
@@ -15661,7 +15741,7 @@
                         </a:spcBef>
                       </a:pPr>
                       <a:r>
-                        <a:rPr lang="ko-KR" altLang="en-US" sz="1000" b="0" dirty="0">
+                        <a:rPr lang="ko-KR" altLang="en-US" sz="1120" b="0" dirty="0">
                           <a:solidFill>
                             <a:srgbClr val="6B7480"/>
                           </a:solidFill>
@@ -15687,7 +15767,7 @@
                     <a:p>
                       <a:pPr algn="l"/>
                       <a:r>
-                        <a:rPr lang="ko-KR" altLang="en-US" sz="1200" b="0">
+                        <a:rPr lang="ko-KR" altLang="en-US" sz="1120" b="0">
                           <a:solidFill>
                             <a:srgbClr val="1E2227"/>
                           </a:solidFill>
@@ -15713,7 +15793,7 @@
                     <a:p>
                       <a:pPr algn="l"/>
                       <a:r>
-                        <a:rPr lang="ko-KR" altLang="en-US" sz="1200" b="1" dirty="0">
+                        <a:rPr lang="ko-KR" altLang="en-US" sz="1120" b="1" dirty="0">
                           <a:solidFill>
                             <a:srgbClr val="273A52"/>
                           </a:solidFill>
@@ -15723,7 +15803,7 @@
                         <a:t>표출</a:t>
                       </a:r>
                       <a:r>
-                        <a:rPr lang="ko-KR" altLang="en-US" sz="1200" b="0" dirty="0">
+                        <a:rPr lang="ko-KR" altLang="en-US" sz="1120" b="0" dirty="0">
                           <a:solidFill>
                             <a:srgbClr val="1E2227"/>
                           </a:solidFill>
@@ -16127,11 +16207,17 @@
           <p:cNvGraphicFramePr>
             <a:graphicFrameLocks noGrp="1"/>
           </p:cNvGraphicFramePr>
-          <p:nvPr/>
+          <p:nvPr>
+            <p:extLst>
+              <p:ext uri="{D42A27DB-BD31-4B8C-83A1-F6EECF244321}">
+                <p14:modId xmlns:p14="http://schemas.microsoft.com/office/powerpoint/2010/main" val="154420383"/>
+              </p:ext>
+            </p:extLst>
+          </p:nvPr>
         </p:nvGraphicFramePr>
         <p:xfrm>
-          <a:off x="546100" y="1752600"/>
-          <a:ext cx="11087100" cy="2743200"/>
+          <a:off x="546100" y="1752599"/>
+          <a:ext cx="11087100" cy="4282380"/>
         </p:xfrm>
         <a:graphic>
           <a:graphicData uri="http://schemas.openxmlformats.org/drawingml/2006/table">
@@ -16176,7 +16262,7 @@
                   </a:extLst>
                 </a:gridCol>
               </a:tblGrid>
-              <a:tr h="304800">
+              <a:tr h="430046">
                 <a:tc>
                   <a:txBody>
                     <a:bodyPr/>
@@ -16184,7 +16270,7 @@
                     <a:p>
                       <a:pPr algn="ctr"/>
                       <a:r>
-                        <a:rPr lang="ko-KR" altLang="en-US" sz="1050" b="1">
+                        <a:rPr lang="ko-KR" altLang="en-US" sz="1120" b="1">
                           <a:solidFill>
                             <a:srgbClr val="FFFFFF"/>
                           </a:solidFill>
@@ -16208,7 +16294,7 @@
                     <a:p>
                       <a:pPr algn="ctr"/>
                       <a:r>
-                        <a:rPr lang="ko-KR" altLang="en-US" sz="1050" b="1">
+                        <a:rPr lang="ko-KR" altLang="en-US" sz="1120" b="1">
                           <a:solidFill>
                             <a:srgbClr val="FFFFFF"/>
                           </a:solidFill>
@@ -16232,7 +16318,7 @@
                     <a:p>
                       <a:pPr algn="ctr"/>
                       <a:r>
-                        <a:rPr lang="ko-KR" altLang="en-US" sz="1050" b="1">
+                        <a:rPr lang="ko-KR" altLang="en-US" sz="1120" b="1">
                           <a:solidFill>
                             <a:srgbClr val="FFFFFF"/>
                           </a:solidFill>
@@ -16256,7 +16342,7 @@
                     <a:p>
                       <a:pPr algn="ctr"/>
                       <a:r>
-                        <a:rPr lang="ko-KR" altLang="en-US" sz="1050" b="1">
+                        <a:rPr lang="ko-KR" altLang="en-US" sz="1120" b="1">
                           <a:solidFill>
                             <a:srgbClr val="FFFFFF"/>
                           </a:solidFill>
@@ -16280,7 +16366,7 @@
                     <a:p>
                       <a:pPr algn="ctr"/>
                       <a:r>
-                        <a:rPr lang="ko-KR" altLang="en-US" sz="1050" b="1">
+                        <a:rPr lang="ko-KR" altLang="en-US" sz="1120" b="1">
                           <a:solidFill>
                             <a:srgbClr val="FFFFFF"/>
                           </a:solidFill>
@@ -16303,7 +16389,7 @@
                   </a:ext>
                 </a:extLst>
               </a:tr>
-              <a:tr h="609600">
+              <a:tr h="881950">
                 <a:tc rowSpan="2">
                   <a:txBody>
                     <a:bodyPr/>
@@ -16311,7 +16397,7 @@
                     <a:p>
                       <a:pPr algn="ctr"/>
                       <a:r>
-                        <a:rPr lang="ko-KR" altLang="en-US" sz="1050" b="1">
+                        <a:rPr lang="ko-KR" altLang="en-US" sz="1120" b="1">
                           <a:solidFill>
                             <a:srgbClr val="273A52"/>
                           </a:solidFill>
@@ -16335,7 +16421,7 @@
                     <a:p>
                       <a:pPr algn="ctr"/>
                       <a:r>
-                        <a:rPr lang="ko-KR" altLang="en-US" sz="1050" b="1">
+                        <a:rPr lang="ko-KR" altLang="en-US" sz="1120" b="1">
                           <a:solidFill>
                             <a:srgbClr val="273A52"/>
                           </a:solidFill>
@@ -16359,27 +16445,27 @@
                     <a:p>
                       <a:pPr algn="l"/>
                       <a:r>
-                        <a:rPr lang="ko-KR" sz="1050" b="0" dirty="0">
+                        <a:rPr lang="ko-KR" sz="1120" b="0" dirty="0">
                           <a:solidFill>
                             <a:srgbClr val="1E2227"/>
                           </a:solidFill>
                           <a:latin typeface="맑은 고딕"/>
                           <a:ea typeface="맑은 고딕"/>
                         </a:rPr>
-                        <a:t>추론 결론과 최종 답이 </a:t>
-                      </a:r>
-                      <a:r>
-                        <a:rPr lang="ko-KR" sz="1050" b="1" dirty="0">
+                        <a:t>추론 결론과 최종 답변이 </a:t>
+                      </a:r>
+                      <a:r>
+                        <a:rPr lang="ko-KR" sz="1120" b="1" dirty="0">
                           <a:solidFill>
                             <a:srgbClr val="1E2227"/>
                           </a:solidFill>
                           <a:latin typeface="맑은 고딕"/>
                           <a:ea typeface="맑은 고딕"/>
                         </a:rPr>
-                        <a:t>일치</a:t>
-                      </a:r>
-                      <a:r>
-                        <a:rPr lang="ko-KR" sz="1050" b="0" dirty="0">
+                        <a:t>일치(L-a)</a:t>
+                      </a:r>
+                      <a:r>
+                        <a:rPr lang="ko-KR" sz="1120" b="0" dirty="0">
                           <a:solidFill>
                             <a:srgbClr val="1E2227"/>
                           </a:solidFill>
@@ -16389,7 +16475,7 @@
                         <a:t>하는가? 불일치는 </a:t>
                       </a:r>
                       <a:r>
-                        <a:rPr lang="ko-KR" sz="1050" b="1" dirty="0">
+                        <a:rPr lang="ko-KR" sz="1120" b="1" dirty="0">
                           <a:solidFill>
                             <a:srgbClr val="1E2227"/>
                           </a:solidFill>
@@ -16399,7 +16485,7 @@
                         <a:t>어느 단계</a:t>
                       </a:r>
                       <a:r>
-                        <a:rPr lang="ko-KR" sz="1050" b="0" dirty="0">
+                        <a:rPr lang="ko-KR" sz="1120" b="0" dirty="0">
                           <a:solidFill>
                             <a:srgbClr val="1E2227"/>
                           </a:solidFill>
@@ -16432,14 +16518,14 @@
                         <a:buChar char="•"/>
                       </a:pPr>
                       <a:r>
-                        <a:rPr lang="ko-KR" sz="1050" b="0" dirty="0">
+                        <a:rPr lang="ko-KR" sz="1120" b="0" dirty="0">
                           <a:solidFill>
                             <a:srgbClr val="1E2227"/>
                           </a:solidFill>
                           <a:latin typeface="맑은 고딕"/>
                           <a:ea typeface="맑은 고딕"/>
                         </a:rPr>
-                        <a:t>결론·최종답 라벨을 문항마다 대조</a:t>
+                        <a:t>문항마다 추론 결론과 최종 답의 라벨을 맞대어 일치 여부 확인</a:t>
                       </a:r>
                     </a:p>
                     <a:p>
@@ -16454,14 +16540,14 @@
                         <a:buChar char="•"/>
                       </a:pPr>
                       <a:r>
-                        <a:rPr lang="ko-KR" sz="1050" b="0" dirty="0">
+                        <a:rPr lang="ko-KR" sz="1120" b="0" dirty="0">
                           <a:solidFill>
                             <a:srgbClr val="1E2227"/>
                           </a:solidFill>
                           <a:latin typeface="맑은 고딕"/>
                           <a:ea typeface="맑은 고딕"/>
                         </a:rPr>
-                        <a:t>탐지 단계의 충돌 원인 유형 적중 집계</a:t>
+                        <a:t>충돌 유형을 얼마나 맞게 알아차리는지 집계</a:t>
                       </a:r>
                     </a:p>
                   </a:txBody>
@@ -16478,7 +16564,7 @@
                     <a:p>
                       <a:pPr algn="l"/>
                       <a:r>
-                        <a:rPr lang="ko-KR" altLang="en-US" sz="1050" b="1">
+                        <a:rPr lang="ko-KR" altLang="en-US" sz="1120" b="1" dirty="0">
                           <a:solidFill>
                             <a:srgbClr val="273A52"/>
                           </a:solidFill>
@@ -16487,6 +16573,68 @@
                         </a:rPr>
                         <a:t>AIR · 유형 인지율</a:t>
                       </a:r>
+                      <a:endParaRPr lang="en-US" altLang="ko-KR" sz="1120" b="1" dirty="0">
+                        <a:solidFill>
+                          <a:srgbClr val="273A52"/>
+                        </a:solidFill>
+                        <a:latin typeface="맑은 고딕"/>
+                        <a:ea typeface="맑은 고딕"/>
+                      </a:endParaRPr>
+                    </a:p>
+                    <a:p>
+                      <a:pPr marL="171450" marR="0" lvl="0" indent="-171450" algn="l" defTabSz="914400" eaLnBrk="1" fontAlgn="auto" latinLnBrk="0" hangingPunct="1">
+                        <a:lnSpc>
+                          <a:spcPct val="100000"/>
+                        </a:lnSpc>
+                        <a:spcBef>
+                          <a:spcPts val="0"/>
+                        </a:spcBef>
+                        <a:spcAft>
+                          <a:spcPts val="0"/>
+                        </a:spcAft>
+                        <a:buClrTx/>
+                        <a:buSzTx/>
+                        <a:buFont typeface="Arial" panose="020B0604020202020204" pitchFamily="34" charset="0"/>
+                        <a:buChar char="•"/>
+                        <a:tabLst/>
+                        <a:defRPr/>
+                      </a:pPr>
+                      <a:r>
+                        <a:rPr lang="ko-KR" altLang="ko-KR" sz="1000" b="1" dirty="0">
+                          <a:solidFill>
+                            <a:schemeClr val="tx1">
+                              <a:lumMod val="50000"/>
+                              <a:lumOff val="50000"/>
+                            </a:schemeClr>
+                          </a:solidFill>
+                          <a:latin typeface="맑은 고딕"/>
+                          <a:ea typeface="맑은 고딕"/>
+                        </a:rPr>
+                        <a:t>유형 인지율</a:t>
+                      </a:r>
+                      <a:r>
+                        <a:rPr lang="ko-KR" altLang="ko-KR" sz="1000" b="0" dirty="0">
+                          <a:solidFill>
+                            <a:schemeClr val="tx1">
+                              <a:lumMod val="50000"/>
+                              <a:lumOff val="50000"/>
+                            </a:schemeClr>
+                          </a:solidFill>
+                          <a:latin typeface="맑은 고딕"/>
+                          <a:ea typeface="맑은 고딕"/>
+                        </a:rPr>
+                        <a:t> = 유형 적중 충돌문항 / 전체 충돌문항</a:t>
+                      </a:r>
+                    </a:p>
+                    <a:p>
+                      <a:pPr algn="l"/>
+                      <a:endParaRPr lang="ko-KR" altLang="en-US" sz="1120" b="1" dirty="0">
+                        <a:solidFill>
+                          <a:srgbClr val="273A52"/>
+                        </a:solidFill>
+                        <a:latin typeface="맑은 고딕"/>
+                        <a:ea typeface="맑은 고딕"/>
+                      </a:endParaRPr>
                     </a:p>
                   </a:txBody>
                   <a:tcPr anchor="ctr">
@@ -16501,7 +16649,7 @@
                   </a:ext>
                 </a:extLst>
               </a:tr>
-              <a:tr h="609600">
+              <a:tr h="860090">
                 <a:tc vMerge="1">
                   <a:txBody>
                     <a:bodyPr/>
@@ -16530,7 +16678,7 @@
                     <a:p>
                       <a:pPr algn="ctr"/>
                       <a:r>
-                        <a:rPr lang="ko-KR" altLang="en-US" sz="1050" b="1">
+                        <a:rPr lang="ko-KR" altLang="en-US" sz="1120" b="1">
                           <a:solidFill>
                             <a:srgbClr val="273A52"/>
                           </a:solidFill>
@@ -16554,54 +16702,54 @@
                     <a:p>
                       <a:pPr algn="l"/>
                       <a:r>
-                        <a:rPr lang="ko-KR" sz="1050" b="0" dirty="0">
+                        <a:rPr lang="ko-KR" sz="1120" b="0" dirty="0">
                           <a:solidFill>
                             <a:srgbClr val="1E2227"/>
                           </a:solidFill>
                           <a:latin typeface="맑은 고딕"/>
                           <a:ea typeface="맑은 고딕"/>
                         </a:rPr>
-                        <a:t>완화 기법의 EM 상승분이 </a:t>
-                      </a:r>
-                      <a:r>
-                        <a:rPr lang="ko-KR" sz="1050" b="1" dirty="0">
+                        <a:t>완화로 늘어난 정답, </a:t>
+                      </a:r>
+                      <a:r>
+                        <a:rPr lang="ko-KR" sz="1120" b="1" dirty="0">
                           <a:solidFill>
                             <a:srgbClr val="1E2227"/>
                           </a:solidFill>
                           <a:latin typeface="맑은 고딕"/>
                           <a:ea typeface="맑은 고딕"/>
                         </a:rPr>
-                        <a:t>진짜 논리</a:t>
-                      </a:r>
-                      <a:r>
-                        <a:rPr lang="ko-KR" sz="1050" b="0" dirty="0">
+                        <a:t>진짜 추론</a:t>
+                      </a:r>
+                      <a:r>
+                        <a:rPr lang="ko-KR" sz="1120" b="0" dirty="0">
                           <a:solidFill>
                             <a:srgbClr val="1E2227"/>
                           </a:solidFill>
                           <a:latin typeface="맑은 고딕"/>
                           <a:ea typeface="맑은 고딕"/>
                         </a:rPr>
-                        <a:t>인가, </a:t>
-                      </a:r>
-                      <a:r>
-                        <a:rPr lang="ko-KR" sz="1050" b="1" dirty="0">
+                        <a:t>으로 맞혔나 · </a:t>
+                      </a:r>
+                      <a:r>
+                        <a:rPr lang="ko-KR" sz="1120" b="1" dirty="0">
                           <a:solidFill>
                             <a:srgbClr val="1E2227"/>
                           </a:solidFill>
                           <a:latin typeface="맑은 고딕"/>
                           <a:ea typeface="맑은 고딕"/>
                         </a:rPr>
-                        <a:t>우회 경로</a:t>
-                      </a:r>
-                      <a:r>
-                        <a:rPr lang="ko-KR" sz="1050" b="0" dirty="0">
+                        <a:t>우연</a:t>
+                      </a:r>
+                      <a:r>
+                        <a:rPr lang="ko-KR" sz="1120" b="0" dirty="0">
                           <a:solidFill>
                             <a:srgbClr val="1E2227"/>
                           </a:solidFill>
                           <a:latin typeface="맑은 고딕"/>
                           <a:ea typeface="맑은 고딕"/>
                         </a:rPr>
-                        <a:t>인가?</a:t>
+                        <a:t>(우회 경로)인가?</a:t>
                       </a:r>
                     </a:p>
                   </a:txBody>
@@ -16627,14 +16775,14 @@
                         <a:buChar char="•"/>
                       </a:pPr>
                       <a:r>
-                        <a:rPr lang="ko-KR" sz="1050" b="0" dirty="0">
+                        <a:rPr lang="ko-KR" sz="1120" b="0" dirty="0">
                           <a:solidFill>
                             <a:srgbClr val="1E2227"/>
                           </a:solidFill>
                           <a:latin typeface="맑은 고딕"/>
                           <a:ea typeface="맑은 고딕"/>
                         </a:rPr>
-                        <a:t>완화 전·후 같은 문항의 정답 경로 이동을 분해</a:t>
+                        <a:t>완화 전·후 같은 문항에서 새로 맞은 정답이 어느 경로로 왔는지 분해</a:t>
                       </a:r>
                     </a:p>
                   </a:txBody>
@@ -16651,15 +16799,32 @@
                     <a:p>
                       <a:pPr algn="l"/>
                       <a:r>
-                        <a:rPr lang="ko-KR" altLang="en-US" sz="1050" b="1">
+                        <a:rPr lang="ko-KR" altLang="en-US" sz="1120" b="1" dirty="0">
                           <a:solidFill>
                             <a:srgbClr val="273A52"/>
                           </a:solidFill>
                           <a:latin typeface="맑은 고딕"/>
                           <a:ea typeface="맑은 고딕"/>
                         </a:rPr>
-                        <a:t>LGR · HR · Flip</a:t>
-                      </a:r>
+                        <a:t>LGR · HR · </a:t>
+                      </a:r>
+                      <a:r>
+                        <a:rPr lang="ko-KR" altLang="en-US" sz="1120" b="1" dirty="0" err="1">
+                          <a:solidFill>
+                            <a:srgbClr val="273A52"/>
+                          </a:solidFill>
+                          <a:latin typeface="맑은 고딕"/>
+                          <a:ea typeface="맑은 고딕"/>
+                        </a:rPr>
+                        <a:t>Flip</a:t>
+                      </a:r>
+                      <a:endParaRPr lang="ko-KR" altLang="en-US" sz="1120" b="1" dirty="0">
+                        <a:solidFill>
+                          <a:srgbClr val="273A52"/>
+                        </a:solidFill>
+                        <a:latin typeface="맑은 고딕"/>
+                        <a:ea typeface="맑은 고딕"/>
+                      </a:endParaRPr>
                     </a:p>
                   </a:txBody>
                   <a:tcPr anchor="ctr">
@@ -16674,7 +16839,7 @@
                   </a:ext>
                 </a:extLst>
               </a:tr>
-              <a:tr h="609600">
+              <a:tr h="881950">
                 <a:tc>
                   <a:txBody>
                     <a:bodyPr/>
@@ -16682,7 +16847,7 @@
                     <a:p>
                       <a:pPr algn="ctr"/>
                       <a:r>
-                        <a:rPr lang="ko-KR" altLang="en-US" sz="1050" b="1">
+                        <a:rPr lang="ko-KR" altLang="en-US" sz="1120" b="1">
                           <a:solidFill>
                             <a:srgbClr val="273A52"/>
                           </a:solidFill>
@@ -16706,7 +16871,7 @@
                     <a:p>
                       <a:pPr algn="ctr"/>
                       <a:r>
-                        <a:rPr lang="ko-KR" altLang="en-US" sz="1050" b="1">
+                        <a:rPr lang="ko-KR" altLang="en-US" sz="1120" b="1">
                           <a:solidFill>
                             <a:srgbClr val="273A52"/>
                           </a:solidFill>
@@ -16730,37 +16895,37 @@
                     <a:p>
                       <a:pPr algn="l"/>
                       <a:r>
-                        <a:rPr lang="ko-KR" sz="1050" b="0" dirty="0">
+                        <a:rPr lang="ko-KR" sz="1120" b="0" dirty="0">
                           <a:solidFill>
                             <a:srgbClr val="1E2227"/>
                           </a:solidFill>
                           <a:latin typeface="맑은 고딕"/>
                           <a:ea typeface="맑은 고딕"/>
                         </a:rPr>
-                        <a:t>불일치가 </a:t>
-                      </a:r>
-                      <a:r>
-                        <a:rPr lang="ko-KR" sz="1050" b="1" dirty="0">
+                        <a:t>관측된 불일치는 </a:t>
+                      </a:r>
+                      <a:r>
+                        <a:rPr lang="ko-KR" sz="1120" b="1" dirty="0">
                           <a:solidFill>
                             <a:srgbClr val="1E2227"/>
                           </a:solidFill>
                           <a:latin typeface="맑은 고딕"/>
                           <a:ea typeface="맑은 고딕"/>
                         </a:rPr>
-                        <a:t>충돌 고유 실패</a:t>
-                      </a:r>
-                      <a:r>
-                        <a:rPr lang="ko-KR" sz="1050" b="0" dirty="0">
+                        <a:t>충돌 고유의 실패</a:t>
+                      </a:r>
+                      <a:r>
+                        <a:rPr lang="ko-KR" sz="1120" b="0" dirty="0">
                           <a:solidFill>
                             <a:srgbClr val="1E2227"/>
                           </a:solidFill>
                           <a:latin typeface="맑은 고딕"/>
                           <a:ea typeface="맑은 고딕"/>
                         </a:rPr>
-                        <a:t>인가, 난이도·문서 수의 </a:t>
-                      </a:r>
-                      <a:r>
-                        <a:rPr lang="ko-KR" sz="1050" b="1" dirty="0">
+                        <a:t>인가, 난이도·문서 수 증가의 </a:t>
+                      </a:r>
+                      <a:r>
+                        <a:rPr lang="ko-KR" sz="1120" b="1" dirty="0">
                           <a:solidFill>
                             <a:srgbClr val="1E2227"/>
                           </a:solidFill>
@@ -16770,7 +16935,7 @@
                         <a:t>부수 효과</a:t>
                       </a:r>
                       <a:r>
-                        <a:rPr lang="ko-KR" sz="1050" b="0" dirty="0">
+                        <a:rPr lang="ko-KR" sz="1120" b="0" dirty="0">
                           <a:solidFill>
                             <a:srgbClr val="1E2227"/>
                           </a:solidFill>
@@ -16803,14 +16968,14 @@
                         <a:buChar char="•"/>
                       </a:pPr>
                       <a:r>
-                        <a:rPr lang="ko-KR" sz="1050" b="0" dirty="0">
+                        <a:rPr lang="ko-KR" sz="1120" b="0" dirty="0">
                           <a:solidFill>
                             <a:srgbClr val="1E2227"/>
                           </a:solidFill>
                           <a:latin typeface="맑은 고딕"/>
                           <a:ea typeface="맑은 고딕"/>
                         </a:rPr>
-                        <a:t>난이도·문서 수 보정 혼합효과 회귀로 충돌 계수 추정</a:t>
+                        <a:t>난이도·문서 수를 걷어낸 회귀로 ‘충돌 자체’의 효과만 추정</a:t>
                       </a:r>
                     </a:p>
                     <a:p>
@@ -16825,14 +16990,14 @@
                         <a:buChar char="•"/>
                       </a:pPr>
                       <a:r>
-                        <a:rPr lang="ko-KR" sz="1050" b="0" dirty="0">
+                        <a:rPr lang="ko-KR" sz="1120" b="0" dirty="0">
                           <a:solidFill>
                             <a:srgbClr val="1E2227"/>
                           </a:solidFill>
                           <a:latin typeface="맑은 고딕"/>
                           <a:ea typeface="맑은 고딕"/>
                         </a:rPr>
-                        <a:t>on/off로 추론 채널 기여 분리</a:t>
+                        <a:t>추론 과정을 켜고/꺼서 그 기여분만 분리</a:t>
                       </a:r>
                     </a:p>
                   </a:txBody>
@@ -16849,15 +17014,159 @@
                     <a:p>
                       <a:pPr algn="l"/>
                       <a:r>
-                        <a:rPr lang="ko-KR" altLang="en-US" sz="1050" b="1">
+                        <a:rPr lang="ko-KR" altLang="en-US" sz="1120" b="1" dirty="0">
                           <a:solidFill>
                             <a:srgbClr val="273A52"/>
                           </a:solidFill>
                           <a:latin typeface="맑은 고딕"/>
                           <a:ea typeface="맑은 고딕"/>
                         </a:rPr>
-                        <a:t>충돌 순효과 · AIR · Shortcut</a:t>
-                      </a:r>
+                        <a:t>충돌 </a:t>
+                      </a:r>
+                      <a:r>
+                        <a:rPr lang="ko-KR" altLang="en-US" sz="1120" b="1" dirty="0" err="1">
+                          <a:solidFill>
+                            <a:srgbClr val="273A52"/>
+                          </a:solidFill>
+                          <a:latin typeface="맑은 고딕"/>
+                          <a:ea typeface="맑은 고딕"/>
+                        </a:rPr>
+                        <a:t>순효과</a:t>
+                      </a:r>
+                      <a:r>
+                        <a:rPr lang="ko-KR" altLang="en-US" sz="1120" b="1" dirty="0">
+                          <a:solidFill>
+                            <a:srgbClr val="273A52"/>
+                          </a:solidFill>
+                          <a:latin typeface="맑은 고딕"/>
+                          <a:ea typeface="맑은 고딕"/>
+                        </a:rPr>
+                        <a:t> · AIR · </a:t>
+                      </a:r>
+                      <a:r>
+                        <a:rPr lang="ko-KR" altLang="en-US" sz="1120" b="1" dirty="0" err="1">
+                          <a:solidFill>
+                            <a:srgbClr val="273A52"/>
+                          </a:solidFill>
+                          <a:latin typeface="맑은 고딕"/>
+                          <a:ea typeface="맑은 고딕"/>
+                        </a:rPr>
+                        <a:t>Shortcut</a:t>
+                      </a:r>
+                      <a:endParaRPr lang="en-US" altLang="ko-KR" sz="1120" b="1" dirty="0">
+                        <a:solidFill>
+                          <a:srgbClr val="273A52"/>
+                        </a:solidFill>
+                        <a:latin typeface="맑은 고딕"/>
+                        <a:ea typeface="맑은 고딕"/>
+                      </a:endParaRPr>
+                    </a:p>
+                    <a:p>
+                      <a:pPr marL="171450" marR="0" lvl="0" indent="-171450" algn="l" defTabSz="914400" eaLnBrk="1" fontAlgn="auto" latinLnBrk="0" hangingPunct="1">
+                        <a:lnSpc>
+                          <a:spcPct val="100000"/>
+                        </a:lnSpc>
+                        <a:spcBef>
+                          <a:spcPts val="0"/>
+                        </a:spcBef>
+                        <a:spcAft>
+                          <a:spcPts val="0"/>
+                        </a:spcAft>
+                        <a:buClrTx/>
+                        <a:buSzTx/>
+                        <a:buFont typeface="Arial" panose="020B0604020202020204" pitchFamily="34" charset="0"/>
+                        <a:buChar char="•"/>
+                        <a:tabLst/>
+                        <a:defRPr/>
+                      </a:pPr>
+                      <a:r>
+                        <a:rPr lang="ko-KR" altLang="ko-KR" sz="1000" b="1" dirty="0">
+                          <a:solidFill>
+                            <a:schemeClr val="tx1">
+                              <a:lumMod val="50000"/>
+                              <a:lumOff val="50000"/>
+                            </a:schemeClr>
+                          </a:solidFill>
+                          <a:latin typeface="맑은 고딕"/>
+                          <a:ea typeface="맑은 고딕"/>
+                        </a:rPr>
+                        <a:t>충돌 </a:t>
+                      </a:r>
+                      <a:r>
+                        <a:rPr lang="ko-KR" altLang="ko-KR" sz="1000" b="1" dirty="0" err="1">
+                          <a:solidFill>
+                            <a:schemeClr val="tx1">
+                              <a:lumMod val="50000"/>
+                              <a:lumOff val="50000"/>
+                            </a:schemeClr>
+                          </a:solidFill>
+                          <a:latin typeface="맑은 고딕"/>
+                          <a:ea typeface="맑은 고딕"/>
+                        </a:rPr>
+                        <a:t>순효과</a:t>
+                      </a:r>
+                      <a:r>
+                        <a:rPr lang="ko-KR" altLang="ko-KR" sz="1000" b="0" dirty="0">
+                          <a:solidFill>
+                            <a:schemeClr val="tx1">
+                              <a:lumMod val="50000"/>
+                              <a:lumOff val="50000"/>
+                            </a:schemeClr>
+                          </a:solidFill>
+                          <a:latin typeface="맑은 고딕"/>
+                          <a:ea typeface="맑은 고딕"/>
+                        </a:rPr>
+                        <a:t> = </a:t>
+                      </a:r>
+                      <a:r>
+                        <a:rPr lang="ko-KR" altLang="ko-KR" sz="1000" b="0" dirty="0" err="1">
+                          <a:solidFill>
+                            <a:schemeClr val="tx1">
+                              <a:lumMod val="50000"/>
+                              <a:lumOff val="50000"/>
+                            </a:schemeClr>
+                          </a:solidFill>
+                          <a:latin typeface="맑은 고딕"/>
+                          <a:ea typeface="맑은 고딕"/>
+                        </a:rPr>
+                        <a:t>공변량</a:t>
+                      </a:r>
+                      <a:r>
+                        <a:rPr lang="ko-KR" altLang="ko-KR" sz="1000" b="0" dirty="0">
+                          <a:solidFill>
+                            <a:schemeClr val="tx1">
+                              <a:lumMod val="50000"/>
+                              <a:lumOff val="50000"/>
+                            </a:schemeClr>
+                          </a:solidFill>
+                          <a:latin typeface="맑은 고딕"/>
+                          <a:ea typeface="맑은 고딕"/>
+                        </a:rPr>
+                        <a:t> 보정 회귀의 충돌 계수 </a:t>
+                      </a:r>
+                      <a:r>
+                        <a:rPr lang="en-US" altLang="ko-KR" sz="1000" i="1" dirty="0">
+                          <a:solidFill>
+                            <a:schemeClr val="tx1">
+                              <a:lumMod val="50000"/>
+                              <a:lumOff val="50000"/>
+                            </a:schemeClr>
+                          </a:solidFill>
+                          <a:latin typeface="Cambria Math"/>
+                          <a:cs typeface="Cambria Math"/>
+                        </a:rPr>
+                        <a:t>β</a:t>
+                      </a:r>
+                    </a:p>
+                    <a:p>
+                      <a:pPr algn="l"/>
+                      <a:endParaRPr lang="ko-KR" altLang="en-US" sz="1120" b="1" dirty="0">
+                        <a:solidFill>
+                          <a:srgbClr val="273A52"/>
+                        </a:solidFill>
+                        <a:latin typeface="맑은 고딕"/>
+                        <a:ea typeface="맑은 고딕"/>
+                      </a:endParaRPr>
                     </a:p>
                   </a:txBody>
                   <a:tcPr anchor="ctr">
@@ -16872,7 +17181,7 @@
                   </a:ext>
                 </a:extLst>
               </a:tr>
-              <a:tr h="609600">
+              <a:tr h="881950">
                 <a:tc>
                   <a:txBody>
                     <a:bodyPr/>
@@ -16880,7 +17189,7 @@
                     <a:p>
                       <a:pPr algn="ctr"/>
                       <a:r>
-                        <a:rPr lang="ko-KR" altLang="en-US" sz="1050" b="1">
+                        <a:rPr lang="ko-KR" altLang="en-US" sz="1120" b="1">
                           <a:solidFill>
                             <a:srgbClr val="273A52"/>
                           </a:solidFill>
@@ -16904,7 +17213,7 @@
                     <a:p>
                       <a:pPr algn="ctr"/>
                       <a:r>
-                        <a:rPr lang="ko-KR" altLang="en-US" sz="1050" b="1">
+                        <a:rPr lang="ko-KR" altLang="en-US" sz="1120" b="1">
                           <a:solidFill>
                             <a:srgbClr val="273A52"/>
                           </a:solidFill>
@@ -16928,34 +17237,34 @@
                     <a:p>
                       <a:pPr algn="l"/>
                       <a:r>
-                        <a:rPr lang="ko-KR" sz="1050" b="0" dirty="0">
+                        <a:rPr lang="ko-KR" sz="1120" b="0" dirty="0">
                           <a:solidFill>
                             <a:srgbClr val="1E2227"/>
                           </a:solidFill>
                           <a:latin typeface="맑은 고딕"/>
                           <a:ea typeface="맑은 고딕"/>
                         </a:rPr>
-                        <a:t>추론 결론이 최종 답을 </a:t>
-                      </a:r>
-                      <a:r>
-                        <a:rPr lang="ko-KR" sz="1050" b="1" dirty="0">
+                        <a:t>추론 결론이 최종 답변에 </a:t>
+                      </a:r>
+                      <a:r>
+                        <a:rPr lang="ko-KR" sz="1120" b="1" dirty="0">
                           <a:solidFill>
                             <a:srgbClr val="1E2227"/>
                           </a:solidFill>
                           <a:latin typeface="맑은 고딕"/>
                           <a:ea typeface="맑은 고딕"/>
                         </a:rPr>
-                        <a:t>인과적으로 구동</a:t>
-                      </a:r>
-                      <a:r>
-                        <a:rPr lang="ko-KR" sz="1050" b="0" dirty="0">
+                        <a:t>인과적으로 영향을 주는가(L-b)</a:t>
+                      </a:r>
+                      <a:r>
+                        <a:rPr lang="ko-KR" sz="1120" b="0" dirty="0">
                           <a:solidFill>
                             <a:srgbClr val="1E2227"/>
                           </a:solidFill>
                           <a:latin typeface="맑은 고딕"/>
                           <a:ea typeface="맑은 고딕"/>
                         </a:rPr>
-                        <a:t>하는가?</a:t>
+                        <a:t>?</a:t>
                       </a:r>
                     </a:p>
                   </a:txBody>
@@ -16981,14 +17290,14 @@
                         <a:buChar char="•"/>
                       </a:pPr>
                       <a:r>
-                        <a:rPr lang="ko-KR" sz="1050" b="0" dirty="0">
+                        <a:rPr lang="ko-KR" sz="1120" b="0" dirty="0">
                           <a:solidFill>
                             <a:srgbClr val="1E2227"/>
                           </a:solidFill>
                           <a:latin typeface="맑은 고딕"/>
                           <a:ea typeface="맑은 고딕"/>
                         </a:rPr>
-                        <a:t>정답 문항의 추론을 절단·재생성해 답 변화 측정</a:t>
+                        <a:t>맞힌 문항의 추론에 개입(절단·재생성)해 답이 바뀌는지 측정</a:t>
                       </a:r>
                     </a:p>
                     <a:p>
@@ -17003,14 +17312,14 @@
                         <a:buChar char="•"/>
                       </a:pPr>
                       <a:r>
-                        <a:rPr lang="ko-KR" sz="1050" b="0" dirty="0">
+                        <a:rPr lang="ko-KR" sz="1120" b="0" dirty="0">
                           <a:solidFill>
                             <a:srgbClr val="1E2227"/>
                           </a:solidFill>
                           <a:latin typeface="맑은 고딕"/>
                           <a:ea typeface="맑은 고딕"/>
                         </a:rPr>
-                        <a:t>경로별 뒤집힘 비율 비교</a:t>
+                        <a:t>경로별로 답이 뒤집히는 비율 비교</a:t>
                       </a:r>
                     </a:p>
                   </a:txBody>
@@ -17027,7 +17336,7 @@
                     <a:p>
                       <a:pPr algn="l"/>
                       <a:r>
-                        <a:rPr lang="ko-KR" altLang="en-US" sz="1050" b="1" dirty="0">
+                        <a:rPr lang="ko-KR" altLang="en-US" sz="1120" b="1" dirty="0">
                           <a:solidFill>
                             <a:srgbClr val="273A52"/>
                           </a:solidFill>
@@ -17035,6 +17344,167 @@
                           <a:ea typeface="맑은 고딕"/>
                         </a:rPr>
                         <a:t>정답 한정 답 변화율 · 경로별 취약성</a:t>
+                      </a:r>
+                      <a:endParaRPr lang="en-US" altLang="ko-KR" sz="1120" b="1" dirty="0">
+                        <a:solidFill>
+                          <a:srgbClr val="273A52"/>
+                        </a:solidFill>
+                        <a:latin typeface="맑은 고딕"/>
+                        <a:ea typeface="맑은 고딕"/>
+                      </a:endParaRPr>
+                    </a:p>
+                    <a:p>
+                      <a:pPr marL="171450" indent="-171450" algn="l">
+                        <a:lnSpc>
+                          <a:spcPct val="118000"/>
+                        </a:lnSpc>
+                        <a:spcAft>
+                          <a:spcPts val="260"/>
+                        </a:spcAft>
+                        <a:buFont typeface="Arial"/>
+                        <a:buChar char="•"/>
+                      </a:pPr>
+                      <a:r>
+                        <a:rPr lang="ko-KR" altLang="ko-KR" sz="1000" b="1" dirty="0">
+                          <a:solidFill>
+                            <a:schemeClr val="tx1">
+                              <a:lumMod val="50000"/>
+                              <a:lumOff val="50000"/>
+                            </a:schemeClr>
+                          </a:solidFill>
+                          <a:latin typeface="맑은 고딕"/>
+                          <a:ea typeface="맑은 고딕"/>
+                        </a:rPr>
+                        <a:t>정답 한정 답 변화율</a:t>
+                      </a:r>
+                      <a:r>
+                        <a:rPr lang="ko-KR" altLang="ko-KR" sz="1000" b="0" dirty="0">
+                          <a:solidFill>
+                            <a:schemeClr val="tx1">
+                              <a:lumMod val="50000"/>
+                              <a:lumOff val="50000"/>
+                            </a:schemeClr>
+                          </a:solidFill>
+                          <a:latin typeface="맑은 고딕"/>
+                          <a:ea typeface="맑은 고딕"/>
+                        </a:rPr>
+                        <a:t> = 개입 후 바뀐 정답 / 정답 문항</a:t>
+                      </a:r>
+                    </a:p>
+                    <a:p>
+                      <a:pPr marL="171450" indent="-171450" algn="l">
+                        <a:lnSpc>
+                          <a:spcPct val="118000"/>
+                        </a:lnSpc>
+                        <a:spcAft>
+                          <a:spcPts val="260"/>
+                        </a:spcAft>
+                        <a:buFont typeface="Arial"/>
+                        <a:buChar char="•"/>
+                      </a:pPr>
+                      <a:r>
+                        <a:rPr lang="ko-KR" altLang="ko-KR" sz="1000" b="1" dirty="0">
+                          <a:solidFill>
+                            <a:schemeClr val="tx1">
+                              <a:lumMod val="50000"/>
+                              <a:lumOff val="50000"/>
+                            </a:schemeClr>
+                          </a:solidFill>
+                          <a:latin typeface="맑은 고딕"/>
+                          <a:ea typeface="맑은 고딕"/>
+                        </a:rPr>
+                        <a:t>경로별 취약성(</a:t>
+                      </a:r>
+                      <a:r>
+                        <a:rPr lang="ko-KR" altLang="ko-KR" sz="1000" b="1" dirty="0" err="1">
+                          <a:solidFill>
+                            <a:schemeClr val="tx1">
+                              <a:lumMod val="50000"/>
+                              <a:lumOff val="50000"/>
+                            </a:schemeClr>
+                          </a:solidFill>
+                          <a:latin typeface="맑은 고딕"/>
+                          <a:ea typeface="맑은 고딕"/>
+                        </a:rPr>
+                        <a:t>p</a:t>
+                      </a:r>
+                      <a:r>
+                        <a:rPr lang="ko-KR" altLang="ko-KR" sz="1000" b="1" dirty="0">
+                          <a:solidFill>
+                            <a:schemeClr val="tx1">
+                              <a:lumMod val="50000"/>
+                              <a:lumOff val="50000"/>
+                            </a:schemeClr>
+                          </a:solidFill>
+                          <a:latin typeface="맑은 고딕"/>
+                          <a:ea typeface="맑은 고딕"/>
+                        </a:rPr>
+                        <a:t>)</a:t>
+                      </a:r>
+                      <a:r>
+                        <a:rPr lang="ko-KR" altLang="ko-KR" sz="1000" b="0" dirty="0">
+                          <a:solidFill>
+                            <a:schemeClr val="tx1">
+                              <a:lumMod val="50000"/>
+                              <a:lumOff val="50000"/>
+                            </a:schemeClr>
+                          </a:solidFill>
+                          <a:latin typeface="맑은 고딕"/>
+                          <a:ea typeface="맑은 고딕"/>
+                        </a:rPr>
+                        <a:t> = 경로 </a:t>
+                      </a:r>
+                      <a:r>
+                        <a:rPr lang="ko-KR" altLang="ko-KR" sz="1000" b="0" dirty="0" err="1">
+                          <a:solidFill>
+                            <a:schemeClr val="tx1">
+                              <a:lumMod val="50000"/>
+                              <a:lumOff val="50000"/>
+                            </a:schemeClr>
+                          </a:solidFill>
+                          <a:latin typeface="맑은 고딕"/>
+                          <a:ea typeface="맑은 고딕"/>
+                        </a:rPr>
+                        <a:t>p</a:t>
+                      </a:r>
+                      <a:r>
+                        <a:rPr lang="ko-KR" altLang="ko-KR" sz="1000" b="0" dirty="0">
+                          <a:solidFill>
+                            <a:schemeClr val="tx1">
+                              <a:lumMod val="50000"/>
+                              <a:lumOff val="50000"/>
+                            </a:schemeClr>
+                          </a:solidFill>
+                          <a:latin typeface="맑은 고딕"/>
+                          <a:ea typeface="맑은 고딕"/>
+                        </a:rPr>
+                        <a:t> 뒤집힘 / 경로 </a:t>
+                      </a:r>
+                      <a:r>
+                        <a:rPr lang="ko-KR" altLang="ko-KR" sz="1000" b="0" dirty="0" err="1">
+                          <a:solidFill>
+                            <a:schemeClr val="tx1">
+                              <a:lumMod val="50000"/>
+                              <a:lumOff val="50000"/>
+                            </a:schemeClr>
+                          </a:solidFill>
+                          <a:latin typeface="맑은 고딕"/>
+                          <a:ea typeface="맑은 고딕"/>
+                        </a:rPr>
+                        <a:t>p</a:t>
+                      </a:r>
+                      <a:r>
+                        <a:rPr lang="ko-KR" altLang="ko-KR" sz="1000" b="0" dirty="0">
+                          <a:solidFill>
+                            <a:schemeClr val="tx1">
+                              <a:lumMod val="50000"/>
+                              <a:lumOff val="50000"/>
+                            </a:schemeClr>
+                          </a:solidFill>
+                          <a:latin typeface="맑은 고딕"/>
+                          <a:ea typeface="맑은 고딕"/>
+                        </a:rPr>
+                        <a:t> 정답</a:t>
                       </a:r>
                     </a:p>
                   </a:txBody>
@@ -17054,365 +17524,10 @@
           </a:graphicData>
         </a:graphic>
       </p:graphicFrame>
-      <p:sp>
-        <p:nvSpPr>
-          <p:cNvPr id="61" name="MetricHead"/>
-          <p:cNvSpPr txBox="1"/>
-          <p:nvPr/>
-        </p:nvSpPr>
-        <p:spPr>
-          <a:xfrm>
-            <a:off x="546100" y="4807319"/>
-            <a:ext cx="5080000" cy="285750"/>
-          </a:xfrm>
-          <a:prstGeom prst="rect">
-            <a:avLst/>
-          </a:prstGeom>
-          <a:noFill/>
-        </p:spPr>
-        <p:txBody>
-          <a:bodyPr wrap="square" lIns="0" tIns="0" rIns="0" bIns="0">
-            <a:spAutoFit/>
-          </a:bodyPr>
-          <a:lstStyle/>
-          <a:p>
-            <a:pPr algn="l"/>
-            <a:r>
-              <a:rPr lang="ko-KR" sz="1300" b="1" dirty="0">
-                <a:solidFill>
-                  <a:srgbClr val="273A52"/>
-                </a:solidFill>
-                <a:latin typeface="맑은 고딕"/>
-                <a:ea typeface="맑은 고딕"/>
-              </a:rPr>
-              <a:t>측정 지표 산식</a:t>
-            </a:r>
-          </a:p>
-        </p:txBody>
-      </p:sp>
-      <p:sp>
-        <p:nvSpPr>
-          <p:cNvPr id="62" name="MetricBullets"/>
-          <p:cNvSpPr txBox="1"/>
-          <p:nvPr/>
-        </p:nvSpPr>
-        <p:spPr>
-          <a:xfrm>
-            <a:off x="546100" y="5137519"/>
-            <a:ext cx="11087100" cy="1240000"/>
-          </a:xfrm>
-          <a:prstGeom prst="rect">
-            <a:avLst/>
-          </a:prstGeom>
-          <a:noFill/>
-        </p:spPr>
-        <p:txBody>
-          <a:bodyPr wrap="square" lIns="0" tIns="0" rIns="0" bIns="0" numCol="2" spcCol="228600" anchor="t"/>
-          <a:lstStyle/>
-          <a:p>
-            <a:pPr marL="171450" indent="-171450" algn="l">
-              <a:lnSpc>
-                <a:spcPct val="118000"/>
-              </a:lnSpc>
-              <a:spcAft>
-                <a:spcPts val="260"/>
-              </a:spcAft>
-              <a:buFont typeface="Arial"/>
-              <a:buChar char="•"/>
-            </a:pPr>
-            <a:r>
-              <a:rPr lang="ko-KR" sz="1100" b="1" dirty="0">
-                <a:solidFill>
-                  <a:srgbClr val="273A52"/>
-                </a:solidFill>
-                <a:latin typeface="맑은 고딕"/>
-                <a:ea typeface="맑은 고딕"/>
-              </a:rPr>
-              <a:t>AIR</a:t>
-            </a:r>
-            <a:r>
-              <a:rPr lang="ko-KR" sz="1100" b="0" dirty="0">
-                <a:solidFill>
-                  <a:srgbClr val="1E2227"/>
-                </a:solidFill>
-                <a:latin typeface="맑은 고딕"/>
-                <a:ea typeface="맑은 고딕"/>
-              </a:rPr>
-              <a:t> = 추론정답·최종오답 문항 / 전체 문항</a:t>
-            </a:r>
-          </a:p>
-          <a:p>
-            <a:pPr marL="171450" indent="-171450" algn="l">
-              <a:lnSpc>
-                <a:spcPct val="118000"/>
-              </a:lnSpc>
-              <a:spcAft>
-                <a:spcPts val="260"/>
-              </a:spcAft>
-              <a:buFont typeface="Arial"/>
-              <a:buChar char="•"/>
-            </a:pPr>
-            <a:r>
-              <a:rPr lang="ko-KR" sz="1100" b="1" dirty="0">
-                <a:solidFill>
-                  <a:srgbClr val="273A52"/>
-                </a:solidFill>
-                <a:latin typeface="맑은 고딕"/>
-                <a:ea typeface="맑은 고딕"/>
-              </a:rPr>
-              <a:t>유형 인지율</a:t>
-            </a:r>
-            <a:r>
-              <a:rPr lang="ko-KR" sz="1100" b="0" dirty="0">
-                <a:solidFill>
-                  <a:srgbClr val="1E2227"/>
-                </a:solidFill>
-                <a:latin typeface="맑은 고딕"/>
-                <a:ea typeface="맑은 고딕"/>
-              </a:rPr>
-              <a:t> = 유형 적중 충돌문항 / 전체 충돌문항</a:t>
-            </a:r>
-          </a:p>
-          <a:p>
-            <a:pPr marL="171450" indent="-171450" algn="l">
-              <a:lnSpc>
-                <a:spcPct val="118000"/>
-              </a:lnSpc>
-              <a:spcAft>
-                <a:spcPts val="260"/>
-              </a:spcAft>
-              <a:buFont typeface="Arial"/>
-              <a:buChar char="•"/>
-            </a:pPr>
-            <a:r>
-              <a:rPr lang="ko-KR" sz="1100" b="1" dirty="0">
-                <a:solidFill>
-                  <a:srgbClr val="273A52"/>
-                </a:solidFill>
-                <a:latin typeface="맑은 고딕"/>
-                <a:ea typeface="맑은 고딕"/>
-              </a:rPr>
-              <a:t>LGR</a:t>
-            </a:r>
-            <a:r>
-              <a:rPr lang="ko-KR" sz="1100" b="0" dirty="0">
-                <a:solidFill>
-                  <a:srgbClr val="1E2227"/>
-                </a:solidFill>
-                <a:latin typeface="맑은 고딕"/>
-                <a:ea typeface="맑은 고딕"/>
-              </a:rPr>
-              <a:t> = 정상경로 신규정답 / 전체 신규정답</a:t>
-            </a:r>
-          </a:p>
-          <a:p>
-            <a:pPr marL="171450" indent="-171450" algn="l">
-              <a:lnSpc>
-                <a:spcPct val="118000"/>
-              </a:lnSpc>
-              <a:spcAft>
-                <a:spcPts val="260"/>
-              </a:spcAft>
-              <a:buFont typeface="Arial"/>
-              <a:buChar char="•"/>
-            </a:pPr>
-            <a:r>
-              <a:rPr lang="ko-KR" sz="1100" b="1" dirty="0">
-                <a:solidFill>
-                  <a:srgbClr val="273A52"/>
-                </a:solidFill>
-                <a:latin typeface="맑은 고딕"/>
-                <a:ea typeface="맑은 고딕"/>
-              </a:rPr>
-              <a:t>HR</a:t>
-            </a:r>
-            <a:r>
-              <a:rPr lang="ko-KR" sz="1100" b="0" dirty="0">
-                <a:solidFill>
-                  <a:srgbClr val="1E2227"/>
-                </a:solidFill>
-                <a:latin typeface="맑은 고딕"/>
-                <a:ea typeface="맑은 고딕"/>
-              </a:rPr>
-              <a:t> = 무너진 기존정답 / 완화 전 정답</a:t>
-            </a:r>
-          </a:p>
-          <a:p>
-            <a:pPr marL="171450" indent="-171450" algn="l">
-              <a:lnSpc>
-                <a:spcPct val="118000"/>
-              </a:lnSpc>
-              <a:spcAft>
-                <a:spcPts val="260"/>
-              </a:spcAft>
-              <a:buFont typeface="Arial"/>
-              <a:buChar char="•"/>
-            </a:pPr>
-            <a:r>
-              <a:rPr lang="ko-KR" sz="1100" b="1" dirty="0">
-                <a:solidFill>
-                  <a:srgbClr val="273A52"/>
-                </a:solidFill>
-                <a:latin typeface="맑은 고딕"/>
-                <a:ea typeface="맑은 고딕"/>
-              </a:rPr>
-              <a:t>Flip</a:t>
-            </a:r>
-            <a:r>
-              <a:rPr lang="ko-KR" sz="1100" b="0" dirty="0">
-                <a:solidFill>
-                  <a:srgbClr val="1E2227"/>
-                </a:solidFill>
-                <a:latin typeface="맑은 고딕"/>
-                <a:ea typeface="맑은 고딕"/>
-              </a:rPr>
-              <a:t> = 정답↔오답 역전 / 전체 문항</a:t>
-            </a:r>
-          </a:p>
-          <a:p>
-            <a:pPr marL="171450" indent="-171450" algn="l">
-              <a:lnSpc>
-                <a:spcPct val="118000"/>
-              </a:lnSpc>
-              <a:spcAft>
-                <a:spcPts val="260"/>
-              </a:spcAft>
-              <a:buFont typeface="Arial"/>
-              <a:buChar char="•"/>
-            </a:pPr>
-            <a:r>
-              <a:rPr lang="ko-KR" sz="1100" b="1" dirty="0">
-                <a:solidFill>
-                  <a:srgbClr val="273A52"/>
-                </a:solidFill>
-                <a:latin typeface="맑은 고딕"/>
-                <a:ea typeface="맑은 고딕"/>
-              </a:rPr>
-              <a:t>Shortcut</a:t>
-            </a:r>
-            <a:r>
-              <a:rPr lang="ko-KR" sz="1100" b="0" dirty="0">
-                <a:solidFill>
-                  <a:srgbClr val="1E2227"/>
-                </a:solidFill>
-                <a:latin typeface="맑은 고딕"/>
-                <a:ea typeface="맑은 고딕"/>
-              </a:rPr>
-              <a:t> = 도약경로 정답 / 전체 정답</a:t>
-            </a:r>
-          </a:p>
-          <a:p>
-            <a:pPr marL="171450" indent="-171450" algn="l">
-              <a:lnSpc>
-                <a:spcPct val="118000"/>
-              </a:lnSpc>
-              <a:spcAft>
-                <a:spcPts val="260"/>
-              </a:spcAft>
-              <a:buFont typeface="Arial"/>
-              <a:buChar char="•"/>
-            </a:pPr>
-            <a:r>
-              <a:rPr lang="ko-KR" sz="1100" b="1" dirty="0">
-                <a:solidFill>
-                  <a:srgbClr val="273A52"/>
-                </a:solidFill>
-                <a:latin typeface="맑은 고딕"/>
-                <a:ea typeface="맑은 고딕"/>
-              </a:rPr>
-              <a:t>충돌 순효과</a:t>
-            </a:r>
-            <a:r>
-              <a:rPr lang="ko-KR" sz="1100" b="0" dirty="0">
-                <a:solidFill>
-                  <a:srgbClr val="1E2227"/>
-                </a:solidFill>
-                <a:latin typeface="맑은 고딕"/>
-                <a:ea typeface="맑은 고딕"/>
-              </a:rPr>
-              <a:t> = 공변량 보정 회귀의 충돌 계수 </a:t>
-            </a:r>
-            <a:r>
-              <a:rPr lang="en-US" sz="1100" i="1" dirty="0">
-                <a:solidFill>
-                  <a:srgbClr val="1E2227"/>
-                </a:solidFill>
-                <a:latin typeface="Cambria Math"/>
-                <a:cs typeface="Cambria Math"/>
-              </a:rPr>
-              <a:t>β</a:t>
-            </a:r>
-          </a:p>
-          <a:p>
-            <a:pPr marL="171450" indent="-171450" algn="l">
-              <a:lnSpc>
-                <a:spcPct val="118000"/>
-              </a:lnSpc>
-              <a:spcAft>
-                <a:spcPts val="260"/>
-              </a:spcAft>
-              <a:buFont typeface="Arial"/>
-              <a:buChar char="•"/>
-            </a:pPr>
-            <a:r>
-              <a:rPr lang="ko-KR" sz="1100" b="1" dirty="0">
-                <a:solidFill>
-                  <a:srgbClr val="273A52"/>
-                </a:solidFill>
-                <a:latin typeface="맑은 고딕"/>
-                <a:ea typeface="맑은 고딕"/>
-              </a:rPr>
-              <a:t>정답 한정 답 변화율</a:t>
-            </a:r>
-            <a:r>
-              <a:rPr lang="ko-KR" sz="1100" b="0" dirty="0">
-                <a:solidFill>
-                  <a:srgbClr val="1E2227"/>
-                </a:solidFill>
-                <a:latin typeface="맑은 고딕"/>
-                <a:ea typeface="맑은 고딕"/>
-              </a:rPr>
-              <a:t> = 개입 후 바뀐 정답 / 정답 문항</a:t>
-            </a:r>
-          </a:p>
-          <a:p>
-            <a:pPr marL="171450" indent="-171450" algn="l">
-              <a:lnSpc>
-                <a:spcPct val="118000"/>
-              </a:lnSpc>
-              <a:spcAft>
-                <a:spcPts val="260"/>
-              </a:spcAft>
-              <a:buFont typeface="Arial"/>
-              <a:buChar char="•"/>
-            </a:pPr>
-            <a:r>
-              <a:rPr lang="ko-KR" sz="1100" b="1" dirty="0">
-                <a:solidFill>
-                  <a:srgbClr val="273A52"/>
-                </a:solidFill>
-                <a:latin typeface="맑은 고딕"/>
-                <a:ea typeface="맑은 고딕"/>
-              </a:rPr>
-              <a:t>경로별 취약성(p)</a:t>
-            </a:r>
-            <a:r>
-              <a:rPr lang="ko-KR" sz="1100" b="0" dirty="0">
-                <a:solidFill>
-                  <a:srgbClr val="1E2227"/>
-                </a:solidFill>
-                <a:latin typeface="맑은 고딕"/>
-                <a:ea typeface="맑은 고딕"/>
-              </a:rPr>
-              <a:t> = 경로 p 뒤집힘 / 경로 p 정답</a:t>
-            </a:r>
-          </a:p>
-        </p:txBody>
-      </p:sp>
     </p:spTree>
     <p:extLst>
       <p:ext uri="{BB962C8B-B14F-4D97-AF65-F5344CB8AC3E}">
-        <p14:creationId xmlns:p14="http://schemas.microsoft.com/office/powerpoint/2010/main" val="1710858786"/>
+        <p14:creationId xmlns:p14="http://schemas.microsoft.com/office/powerpoint/2010/main" val="439479226"/>
       </p:ext>
     </p:extLst>
   </p:cSld>
@@ -22081,11 +22196,17 @@
           <p:cNvGraphicFramePr>
             <a:graphicFrameLocks noGrp="1"/>
           </p:cNvGraphicFramePr>
-          <p:nvPr/>
+          <p:nvPr>
+            <p:extLst>
+              <p:ext uri="{D42A27DB-BD31-4B8C-83A1-F6EECF244321}">
+                <p14:modId xmlns:p14="http://schemas.microsoft.com/office/powerpoint/2010/main" val="3827271827"/>
+              </p:ext>
+            </p:extLst>
+          </p:nvPr>
         </p:nvGraphicFramePr>
         <p:xfrm>
           <a:off x="548640" y="1608328"/>
-          <a:ext cx="11087100" cy="2032000"/>
+          <a:ext cx="11087100" cy="1820673"/>
         </p:xfrm>
         <a:graphic>
           <a:graphicData uri="http://schemas.openxmlformats.org/drawingml/2006/table">
@@ -22116,7 +22237,7 @@
                   </a:extLst>
                 </a:gridCol>
               </a:tblGrid>
-              <a:tr h="355600">
+              <a:tr h="318618">
                 <a:tc>
                   <a:txBody>
                     <a:bodyPr/>
@@ -22195,7 +22316,7 @@
                   </a:ext>
                 </a:extLst>
               </a:tr>
-              <a:tr h="558800">
+              <a:tr h="500685">
                 <a:tc>
                   <a:txBody>
                     <a:bodyPr/>
@@ -22327,7 +22448,7 @@
                   </a:ext>
                 </a:extLst>
               </a:tr>
-              <a:tr h="558800">
+              <a:tr h="500685">
                 <a:tc>
                   <a:txBody>
                     <a:bodyPr/>
@@ -22372,14 +22493,34 @@
                     <a:p>
                       <a:pPr algn="l"/>
                       <a:r>
-                        <a:rPr lang="ko-KR" altLang="en-US" sz="1200" b="0">
+                        <a:rPr lang="ko-KR" altLang="en-US" sz="1200" b="0" dirty="0">
                           <a:solidFill>
                             <a:srgbClr val="1E2227"/>
                           </a:solidFill>
                           <a:latin typeface="맑은 고딕"/>
                           <a:ea typeface="맑은 고딕"/>
                         </a:rPr>
-                        <a:t>완화 전 정상 정답이던 문항이 오답·기권·AIR로 무너진 비율</a:t>
+                        <a:t>완화 전 정상 정답이던 문항이 </a:t>
+                      </a:r>
+                      <a:r>
+                        <a:rPr lang="ko-KR" altLang="en-US" sz="1200" b="0" dirty="0" err="1">
+                          <a:solidFill>
+                            <a:srgbClr val="1E2227"/>
+                          </a:solidFill>
+                          <a:latin typeface="맑은 고딕"/>
+                          <a:ea typeface="맑은 고딕"/>
+                        </a:rPr>
+                        <a:t>오답·기권·AIR로</a:t>
+                      </a:r>
+                      <a:r>
+                        <a:rPr lang="ko-KR" altLang="en-US" sz="1200" b="0" dirty="0">
+                          <a:solidFill>
+                            <a:srgbClr val="1E2227"/>
+                          </a:solidFill>
+                          <a:latin typeface="맑은 고딕"/>
+                          <a:ea typeface="맑은 고딕"/>
+                        </a:rPr>
+                        <a:t> 무너진 비율</a:t>
                       </a:r>
                     </a:p>
                   </a:txBody>
@@ -22439,7 +22580,7 @@
                   </a:ext>
                 </a:extLst>
               </a:tr>
-              <a:tr h="558800">
+              <a:tr h="500685">
                 <a:tc>
                   <a:txBody>
                     <a:bodyPr/>
@@ -30190,7 +30331,7 @@
           <p:nvPr>
             <p:extLst>
               <p:ext uri="{D42A27DB-BD31-4B8C-83A1-F6EECF244321}">
-                <p14:modId xmlns:p14="http://schemas.microsoft.com/office/powerpoint/2010/main" val="3453158413"/>
+                <p14:modId xmlns:p14="http://schemas.microsoft.com/office/powerpoint/2010/main" val="3893176576"/>
               </p:ext>
             </p:extLst>
           </p:nvPr>
@@ -30241,7 +30382,7 @@
                     <a:bodyPr/>
                     <a:lstStyle/>
                     <a:p>
-                      <a:pPr algn="l">
+                      <a:pPr algn="ctr">
                         <a:lnSpc>
                           <a:spcPct val="114000"/>
                         </a:lnSpc>
@@ -30250,15 +30391,42 @@
                         </a:spcAft>
                       </a:pPr>
                       <a:r>
-                        <a:rPr sz="1150" b="1">
+                        <a:rPr sz="1150" b="1" dirty="0" err="1">
                           <a:solidFill>
                             <a:srgbClr val="FFFFFF"/>
                           </a:solidFill>
                           <a:latin typeface="맑은 고딕"/>
                           <a:ea typeface="맑은 고딕"/>
                         </a:rPr>
-                        <a:t>버전 · 타입</a:t>
-                      </a:r>
+                        <a:t>버전</a:t>
+                      </a:r>
+                      <a:r>
+                        <a:rPr sz="1150" b="1" dirty="0">
+                          <a:solidFill>
+                            <a:srgbClr val="FFFFFF"/>
+                          </a:solidFill>
+                          <a:latin typeface="맑은 고딕"/>
+                          <a:ea typeface="맑은 고딕"/>
+                        </a:rPr>
+                        <a:t> · </a:t>
+                      </a:r>
+                      <a:r>
+                        <a:rPr sz="1150" b="1" dirty="0" err="1">
+                          <a:solidFill>
+                            <a:srgbClr val="FFFFFF"/>
+                          </a:solidFill>
+                          <a:latin typeface="맑은 고딕"/>
+                          <a:ea typeface="맑은 고딕"/>
+                        </a:rPr>
+                        <a:t>타입</a:t>
+                      </a:r>
+                      <a:endParaRPr sz="1150" b="1" dirty="0">
+                        <a:solidFill>
+                          <a:srgbClr val="FFFFFF"/>
+                        </a:solidFill>
+                        <a:latin typeface="맑은 고딕"/>
+                        <a:ea typeface="맑은 고딕"/>
+                      </a:endParaRPr>
                     </a:p>
                   </a:txBody>
                   <a:tcPr marL="82296" marR="82296" marT="36576" marB="36576" anchor="ctr">
@@ -30272,7 +30440,7 @@
                     <a:bodyPr/>
                     <a:lstStyle/>
                     <a:p>
-                      <a:pPr algn="l">
+                      <a:pPr algn="ctr">
                         <a:lnSpc>
                           <a:spcPct val="114000"/>
                         </a:lnSpc>
@@ -30281,15 +30449,42 @@
                         </a:spcAft>
                       </a:pPr>
                       <a:r>
-                        <a:rPr sz="1150" b="1">
+                        <a:rPr sz="1150" b="1" dirty="0" err="1">
                           <a:solidFill>
                             <a:srgbClr val="FFFFFF"/>
                           </a:solidFill>
                           <a:latin typeface="맑은 고딕"/>
                           <a:ea typeface="맑은 고딕"/>
                         </a:rPr>
-                        <a:t>무엇을 시도했나</a:t>
-                      </a:r>
+                        <a:t>무엇을</a:t>
+                      </a:r>
+                      <a:r>
+                        <a:rPr sz="1150" b="1" dirty="0">
+                          <a:solidFill>
+                            <a:srgbClr val="FFFFFF"/>
+                          </a:solidFill>
+                          <a:latin typeface="맑은 고딕"/>
+                          <a:ea typeface="맑은 고딕"/>
+                        </a:rPr>
+                        <a:t> </a:t>
+                      </a:r>
+                      <a:r>
+                        <a:rPr sz="1150" b="1" dirty="0" err="1">
+                          <a:solidFill>
+                            <a:srgbClr val="FFFFFF"/>
+                          </a:solidFill>
+                          <a:latin typeface="맑은 고딕"/>
+                          <a:ea typeface="맑은 고딕"/>
+                        </a:rPr>
+                        <a:t>시도했나</a:t>
+                      </a:r>
+                      <a:endParaRPr sz="1150" b="1" dirty="0">
+                        <a:solidFill>
+                          <a:srgbClr val="FFFFFF"/>
+                        </a:solidFill>
+                        <a:latin typeface="맑은 고딕"/>
+                        <a:ea typeface="맑은 고딕"/>
+                      </a:endParaRPr>
                     </a:p>
                   </a:txBody>
                   <a:tcPr marL="82296" marR="82296" marT="36576" marB="36576" anchor="ctr">
@@ -30303,7 +30498,7 @@
                     <a:bodyPr/>
                     <a:lstStyle/>
                     <a:p>
-                      <a:pPr algn="l">
+                      <a:pPr algn="ctr">
                         <a:lnSpc>
                           <a:spcPct val="114000"/>
                         </a:lnSpc>
@@ -30312,15 +30507,42 @@
                         </a:spcAft>
                       </a:pPr>
                       <a:r>
-                        <a:rPr sz="1150" b="1">
+                        <a:rPr sz="1150" b="1" dirty="0" err="1">
                           <a:solidFill>
                             <a:srgbClr val="FFFFFF"/>
                           </a:solidFill>
                           <a:latin typeface="맑은 고딕"/>
                           <a:ea typeface="맑은 고딕"/>
                         </a:rPr>
-                        <a:t>무엇을 얻었나</a:t>
-                      </a:r>
+                        <a:t>무엇을</a:t>
+                      </a:r>
+                      <a:r>
+                        <a:rPr sz="1150" b="1" dirty="0">
+                          <a:solidFill>
+                            <a:srgbClr val="FFFFFF"/>
+                          </a:solidFill>
+                          <a:latin typeface="맑은 고딕"/>
+                          <a:ea typeface="맑은 고딕"/>
+                        </a:rPr>
+                        <a:t> </a:t>
+                      </a:r>
+                      <a:r>
+                        <a:rPr sz="1150" b="1" dirty="0" err="1">
+                          <a:solidFill>
+                            <a:srgbClr val="FFFFFF"/>
+                          </a:solidFill>
+                          <a:latin typeface="맑은 고딕"/>
+                          <a:ea typeface="맑은 고딕"/>
+                        </a:rPr>
+                        <a:t>얻었나</a:t>
+                      </a:r>
+                      <a:endParaRPr sz="1150" b="1" dirty="0">
+                        <a:solidFill>
+                          <a:srgbClr val="FFFFFF"/>
+                        </a:solidFill>
+                        <a:latin typeface="맑은 고딕"/>
+                        <a:ea typeface="맑은 고딕"/>
+                      </a:endParaRPr>
                     </a:p>
                   </a:txBody>
                   <a:tcPr marL="82296" marR="82296" marT="36576" marB="36576" anchor="ctr">
@@ -30334,7 +30556,7 @@
                     <a:bodyPr/>
                     <a:lstStyle/>
                     <a:p>
-                      <a:pPr algn="l">
+                      <a:pPr algn="ctr">
                         <a:lnSpc>
                           <a:spcPct val="114000"/>
                         </a:lnSpc>
@@ -43501,7 +43723,7 @@
                 <a:latin typeface="맑은 고딕"/>
                 <a:ea typeface="맑은 고딕"/>
               </a:rPr>
-              <a:t>추론 결론이 최종 답변을 인과적으로 구동(L-b)</a:t>
+              <a:t>추론 결론이 최종 답변에 인과적으로 영향을 주는가(L-b)</a:t>
             </a:r>
             <a:r>
               <a:rPr lang="ko-KR" sz="1100" b="0" dirty="0">
@@ -43511,7 +43733,7 @@
                 <a:latin typeface="맑은 고딕"/>
                 <a:ea typeface="맑은 고딕"/>
               </a:rPr>
-              <a:t>하는가, 답변이 </a:t>
+              <a:t>, 답변이 </a:t>
             </a:r>
             <a:r>
               <a:rPr lang="ko-KR" sz="1100" b="1" dirty="0">
@@ -44304,7 +44526,7 @@
     </p:spTree>
     <p:extLst>
       <p:ext uri="{BB962C8B-B14F-4D97-AF65-F5344CB8AC3E}">
-        <p14:creationId xmlns:p14="http://schemas.microsoft.com/office/powerpoint/2010/main" val="3908019292"/>
+        <p14:creationId xmlns:p14="http://schemas.microsoft.com/office/powerpoint/2010/main" val="3975180155"/>
       </p:ext>
     </p:extLst>
   </p:cSld>

</xml_diff>

<commit_message>
refactor(prep): make CSV the working format of the pipeline
</commit_message>
<xml_diff>
--- a/docs/ThinkConflict_연구보고.pptx
+++ b/docs/ThinkConflict_연구보고.pptx
@@ -24,10 +24,10 @@
     <p:sldId id="571" r:id="rId15"/>
     <p:sldId id="599" r:id="rId16"/>
     <p:sldId id="676" r:id="rId17"/>
-    <p:sldId id="681" r:id="rId18"/>
+    <p:sldId id="684" r:id="rId18"/>
     <p:sldId id="595" r:id="rId19"/>
     <p:sldId id="644" r:id="rId20"/>
-    <p:sldId id="645" r:id="rId21"/>
+    <p:sldId id="685" r:id="rId21"/>
     <p:sldId id="646" r:id="rId22"/>
     <p:sldId id="648" r:id="rId23"/>
     <p:sldId id="440" r:id="rId24"/>
@@ -910,6 +910,90 @@
     <p:extLst>
       <p:ext uri="{BB962C8B-B14F-4D97-AF65-F5344CB8AC3E}">
         <p14:creationId xmlns:p14="http://schemas.microsoft.com/office/powerpoint/2010/main" val="2747419053"/>
+      </p:ext>
+    </p:extLst>
+  </p:cSld>
+  <p:clrMapOvr>
+    <a:masterClrMapping/>
+  </p:clrMapOvr>
+</p:notes>
+</file>
+
+<file path=ppt/notesSlides/notesSlide6.xml><?xml version="1.0" encoding="utf-8"?>
+<p:notes xmlns:a="http://schemas.openxmlformats.org/drawingml/2006/main" xmlns:r="http://schemas.openxmlformats.org/officeDocument/2006/relationships" xmlns:p="http://schemas.openxmlformats.org/presentationml/2006/main">
+  <p:cSld>
+    <p:spTree>
+      <p:nvGrpSpPr>
+        <p:cNvPr id="1" name=""/>
+        <p:cNvGrpSpPr/>
+        <p:nvPr/>
+      </p:nvGrpSpPr>
+      <p:grpSpPr>
+        <a:xfrm>
+          <a:off x="0" y="0"/>
+          <a:ext cx="0" cy="0"/>
+          <a:chOff x="0" y="0"/>
+          <a:chExt cx="0" cy="0"/>
+        </a:xfrm>
+      </p:grpSpPr>
+      <p:sp>
+        <p:nvSpPr>
+          <p:cNvPr id="2" name="슬라이드 이미지 개체 틀 1"/>
+          <p:cNvSpPr>
+            <a:spLocks noGrp="1" noRot="1" noChangeAspect="1"/>
+          </p:cNvSpPr>
+          <p:nvPr>
+            <p:ph type="sldImg"/>
+          </p:nvPr>
+        </p:nvSpPr>
+        <p:spPr/>
+      </p:sp>
+      <p:sp>
+        <p:nvSpPr>
+          <p:cNvPr id="3" name="슬라이드 노트 개체 틀 2"/>
+          <p:cNvSpPr>
+            <a:spLocks noGrp="1"/>
+          </p:cNvSpPr>
+          <p:nvPr>
+            <p:ph type="body" idx="1"/>
+          </p:nvPr>
+        </p:nvSpPr>
+        <p:spPr/>
+        <p:txBody>
+          <a:bodyPr/>
+          <a:lstStyle/>
+          <a:p>
+            <a:endParaRPr kumimoji="1" lang="ko-KR" altLang="en-US" dirty="0"/>
+          </a:p>
+        </p:txBody>
+      </p:sp>
+      <p:sp>
+        <p:nvSpPr>
+          <p:cNvPr id="4" name="슬라이드 번호 개체 틀 3"/>
+          <p:cNvSpPr>
+            <a:spLocks noGrp="1"/>
+          </p:cNvSpPr>
+          <p:nvPr>
+            <p:ph type="sldNum" sz="quarter" idx="5"/>
+          </p:nvPr>
+        </p:nvSpPr>
+        <p:spPr/>
+        <p:txBody>
+          <a:bodyPr/>
+          <a:lstStyle/>
+          <a:p>
+            <a:fld id="{79492483-278F-4C46-B567-3E1E49742A91}" type="slidenum">
+              <a:rPr kumimoji="1" lang="ko-KR" altLang="en-US" smtClean="0"/>
+              <a:t>21</a:t>
+            </a:fld>
+            <a:endParaRPr kumimoji="1" lang="ko-KR" altLang="en-US"/>
+          </a:p>
+        </p:txBody>
+      </p:sp>
+    </p:spTree>
+    <p:extLst>
+      <p:ext uri="{BB962C8B-B14F-4D97-AF65-F5344CB8AC3E}">
+        <p14:creationId xmlns:p14="http://schemas.microsoft.com/office/powerpoint/2010/main" val="4064272018"/>
       </p:ext>
     </p:extLst>
   </p:cSld>
@@ -7565,7 +7649,27 @@
                 <a:latin typeface="Consolas"/>
                 <a:ea typeface="맑은 고딕"/>
               </a:rPr>
-              <a:t>  "correct_answer": "sundown, Sat April 12, 2025",</a:t>
+              <a:t>  "</a:t>
+            </a:r>
+            <a:r>
+              <a:rPr lang="en-US" sz="1050" b="0" dirty="0" err="1">
+                <a:solidFill>
+                  <a:srgbClr val="1E2227"/>
+                </a:solidFill>
+                <a:latin typeface="Consolas"/>
+                <a:ea typeface="맑은 고딕"/>
+              </a:rPr>
+              <a:t>correct_answers</a:t>
+            </a:r>
+            <a:r>
+              <a:rPr lang="en-US" sz="1050" b="0" dirty="0">
+                <a:solidFill>
+                  <a:srgbClr val="1E2227"/>
+                </a:solidFill>
+                <a:latin typeface="Consolas"/>
+                <a:ea typeface="맑은 고딕"/>
+              </a:rPr>
+              <a:t>": ["sundown, Sat April 12, 2025”],</a:t>
             </a:r>
             <a:r>
               <a:rPr lang="ko-KR" sz="1000" b="0" dirty="0">
@@ -16145,56 +16249,6 @@
           </a:p>
         </p:txBody>
       </p:sp>
-      <p:sp>
-        <p:nvSpPr>
-          <p:cNvPr id="7" name="TextBox 6"/>
-          <p:cNvSpPr txBox="1"/>
-          <p:nvPr/>
-        </p:nvSpPr>
-        <p:spPr>
-          <a:xfrm>
-            <a:off x="548640" y="1270000"/>
-            <a:ext cx="11091672" cy="301236"/>
-          </a:xfrm>
-          <a:prstGeom prst="rect">
-            <a:avLst/>
-          </a:prstGeom>
-          <a:noFill/>
-        </p:spPr>
-        <p:txBody>
-          <a:bodyPr wrap="square" lIns="91440" tIns="45720" rIns="91440" bIns="45720" anchor="t" anchorCtr="0">
-            <a:spAutoFit/>
-          </a:bodyPr>
-          <a:lstStyle/>
-          <a:p>
-            <a:pPr algn="l">
-              <a:lnSpc>
-                <a:spcPct val="115000"/>
-              </a:lnSpc>
-            </a:pPr>
-            <a:r>
-              <a:rPr lang="ko-KR" sz="1300" b="1" dirty="0">
-                <a:solidFill>
-                  <a:srgbClr val="273A52"/>
-                </a:solidFill>
-                <a:latin typeface="맑은 고딕"/>
-                <a:ea typeface="맑은 고딕"/>
-              </a:rPr>
-              <a:t>네 가설을 어떻게 판정하고 무엇으로 재는지 한눈 종합   </a:t>
-            </a:r>
-            <a:r>
-              <a:rPr lang="ko-KR" sz="1200" b="0" dirty="0">
-                <a:solidFill>
-                  <a:srgbClr val="6B7480"/>
-                </a:solidFill>
-                <a:latin typeface="맑은 고딕"/>
-                <a:ea typeface="맑은 고딕"/>
-              </a:rPr>
-              <a:t>§3.2 진단 도구를 §3.3 세 실험이 실행한다 · 이득 분해는 실험 1 전용(20p)</a:t>
-            </a:r>
-          </a:p>
-        </p:txBody>
-      </p:sp>
       <p:graphicFrame>
         <p:nvGraphicFramePr>
           <p:cNvPr id="8" name="표 7">
@@ -16210,14 +16264,14 @@
           <p:nvPr>
             <p:extLst>
               <p:ext uri="{D42A27DB-BD31-4B8C-83A1-F6EECF244321}">
-                <p14:modId xmlns:p14="http://schemas.microsoft.com/office/powerpoint/2010/main" val="154420383"/>
+                <p14:modId xmlns:p14="http://schemas.microsoft.com/office/powerpoint/2010/main" val="2458455296"/>
               </p:ext>
             </p:extLst>
           </p:nvPr>
         </p:nvGraphicFramePr>
         <p:xfrm>
-          <a:off x="546100" y="1752599"/>
-          <a:ext cx="11087100" cy="4282380"/>
+          <a:off x="546100" y="1472183"/>
+          <a:ext cx="11087100" cy="4563869"/>
         </p:xfrm>
         <a:graphic>
           <a:graphicData uri="http://schemas.openxmlformats.org/drawingml/2006/table">
@@ -16262,7 +16316,7 @@
                   </a:extLst>
                 </a:gridCol>
               </a:tblGrid>
-              <a:tr h="430046">
+              <a:tr h="483855">
                 <a:tc>
                   <a:txBody>
                     <a:bodyPr/>
@@ -16389,7 +16443,7 @@
                   </a:ext>
                 </a:extLst>
               </a:tr>
-              <a:tr h="881950">
+              <a:tr h="992304">
                 <a:tc rowSpan="2">
                   <a:txBody>
                     <a:bodyPr/>
@@ -16452,47 +16506,7 @@
                           <a:latin typeface="맑은 고딕"/>
                           <a:ea typeface="맑은 고딕"/>
                         </a:rPr>
-                        <a:t>추론 결론과 최종 답변이 </a:t>
-                      </a:r>
-                      <a:r>
-                        <a:rPr lang="ko-KR" sz="1120" b="1" dirty="0">
-                          <a:solidFill>
-                            <a:srgbClr val="1E2227"/>
-                          </a:solidFill>
-                          <a:latin typeface="맑은 고딕"/>
-                          <a:ea typeface="맑은 고딕"/>
-                        </a:rPr>
-                        <a:t>일치(L-a)</a:t>
-                      </a:r>
-                      <a:r>
-                        <a:rPr lang="ko-KR" sz="1120" b="0" dirty="0">
-                          <a:solidFill>
-                            <a:srgbClr val="1E2227"/>
-                          </a:solidFill>
-                          <a:latin typeface="맑은 고딕"/>
-                          <a:ea typeface="맑은 고딕"/>
-                        </a:rPr>
-                        <a:t>하는가? 불일치는 </a:t>
-                      </a:r>
-                      <a:r>
-                        <a:rPr lang="ko-KR" sz="1120" b="1" dirty="0">
-                          <a:solidFill>
-                            <a:srgbClr val="1E2227"/>
-                          </a:solidFill>
-                          <a:latin typeface="맑은 고딕"/>
-                          <a:ea typeface="맑은 고딕"/>
-                        </a:rPr>
-                        <a:t>어느 단계</a:t>
-                      </a:r>
-                      <a:r>
-                        <a:rPr lang="ko-KR" sz="1120" b="0" dirty="0">
-                          <a:solidFill>
-                            <a:srgbClr val="1E2227"/>
-                          </a:solidFill>
-                          <a:latin typeface="맑은 고딕"/>
-                          <a:ea typeface="맑은 고딕"/>
-                        </a:rPr>
-                        <a:t>에서 생기나?</a:t>
+                        <a:t>추론 결론과 최종 답변이 일치(L-a)하는가? 불일치는 어느 단계에서 생기나?</a:t>
                       </a:r>
                     </a:p>
                   </a:txBody>
@@ -16525,7 +16539,17 @@
                           <a:latin typeface="맑은 고딕"/>
                           <a:ea typeface="맑은 고딕"/>
                         </a:rPr>
-                        <a:t>문항마다 추론 결론과 최종 답의 라벨을 맞대어 일치 여부 확인</a:t>
+                        <a:t>문항마다 추론 결론과 최종 답의 라벨을 맞대어 </a:t>
+                      </a:r>
+                      <a:r>
+                        <a:rPr lang="ko-KR" sz="1120" b="1" dirty="0">
+                          <a:solidFill>
+                            <a:srgbClr val="1E2227"/>
+                          </a:solidFill>
+                          <a:latin typeface="맑은 고딕"/>
+                          <a:ea typeface="맑은 고딕"/>
+                        </a:rPr>
+                        <a:t>일치 여부 확인</a:t>
                       </a:r>
                     </a:p>
                     <a:p>
@@ -16547,7 +16571,17 @@
                           <a:latin typeface="맑은 고딕"/>
                           <a:ea typeface="맑은 고딕"/>
                         </a:rPr>
-                        <a:t>충돌 유형을 얼마나 맞게 알아차리는지 집계</a:t>
+                        <a:t>충돌 유형을 얼마나 맞게 </a:t>
+                      </a:r>
+                      <a:r>
+                        <a:rPr lang="ko-KR" sz="1120" b="1" dirty="0">
+                          <a:solidFill>
+                            <a:srgbClr val="1E2227"/>
+                          </a:solidFill>
+                          <a:latin typeface="맑은 고딕"/>
+                          <a:ea typeface="맑은 고딕"/>
+                        </a:rPr>
+                        <a:t>알아차리는지 집계</a:t>
                       </a:r>
                     </a:p>
                   </a:txBody>
@@ -16626,16 +16660,6 @@
                         <a:t> = 유형 적중 충돌문항 / 전체 충돌문항</a:t>
                       </a:r>
                     </a:p>
-                    <a:p>
-                      <a:pPr algn="l"/>
-                      <a:endParaRPr lang="ko-KR" altLang="en-US" sz="1120" b="1" dirty="0">
-                        <a:solidFill>
-                          <a:srgbClr val="273A52"/>
-                        </a:solidFill>
-                        <a:latin typeface="맑은 고딕"/>
-                        <a:ea typeface="맑은 고딕"/>
-                      </a:endParaRPr>
-                    </a:p>
                   </a:txBody>
                   <a:tcPr anchor="ctr">
                     <a:solidFill>
@@ -16649,7 +16673,7 @@
                   </a:ext>
                 </a:extLst>
               </a:tr>
-              <a:tr h="860090">
+              <a:tr h="967710">
                 <a:tc vMerge="1">
                   <a:txBody>
                     <a:bodyPr/>
@@ -16709,47 +16733,7 @@
                           <a:latin typeface="맑은 고딕"/>
                           <a:ea typeface="맑은 고딕"/>
                         </a:rPr>
-                        <a:t>완화로 늘어난 정답, </a:t>
-                      </a:r>
-                      <a:r>
-                        <a:rPr lang="ko-KR" sz="1120" b="1" dirty="0">
-                          <a:solidFill>
-                            <a:srgbClr val="1E2227"/>
-                          </a:solidFill>
-                          <a:latin typeface="맑은 고딕"/>
-                          <a:ea typeface="맑은 고딕"/>
-                        </a:rPr>
-                        <a:t>진짜 추론</a:t>
-                      </a:r>
-                      <a:r>
-                        <a:rPr lang="ko-KR" sz="1120" b="0" dirty="0">
-                          <a:solidFill>
-                            <a:srgbClr val="1E2227"/>
-                          </a:solidFill>
-                          <a:latin typeface="맑은 고딕"/>
-                          <a:ea typeface="맑은 고딕"/>
-                        </a:rPr>
-                        <a:t>으로 맞혔나 · </a:t>
-                      </a:r>
-                      <a:r>
-                        <a:rPr lang="ko-KR" sz="1120" b="1" dirty="0">
-                          <a:solidFill>
-                            <a:srgbClr val="1E2227"/>
-                          </a:solidFill>
-                          <a:latin typeface="맑은 고딕"/>
-                          <a:ea typeface="맑은 고딕"/>
-                        </a:rPr>
-                        <a:t>우연</a:t>
-                      </a:r>
-                      <a:r>
-                        <a:rPr lang="ko-KR" sz="1120" b="0" dirty="0">
-                          <a:solidFill>
-                            <a:srgbClr val="1E2227"/>
-                          </a:solidFill>
-                          <a:latin typeface="맑은 고딕"/>
-                          <a:ea typeface="맑은 고딕"/>
-                        </a:rPr>
-                        <a:t>(우회 경로)인가?</a:t>
+                        <a:t>완화로 늘어난 정답, 진짜 추론으로 맞혔나 · 우연(우회 경로)인가?</a:t>
                       </a:r>
                     </a:p>
                   </a:txBody>
@@ -16782,7 +16766,27 @@
                           <a:latin typeface="맑은 고딕"/>
                           <a:ea typeface="맑은 고딕"/>
                         </a:rPr>
-                        <a:t>완화 전·후 같은 문항에서 새로 맞은 정답이 어느 경로로 왔는지 분해</a:t>
+                        <a:t>완화 전·후 같은 문항의 </a:t>
+                      </a:r>
+                      <a:r>
+                        <a:rPr lang="ko-KR" sz="1120" b="1" dirty="0">
+                          <a:solidFill>
+                            <a:srgbClr val="1E2227"/>
+                          </a:solidFill>
+                          <a:latin typeface="맑은 고딕"/>
+                          <a:ea typeface="맑은 고딕"/>
+                        </a:rPr>
+                        <a:t>정답 변화를 경로별로 분해</a:t>
+                      </a:r>
+                      <a:r>
+                        <a:rPr lang="ko-KR" sz="1120" b="0" dirty="0">
+                          <a:solidFill>
+                            <a:srgbClr val="1E2227"/>
+                          </a:solidFill>
+                          <a:latin typeface="맑은 고딕"/>
+                          <a:ea typeface="맑은 고딕"/>
+                        </a:rPr>
+                        <a:t> (신규 정답 · 숨은 퇴행 · 뒤집힘)</a:t>
                       </a:r>
                     </a:p>
                   </a:txBody>
@@ -16839,7 +16843,7 @@
                   </a:ext>
                 </a:extLst>
               </a:tr>
-              <a:tr h="881950">
+              <a:tr h="992304">
                 <a:tc>
                   <a:txBody>
                     <a:bodyPr/>
@@ -16902,47 +16906,7 @@
                           <a:latin typeface="맑은 고딕"/>
                           <a:ea typeface="맑은 고딕"/>
                         </a:rPr>
-                        <a:t>관측된 불일치는 </a:t>
-                      </a:r>
-                      <a:r>
-                        <a:rPr lang="ko-KR" sz="1120" b="1" dirty="0">
-                          <a:solidFill>
-                            <a:srgbClr val="1E2227"/>
-                          </a:solidFill>
-                          <a:latin typeface="맑은 고딕"/>
-                          <a:ea typeface="맑은 고딕"/>
-                        </a:rPr>
-                        <a:t>충돌 고유의 실패</a:t>
-                      </a:r>
-                      <a:r>
-                        <a:rPr lang="ko-KR" sz="1120" b="0" dirty="0">
-                          <a:solidFill>
-                            <a:srgbClr val="1E2227"/>
-                          </a:solidFill>
-                          <a:latin typeface="맑은 고딕"/>
-                          <a:ea typeface="맑은 고딕"/>
-                        </a:rPr>
-                        <a:t>인가, 난이도·문서 수 증가의 </a:t>
-                      </a:r>
-                      <a:r>
-                        <a:rPr lang="ko-KR" sz="1120" b="1" dirty="0">
-                          <a:solidFill>
-                            <a:srgbClr val="1E2227"/>
-                          </a:solidFill>
-                          <a:latin typeface="맑은 고딕"/>
-                          <a:ea typeface="맑은 고딕"/>
-                        </a:rPr>
-                        <a:t>부수 효과</a:t>
-                      </a:r>
-                      <a:r>
-                        <a:rPr lang="ko-KR" sz="1120" b="0" dirty="0">
-                          <a:solidFill>
-                            <a:srgbClr val="1E2227"/>
-                          </a:solidFill>
-                          <a:latin typeface="맑은 고딕"/>
-                          <a:ea typeface="맑은 고딕"/>
-                        </a:rPr>
-                        <a:t>인가?</a:t>
+                        <a:t>관측된 불일치는 충돌 고유의 실패인가, 난이도·문서 수 증가의 부수 효과인가?</a:t>
                       </a:r>
                     </a:p>
                   </a:txBody>
@@ -16975,7 +16939,17 @@
                           <a:latin typeface="맑은 고딕"/>
                           <a:ea typeface="맑은 고딕"/>
                         </a:rPr>
-                        <a:t>난이도·문서 수를 걷어낸 회귀로 ‘충돌 자체’의 효과만 추정</a:t>
+                        <a:t>난이도·문서 수를 걷어낸 회귀로 </a:t>
+                      </a:r>
+                      <a:r>
+                        <a:rPr lang="ko-KR" sz="1120" b="1" dirty="0">
+                          <a:solidFill>
+                            <a:srgbClr val="1E2227"/>
+                          </a:solidFill>
+                          <a:latin typeface="맑은 고딕"/>
+                          <a:ea typeface="맑은 고딕"/>
+                        </a:rPr>
+                        <a:t>‘충돌 자체’의 효과만 추정</a:t>
                       </a:r>
                     </a:p>
                     <a:p>
@@ -16997,7 +16971,17 @@
                           <a:latin typeface="맑은 고딕"/>
                           <a:ea typeface="맑은 고딕"/>
                         </a:rPr>
-                        <a:t>추론 과정을 켜고/꺼서 그 기여분만 분리</a:t>
+                        <a:t>추론 과정을 켜고/꺼서 그 </a:t>
+                      </a:r>
+                      <a:r>
+                        <a:rPr lang="ko-KR" sz="1120" b="1" dirty="0">
+                          <a:solidFill>
+                            <a:srgbClr val="1E2227"/>
+                          </a:solidFill>
+                          <a:latin typeface="맑은 고딕"/>
+                          <a:ea typeface="맑은 고딕"/>
+                        </a:rPr>
+                        <a:t>기여분만 분리</a:t>
                       </a:r>
                     </a:p>
                   </a:txBody>
@@ -17181,7 +17165,7 @@
                   </a:ext>
                 </a:extLst>
               </a:tr>
-              <a:tr h="881950">
+              <a:tr h="1127696">
                 <a:tc>
                   <a:txBody>
                     <a:bodyPr/>
@@ -17244,27 +17228,7 @@
                           <a:latin typeface="맑은 고딕"/>
                           <a:ea typeface="맑은 고딕"/>
                         </a:rPr>
-                        <a:t>추론 결론이 최종 답변에 </a:t>
-                      </a:r>
-                      <a:r>
-                        <a:rPr lang="ko-KR" sz="1120" b="1" dirty="0">
-                          <a:solidFill>
-                            <a:srgbClr val="1E2227"/>
-                          </a:solidFill>
-                          <a:latin typeface="맑은 고딕"/>
-                          <a:ea typeface="맑은 고딕"/>
-                        </a:rPr>
-                        <a:t>인과적으로 영향을 주는가(L-b)</a:t>
-                      </a:r>
-                      <a:r>
-                        <a:rPr lang="ko-KR" sz="1120" b="0" dirty="0">
-                          <a:solidFill>
-                            <a:srgbClr val="1E2227"/>
-                          </a:solidFill>
-                          <a:latin typeface="맑은 고딕"/>
-                          <a:ea typeface="맑은 고딕"/>
-                        </a:rPr>
-                        <a:t>?</a:t>
+                        <a:t>추론 결론이 최종 답변에 인과적으로 영향을 주는가(L-b)?</a:t>
                       </a:r>
                     </a:p>
                   </a:txBody>
@@ -17297,7 +17261,27 @@
                           <a:latin typeface="맑은 고딕"/>
                           <a:ea typeface="맑은 고딕"/>
                         </a:rPr>
-                        <a:t>맞힌 문항의 추론에 개입(절단·재생성)해 답이 바뀌는지 측정</a:t>
+                        <a:t>맞힌 문항의 추론에 </a:t>
+                      </a:r>
+                      <a:r>
+                        <a:rPr lang="ko-KR" sz="1120" b="1" dirty="0">
+                          <a:solidFill>
+                            <a:srgbClr val="1E2227"/>
+                          </a:solidFill>
+                          <a:latin typeface="맑은 고딕"/>
+                          <a:ea typeface="맑은 고딕"/>
+                        </a:rPr>
+                        <a:t>개입(절단·재생성)</a:t>
+                      </a:r>
+                      <a:r>
+                        <a:rPr lang="ko-KR" sz="1120" b="0" dirty="0">
+                          <a:solidFill>
+                            <a:srgbClr val="1E2227"/>
+                          </a:solidFill>
+                          <a:latin typeface="맑은 고딕"/>
+                          <a:ea typeface="맑은 고딕"/>
+                        </a:rPr>
+                        <a:t>해 답이 바뀌는지 측정</a:t>
                       </a:r>
                     </a:p>
                     <a:p>
@@ -17319,7 +17303,17 @@
                           <a:latin typeface="맑은 고딕"/>
                           <a:ea typeface="맑은 고딕"/>
                         </a:rPr>
-                        <a:t>경로별로 답이 뒤집히는 비율 비교</a:t>
+                        <a:t>개입 시 경로별로 답이 얼마나 </a:t>
+                      </a:r>
+                      <a:r>
+                        <a:rPr lang="ko-KR" sz="1120" b="1" dirty="0">
+                          <a:solidFill>
+                            <a:srgbClr val="1E2227"/>
+                          </a:solidFill>
+                          <a:latin typeface="맑은 고딕"/>
+                          <a:ea typeface="맑은 고딕"/>
+                        </a:rPr>
+                        <a:t>뒤집히는지 비교</a:t>
                       </a:r>
                     </a:p>
                   </a:txBody>
@@ -17527,7 +17521,7 @@
     </p:spTree>
     <p:extLst>
       <p:ext uri="{BB962C8B-B14F-4D97-AF65-F5344CB8AC3E}">
-        <p14:creationId xmlns:p14="http://schemas.microsoft.com/office/powerpoint/2010/main" val="439479226"/>
+        <p14:creationId xmlns:p14="http://schemas.microsoft.com/office/powerpoint/2010/main" val="130462809"/>
       </p:ext>
     </p:extLst>
   </p:cSld>
@@ -18560,7 +18554,7 @@
         </p:nvSpPr>
         <p:spPr>
           <a:xfrm>
-            <a:off x="548640" y="3962400"/>
+            <a:off x="548640" y="4169664"/>
             <a:ext cx="11087100" cy="33020"/>
           </a:xfrm>
           <a:prstGeom prst="rect">
@@ -18605,7 +18599,7 @@
         </p:nvSpPr>
         <p:spPr>
           <a:xfrm>
-            <a:off x="548640" y="4000500"/>
+            <a:off x="548640" y="4207764"/>
             <a:ext cx="11087100" cy="1985288"/>
           </a:xfrm>
           <a:prstGeom prst="rect">
@@ -18668,7 +18662,7 @@
               <a:buChar char="•"/>
             </a:pPr>
             <a:r>
-              <a:rPr lang="ko-KR" sz="1200" b="1" dirty="0">
+              <a:rPr lang="ko-KR" sz="1120" b="1" dirty="0">
                 <a:solidFill>
                   <a:srgbClr val="1E2227"/>
                 </a:solidFill>
@@ -18678,7 +18672,7 @@
               <a:t>네이티브 추론 모델만 사용합니다.</a:t>
             </a:r>
             <a:r>
-              <a:rPr lang="ko-KR" sz="1200" b="0" dirty="0">
+              <a:rPr lang="ko-KR" sz="1120" b="0" dirty="0">
                 <a:solidFill>
                   <a:srgbClr val="1E2227"/>
                 </a:solidFill>
@@ -18687,7 +18681,7 @@
               </a:rPr>
               <a:t>  SFT 증류 모델은 장식적 트레이스 위험이 있어 제외합니다.</a:t>
             </a:r>
-            <a:endParaRPr lang="en-US" altLang="ko-KR" sz="1200" b="0" dirty="0">
+            <a:endParaRPr lang="en-US" altLang="ko-KR" sz="1120" b="0" dirty="0">
               <a:solidFill>
                 <a:srgbClr val="1E2227"/>
               </a:solidFill>
@@ -18707,7 +18701,7 @@
               <a:buChar char="•"/>
             </a:pPr>
             <a:r>
-              <a:rPr lang="ko-KR" sz="1200" b="1" dirty="0">
+              <a:rPr lang="ko-KR" sz="1120" b="1" dirty="0">
                 <a:solidFill>
                   <a:srgbClr val="1E2227"/>
                 </a:solidFill>
@@ -18717,7 +18711,7 @@
               <a:t>20~32B 오픈 가중치만 씁니다.</a:t>
             </a:r>
             <a:r>
-              <a:rPr lang="ko-KR" sz="1200" b="0" dirty="0">
+              <a:rPr lang="ko-KR" sz="1120" b="0" dirty="0">
                 <a:solidFill>
                   <a:srgbClr val="1E2227"/>
                 </a:solidFill>
@@ -18726,7 +18720,7 @@
               </a:rPr>
               <a:t>  사고 과정(추론 트레이스)을 통째로 읽어 라벨링해야 하는데, 폐쇄형 API는 이를 숨기거나 요약만 줘서 불가능하기 때문입니다. 이 규모는 제대로 된 추론 능력이 나타나면서도, 압축(양자화) 없이 같은 설정으로 여러 번 반복 실행해 우연·왜곡 없이 재현할 수 있는 지점입니다.</a:t>
             </a:r>
-            <a:endParaRPr lang="en-US" altLang="ko-KR" sz="1200" b="0" dirty="0">
+            <a:endParaRPr lang="en-US" altLang="ko-KR" sz="1120" b="0" dirty="0">
               <a:solidFill>
                 <a:srgbClr val="1E2227"/>
               </a:solidFill>
@@ -18746,7 +18740,7 @@
               <a:buChar char="•"/>
             </a:pPr>
             <a:r>
-              <a:rPr lang="ko-KR" sz="1200" b="1" dirty="0">
+              <a:rPr lang="ko-KR" sz="1120" b="1" dirty="0">
                 <a:solidFill>
                   <a:srgbClr val="1E2227"/>
                 </a:solidFill>
@@ -18756,7 +18750,7 @@
               <a:t>추론 유무를 교차합니다.</a:t>
             </a:r>
             <a:r>
-              <a:rPr lang="ko-KR" sz="1200" b="0" dirty="0">
+              <a:rPr lang="ko-KR" sz="1120" b="0" dirty="0">
                 <a:solidFill>
                   <a:srgbClr val="1E2227"/>
                 </a:solidFill>
@@ -19061,11 +19055,17 @@
           <p:cNvGraphicFramePr>
             <a:graphicFrameLocks noGrp="1"/>
           </p:cNvGraphicFramePr>
-          <p:nvPr/>
+          <p:nvPr>
+            <p:extLst>
+              <p:ext uri="{D42A27DB-BD31-4B8C-83A1-F6EECF244321}">
+                <p14:modId xmlns:p14="http://schemas.microsoft.com/office/powerpoint/2010/main" val="1402298283"/>
+              </p:ext>
+            </p:extLst>
+          </p:nvPr>
         </p:nvGraphicFramePr>
         <p:xfrm>
           <a:off x="548640" y="1600200"/>
-          <a:ext cx="11091672" cy="3352800"/>
+          <a:ext cx="11091672" cy="3487422"/>
         </p:xfrm>
         <a:graphic>
           <a:graphicData uri="http://schemas.openxmlformats.org/drawingml/2006/table">
@@ -19095,14 +19095,14 @@
                     </a:ext>
                   </a:extLst>
                 </a:gridCol>
-                <a:gridCol w="5330952">
+                <a:gridCol w="5468112">
                   <a:extLst>
                     <a:ext uri="{9D8B030D-6E8A-4147-A177-3AD203B41FA5}">
                       <a16:colId xmlns:a16="http://schemas.microsoft.com/office/drawing/2014/main" val="20003"/>
                     </a:ext>
                   </a:extLst>
                 </a:gridCol>
-                <a:gridCol w="1280160">
+                <a:gridCol w="1143000">
                   <a:extLst>
                     <a:ext uri="{9D8B030D-6E8A-4147-A177-3AD203B41FA5}">
                       <a16:colId xmlns:a16="http://schemas.microsoft.com/office/drawing/2014/main" val="20004"/>
@@ -19110,13 +19110,13 @@
                   </a:extLst>
                 </a:gridCol>
               </a:tblGrid>
-              <a:tr h="431800">
+              <a:tr h="449137">
                 <a:tc>
                   <a:txBody>
                     <a:bodyPr/>
                     <a:lstStyle/>
                     <a:p>
-                      <a:pPr algn="l">
+                      <a:pPr algn="ctr">
                         <a:lnSpc>
                           <a:spcPct val="114000"/>
                         </a:lnSpc>
@@ -19147,7 +19147,7 @@
                     <a:bodyPr/>
                     <a:lstStyle/>
                     <a:p>
-                      <a:pPr algn="l">
+                      <a:pPr algn="ctr">
                         <a:lnSpc>
                           <a:spcPct val="114000"/>
                         </a:lnSpc>
@@ -19178,7 +19178,7 @@
                     <a:bodyPr/>
                     <a:lstStyle/>
                     <a:p>
-                      <a:pPr algn="l">
+                      <a:pPr algn="ctr">
                         <a:lnSpc>
                           <a:spcPct val="114000"/>
                         </a:lnSpc>
@@ -19209,7 +19209,7 @@
                     <a:bodyPr/>
                     <a:lstStyle/>
                     <a:p>
-                      <a:pPr algn="l">
+                      <a:pPr algn="ctr">
                         <a:lnSpc>
                           <a:spcPct val="114000"/>
                         </a:lnSpc>
@@ -19240,7 +19240,7 @@
                     <a:bodyPr/>
                     <a:lstStyle/>
                     <a:p>
-                      <a:pPr algn="l">
+                      <a:pPr algn="ctr">
                         <a:lnSpc>
                           <a:spcPct val="114000"/>
                         </a:lnSpc>
@@ -19249,15 +19249,42 @@
                         </a:spcAft>
                       </a:pPr>
                       <a:r>
-                        <a:rPr sz="1150" b="1">
+                        <a:rPr sz="1150" b="1" dirty="0" err="1">
                           <a:solidFill>
                             <a:srgbClr val="FFFFFF"/>
                           </a:solidFill>
                           <a:latin typeface="맑은 고딕"/>
                           <a:ea typeface="맑은 고딕"/>
                         </a:rPr>
-                        <a:t>예상 영향</a:t>
-                      </a:r>
+                        <a:t>예상</a:t>
+                      </a:r>
+                      <a:r>
+                        <a:rPr sz="1150" b="1" dirty="0">
+                          <a:solidFill>
+                            <a:srgbClr val="FFFFFF"/>
+                          </a:solidFill>
+                          <a:latin typeface="맑은 고딕"/>
+                          <a:ea typeface="맑은 고딕"/>
+                        </a:rPr>
+                        <a:t> </a:t>
+                      </a:r>
+                      <a:r>
+                        <a:rPr sz="1150" b="1" dirty="0" err="1">
+                          <a:solidFill>
+                            <a:srgbClr val="FFFFFF"/>
+                          </a:solidFill>
+                          <a:latin typeface="맑은 고딕"/>
+                          <a:ea typeface="맑은 고딕"/>
+                        </a:rPr>
+                        <a:t>영향</a:t>
+                      </a:r>
+                      <a:endParaRPr sz="1150" b="1" dirty="0">
+                        <a:solidFill>
+                          <a:srgbClr val="FFFFFF"/>
+                        </a:solidFill>
+                        <a:latin typeface="맑은 고딕"/>
+                        <a:ea typeface="맑은 고딕"/>
+                      </a:endParaRPr>
                     </a:p>
                   </a:txBody>
                   <a:tcPr marL="82296" marR="82296" marT="36576" marB="36576" anchor="ctr">
@@ -19272,7 +19299,7 @@
                   </a:ext>
                 </a:extLst>
               </a:tr>
-              <a:tr h="584200">
+              <a:tr h="607657">
                 <a:tc>
                   <a:txBody>
                     <a:bodyPr/>
@@ -19494,7 +19521,7 @@
                   </a:ext>
                 </a:extLst>
               </a:tr>
-              <a:tr h="584200">
+              <a:tr h="607657">
                 <a:tc>
                   <a:txBody>
                     <a:bodyPr/>
@@ -19736,7 +19763,7 @@
                   </a:ext>
                 </a:extLst>
               </a:tr>
-              <a:tr h="584200">
+              <a:tr h="607657">
                 <a:tc>
                   <a:txBody>
                     <a:bodyPr/>
@@ -19948,7 +19975,7 @@
                   </a:ext>
                 </a:extLst>
               </a:tr>
-              <a:tr h="584200">
+              <a:tr h="607657">
                 <a:tc>
                   <a:txBody>
                     <a:bodyPr/>
@@ -20063,7 +20090,67 @@
                           <a:latin typeface="맑은 고딕"/>
                           <a:ea typeface="맑은 고딕"/>
                         </a:rPr>
-                        <a:t>date 최신성·url 권위를 우선</a:t>
+                        <a:t>date </a:t>
+                      </a:r>
+                      <a:r>
+                        <a:rPr sz="1120" b="1" dirty="0" err="1">
+                          <a:solidFill>
+                            <a:srgbClr val="1E2227"/>
+                          </a:solidFill>
+                          <a:latin typeface="맑은 고딕"/>
+                          <a:ea typeface="맑은 고딕"/>
+                        </a:rPr>
+                        <a:t>최신성</a:t>
+                      </a:r>
+                      <a:r>
+                        <a:rPr lang="ko-KR" altLang="en-US" sz="1120" b="1" dirty="0">
+                          <a:solidFill>
+                            <a:srgbClr val="1E2227"/>
+                          </a:solidFill>
+                          <a:latin typeface="맑은 고딕"/>
+                          <a:ea typeface="맑은 고딕"/>
+                        </a:rPr>
+                        <a:t> </a:t>
+                      </a:r>
+                      <a:r>
+                        <a:rPr sz="1120" b="1" dirty="0">
+                          <a:solidFill>
+                            <a:srgbClr val="1E2227"/>
+                          </a:solidFill>
+                          <a:latin typeface="맑은 고딕"/>
+                          <a:ea typeface="맑은 고딕"/>
+                        </a:rPr>
+                        <a:t>·</a:t>
+                      </a:r>
+                      <a:r>
+                        <a:rPr lang="ko-KR" altLang="en-US" sz="1120" b="1" dirty="0">
+                          <a:solidFill>
+                            <a:srgbClr val="1E2227"/>
+                          </a:solidFill>
+                          <a:latin typeface="맑은 고딕"/>
+                          <a:ea typeface="맑은 고딕"/>
+                        </a:rPr>
+                        <a:t> </a:t>
+                      </a:r>
+                      <a:r>
+                        <a:rPr sz="1120" b="1" dirty="0" err="1">
+                          <a:solidFill>
+                            <a:srgbClr val="1E2227"/>
+                          </a:solidFill>
+                          <a:latin typeface="맑은 고딕"/>
+                          <a:ea typeface="맑은 고딕"/>
+                        </a:rPr>
+                        <a:t>url</a:t>
+                      </a:r>
+                      <a:r>
+                        <a:rPr sz="1120" b="1" dirty="0">
+                          <a:solidFill>
+                            <a:srgbClr val="1E2227"/>
+                          </a:solidFill>
+                          <a:latin typeface="맑은 고딕"/>
+                          <a:ea typeface="맑은 고딕"/>
+                        </a:rPr>
+                        <a:t> 권위를 우선</a:t>
                       </a:r>
                       <a:r>
                         <a:rPr sz="1120" b="0" dirty="0">
@@ -20140,7 +20227,7 @@
                   </a:ext>
                 </a:extLst>
               </a:tr>
-              <a:tr h="584200">
+              <a:tr h="607657">
                 <a:tc>
                   <a:txBody>
                     <a:bodyPr/>
@@ -20374,7 +20461,7 @@
         </p:nvSpPr>
         <p:spPr>
           <a:xfrm>
-            <a:off x="546100" y="5105400"/>
+            <a:off x="546100" y="5215128"/>
             <a:ext cx="11091672" cy="1143000"/>
           </a:xfrm>
           <a:prstGeom prst="rect">
@@ -20415,7 +20502,7 @@
               <a:buChar char="•"/>
             </a:pPr>
             <a:r>
-              <a:rPr lang="ko-KR" sz="1200" b="1" dirty="0">
+              <a:rPr lang="ko-KR" sz="1120" b="1" dirty="0">
                 <a:solidFill>
                   <a:srgbClr val="273A52"/>
                 </a:solidFill>
@@ -20425,7 +20512,7 @@
               <a:t>실행 방법. </a:t>
             </a:r>
             <a:r>
-              <a:rPr lang="ko-KR" sz="1200" b="0" dirty="0">
+              <a:rPr lang="ko-KR" sz="1120" b="0" dirty="0">
                 <a:solidFill>
                   <a:srgbClr val="1E2227"/>
                 </a:solidFill>
@@ -20435,7 +20522,7 @@
               <a:t>5개 환경 × 3개 모델 × 3개 데이터셋을 순서를 섞어 전부 실행해 </a:t>
             </a:r>
             <a:r>
-              <a:rPr lang="ko-KR" sz="1200" b="1" dirty="0">
+              <a:rPr lang="ko-KR" sz="1120" b="1" dirty="0">
                 <a:solidFill>
                   <a:srgbClr val="1E2227"/>
                 </a:solidFill>
@@ -20445,7 +20532,7 @@
               <a:t>환경별 전환 행렬</a:t>
             </a:r>
             <a:r>
-              <a:rPr lang="ko-KR" sz="1200" b="0" dirty="0">
+              <a:rPr lang="ko-KR" sz="1120" b="0" dirty="0">
                 <a:solidFill>
                   <a:srgbClr val="1E2227"/>
                 </a:solidFill>
@@ -20454,7 +20541,7 @@
               </a:rPr>
               <a:t>을 도출한다</a:t>
             </a:r>
-            <a:endParaRPr lang="en-US" altLang="ko-KR" sz="1200" b="0" dirty="0">
+            <a:endParaRPr lang="en-US" altLang="ko-KR" sz="1120" b="0" dirty="0">
               <a:solidFill>
                 <a:srgbClr val="1E2227"/>
               </a:solidFill>
@@ -20474,7 +20561,7 @@
               <a:buChar char="•"/>
             </a:pPr>
             <a:r>
-              <a:rPr lang="ko-KR" sz="1200" b="1" dirty="0">
+              <a:rPr lang="ko-KR" sz="1120" b="1" dirty="0">
                 <a:solidFill>
                   <a:srgbClr val="273A52"/>
                 </a:solidFill>
@@ -20484,7 +20571,7 @@
               <a:t>프레임. </a:t>
             </a:r>
             <a:r>
-              <a:rPr lang="ko-KR" sz="1200" b="0" dirty="0">
+              <a:rPr lang="ko-KR" sz="1120" b="0" dirty="0">
                 <a:solidFill>
                   <a:srgbClr val="1E2227"/>
                 </a:solidFill>
@@ -20494,7 +20581,7 @@
               <a:t>기법 대부분이 비-thinking 모델 산물이라, 성능 순위가 아니라 </a:t>
             </a:r>
             <a:r>
-              <a:rPr lang="ko-KR" sz="1200" b="1" dirty="0">
+              <a:rPr lang="ko-KR" sz="1120" b="1" dirty="0">
                 <a:solidFill>
                   <a:srgbClr val="1E2227"/>
                 </a:solidFill>
@@ -20504,7 +20591,7 @@
               <a:t>추론 모델에서의 정답 경로 변화</a:t>
             </a:r>
             <a:r>
-              <a:rPr lang="ko-KR" sz="1200" b="0" dirty="0">
+              <a:rPr lang="ko-KR" sz="1120" b="0" dirty="0">
                 <a:solidFill>
                   <a:srgbClr val="1E2227"/>
                 </a:solidFill>
@@ -20526,7 +20613,7 @@
               <a:buChar char="•"/>
             </a:pPr>
             <a:r>
-              <a:rPr lang="ko-KR" sz="1200" b="1" dirty="0">
+              <a:rPr lang="ko-KR" sz="1120" b="1" dirty="0">
                 <a:solidFill>
                   <a:srgbClr val="273A52"/>
                 </a:solidFill>
@@ -20536,7 +20623,7 @@
               <a:t>안정성. </a:t>
             </a:r>
             <a:r>
-              <a:rPr lang="ko-KR" sz="1200" b="0" dirty="0">
+              <a:rPr lang="ko-KR" sz="1120" b="0" dirty="0">
                 <a:solidFill>
                   <a:srgbClr val="1E2227"/>
                 </a:solidFill>
@@ -20546,7 +20633,7 @@
               <a:t>문항당 시드 5회 이상 반복해 </a:t>
             </a:r>
             <a:r>
-              <a:rPr lang="ko-KR" sz="1200" b="1" dirty="0">
+              <a:rPr lang="ko-KR" sz="1120" b="1" dirty="0">
                 <a:solidFill>
                   <a:srgbClr val="1E2227"/>
                 </a:solidFill>
@@ -20556,7 +20643,7 @@
               <a:t>최빈 경로</a:t>
             </a:r>
             <a:r>
-              <a:rPr lang="ko-KR" sz="1200" b="0" dirty="0">
+              <a:rPr lang="ko-KR" sz="1120" b="0" dirty="0">
                 <a:solidFill>
                   <a:srgbClr val="1E2227"/>
                 </a:solidFill>
@@ -20566,7 +20653,7 @@
               <a:t>를 대표로 삼고, 과반 미달(예: 2-2-1)은 </a:t>
             </a:r>
             <a:r>
-              <a:rPr lang="ko-KR" sz="1200" b="1" dirty="0">
+              <a:rPr lang="ko-KR" sz="1120" b="1" dirty="0">
                 <a:solidFill>
                   <a:srgbClr val="1E2227"/>
                 </a:solidFill>
@@ -20576,7 +20663,7 @@
               <a:t>'불안정'으로 분리</a:t>
             </a:r>
             <a:r>
-              <a:rPr lang="ko-KR" sz="1200" b="0" dirty="0">
+              <a:rPr lang="ko-KR" sz="1120" b="0" dirty="0">
                 <a:solidFill>
                   <a:srgbClr val="1E2227"/>
                 </a:solidFill>
@@ -22196,13 +22283,7 @@
           <p:cNvGraphicFramePr>
             <a:graphicFrameLocks noGrp="1"/>
           </p:cNvGraphicFramePr>
-          <p:nvPr>
-            <p:extLst>
-              <p:ext uri="{D42A27DB-BD31-4B8C-83A1-F6EECF244321}">
-                <p14:modId xmlns:p14="http://schemas.microsoft.com/office/powerpoint/2010/main" val="3827271827"/>
-              </p:ext>
-            </p:extLst>
-          </p:nvPr>
+          <p:nvPr/>
         </p:nvGraphicFramePr>
         <p:xfrm>
           <a:off x="548640" y="1608328"/>
@@ -22245,7 +22326,7 @@
                     <a:p>
                       <a:pPr algn="ctr"/>
                       <a:r>
-                        <a:rPr lang="ko-KR" altLang="en-US" sz="1200" b="1">
+                        <a:rPr lang="ko-KR" altLang="en-US" sz="1120" b="1">
                           <a:solidFill>
                             <a:srgbClr val="FFFFFF"/>
                           </a:solidFill>
@@ -22269,7 +22350,7 @@
                     <a:p>
                       <a:pPr algn="ctr"/>
                       <a:r>
-                        <a:rPr lang="ko-KR" altLang="en-US" sz="1200" b="1" dirty="0">
+                        <a:rPr lang="ko-KR" altLang="en-US" sz="1120" b="1" dirty="0">
                           <a:solidFill>
                             <a:srgbClr val="FFFFFF"/>
                           </a:solidFill>
@@ -22293,7 +22374,7 @@
                     <a:p>
                       <a:pPr algn="ctr"/>
                       <a:r>
-                        <a:rPr lang="ko-KR" altLang="en-US" sz="1200" b="1">
+                        <a:rPr lang="ko-KR" altLang="en-US" sz="1120" b="1" dirty="0">
                           <a:solidFill>
                             <a:srgbClr val="FFFFFF"/>
                           </a:solidFill>
@@ -22324,7 +22405,7 @@
                     <a:p>
                       <a:pPr algn="l"/>
                       <a:r>
-                        <a:rPr lang="en-US" sz="1200" b="1" dirty="0">
+                        <a:rPr lang="en-US" sz="1120" b="1" dirty="0">
                           <a:solidFill>
                             <a:srgbClr val="1E2227"/>
                           </a:solidFill>
@@ -22361,7 +22442,7 @@
                     <a:p>
                       <a:pPr algn="l"/>
                       <a:r>
-                        <a:rPr lang="ko-KR" altLang="en-US" sz="1200" b="0" dirty="0">
+                        <a:rPr lang="ko-KR" altLang="en-US" sz="1120" b="0" dirty="0">
                           <a:solidFill>
                             <a:srgbClr val="1E2227"/>
                           </a:solidFill>
@@ -22371,7 +22452,7 @@
                         <a:t>새로 맞은 정답 중 '정상 </a:t>
                       </a:r>
                       <a:r>
-                        <a:rPr lang="ko-KR" altLang="en-US" sz="1200" b="0" dirty="0" err="1">
+                        <a:rPr lang="ko-KR" altLang="en-US" sz="1120" b="0" dirty="0" err="1">
                           <a:solidFill>
                             <a:srgbClr val="1E2227"/>
                           </a:solidFill>
@@ -22381,7 +22462,7 @@
                         <a:t>경로'로</a:t>
                       </a:r>
                       <a:r>
-                        <a:rPr lang="ko-KR" altLang="en-US" sz="1200" b="0" dirty="0">
+                        <a:rPr lang="ko-KR" altLang="en-US" sz="1120" b="0" dirty="0">
                           <a:solidFill>
                             <a:srgbClr val="1E2227"/>
                           </a:solidFill>
@@ -22405,7 +22486,7 @@
                     <a:p>
                       <a:pPr algn="l"/>
                       <a:r>
-                        <a:rPr lang="ko-KR" altLang="en-US" sz="1200" b="0">
+                        <a:rPr lang="ko-KR" altLang="en-US" sz="1120" b="0">
                           <a:solidFill>
                             <a:srgbClr val="1E2227"/>
                           </a:solidFill>
@@ -22415,7 +22496,7 @@
                         <a:t>높으면 </a:t>
                       </a:r>
                       <a:r>
-                        <a:rPr lang="ko-KR" altLang="en-US" sz="1200" b="1">
+                        <a:rPr lang="ko-KR" altLang="en-US" sz="1120" b="1">
                           <a:solidFill>
                             <a:srgbClr val="1E2227"/>
                           </a:solidFill>
@@ -22425,7 +22506,7 @@
                         <a:t>진짜 이득</a:t>
                       </a:r>
                       <a:r>
-                        <a:rPr lang="ko-KR" altLang="en-US" sz="1200" b="0">
+                        <a:rPr lang="ko-KR" altLang="en-US" sz="1120" b="0">
                           <a:solidFill>
                             <a:srgbClr val="1E2227"/>
                           </a:solidFill>
@@ -22456,7 +22537,7 @@
                     <a:p>
                       <a:pPr algn="l"/>
                       <a:r>
-                        <a:rPr lang="en-US" sz="1200" b="1" dirty="0">
+                        <a:rPr lang="en-US" sz="1120" b="1" dirty="0">
                           <a:solidFill>
                             <a:srgbClr val="1E2227"/>
                           </a:solidFill>
@@ -22493,7 +22574,7 @@
                     <a:p>
                       <a:pPr algn="l"/>
                       <a:r>
-                        <a:rPr lang="ko-KR" altLang="en-US" sz="1200" b="0" dirty="0">
+                        <a:rPr lang="ko-KR" altLang="en-US" sz="1120" b="0" dirty="0">
                           <a:solidFill>
                             <a:srgbClr val="1E2227"/>
                           </a:solidFill>
@@ -22503,7 +22584,7 @@
                         <a:t>완화 전 정상 정답이던 문항이 </a:t>
                       </a:r>
                       <a:r>
-                        <a:rPr lang="ko-KR" altLang="en-US" sz="1200" b="0" dirty="0" err="1">
+                        <a:rPr lang="ko-KR" altLang="en-US" sz="1120" b="0" dirty="0" err="1">
                           <a:solidFill>
                             <a:srgbClr val="1E2227"/>
                           </a:solidFill>
@@ -22513,7 +22594,7 @@
                         <a:t>오답·기권·AIR로</a:t>
                       </a:r>
                       <a:r>
-                        <a:rPr lang="ko-KR" altLang="en-US" sz="1200" b="0" dirty="0">
+                        <a:rPr lang="ko-KR" altLang="en-US" sz="1120" b="0" dirty="0">
                           <a:solidFill>
                             <a:srgbClr val="1E2227"/>
                           </a:solidFill>
@@ -22537,7 +22618,7 @@
                     <a:p>
                       <a:pPr algn="l"/>
                       <a:r>
-                        <a:rPr lang="ko-KR" altLang="en-US" sz="1200" b="0">
+                        <a:rPr lang="ko-KR" altLang="en-US" sz="1120" b="0">
                           <a:solidFill>
                             <a:srgbClr val="1E2227"/>
                           </a:solidFill>
@@ -22547,7 +22628,7 @@
                         <a:t>클수록 EM이 올라도 </a:t>
                       </a:r>
                       <a:r>
-                        <a:rPr lang="ko-KR" altLang="en-US" sz="1200" b="1">
+                        <a:rPr lang="ko-KR" altLang="en-US" sz="1120" b="1">
                           <a:solidFill>
                             <a:srgbClr val="1E2227"/>
                           </a:solidFill>
@@ -22557,7 +22638,7 @@
                         <a:t>이득 신뢰도 차감</a:t>
                       </a:r>
                       <a:r>
-                        <a:rPr lang="ko-KR" altLang="en-US" sz="1200" b="0">
+                        <a:rPr lang="ko-KR" altLang="en-US" sz="1120" b="0">
                           <a:solidFill>
                             <a:srgbClr val="1E2227"/>
                           </a:solidFill>
@@ -22588,7 +22669,7 @@
                     <a:p>
                       <a:pPr algn="l"/>
                       <a:r>
-                        <a:rPr lang="en-US" sz="1200" b="1" dirty="0">
+                        <a:rPr lang="en-US" sz="1120" b="1" dirty="0">
                           <a:solidFill>
                             <a:srgbClr val="1E2227"/>
                           </a:solidFill>
@@ -22625,7 +22706,7 @@
                     <a:p>
                       <a:pPr algn="l"/>
                       <a:r>
-                        <a:rPr lang="ko-KR" sz="1200" b="0" dirty="0">
+                        <a:rPr lang="ko-KR" sz="1120" b="0" dirty="0">
                           <a:solidFill>
                             <a:srgbClr val="1E2227"/>
                           </a:solidFill>
@@ -22649,7 +22730,7 @@
                     <a:p>
                       <a:pPr algn="l"/>
                       <a:r>
-                        <a:rPr lang="ko-KR" altLang="en-US" sz="1200" b="0" dirty="0" err="1">
+                        <a:rPr lang="ko-KR" altLang="en-US" sz="1120" b="0" dirty="0" err="1">
                           <a:solidFill>
                             <a:srgbClr val="1E2227"/>
                           </a:solidFill>
@@ -22659,7 +22740,7 @@
                         <a:t>net EM = 0이어도 값이 크면 </a:t>
                       </a:r>
                       <a:r>
-                        <a:rPr lang="ko-KR" altLang="en-US" sz="1200" b="1" dirty="0" err="1">
+                        <a:rPr lang="ko-KR" altLang="en-US" sz="1120" b="1" dirty="0" err="1">
                           <a:solidFill>
                             <a:srgbClr val="1E2227"/>
                           </a:solidFill>
@@ -22716,6 +22797,46 @@
           <a:p>
             <a:pPr algn="l"/>
             <a:r>
+              <a:rPr lang="en-US" altLang="ko-KR" sz="1300" b="1" dirty="0">
+                <a:solidFill>
+                  <a:srgbClr val="273A52"/>
+                </a:solidFill>
+                <a:latin typeface="맑은 고딕"/>
+                <a:ea typeface="맑은 고딕"/>
+              </a:rPr>
+              <a:t>[</a:t>
+            </a:r>
+            <a:r>
+              <a:rPr lang="ko-KR" altLang="en-US" sz="1300" b="1" dirty="0">
+                <a:solidFill>
+                  <a:srgbClr val="273A52"/>
+                </a:solidFill>
+                <a:latin typeface="맑은 고딕"/>
+                <a:ea typeface="맑은 고딕"/>
+              </a:rPr>
+              <a:t>예시</a:t>
+            </a:r>
+            <a:r>
+              <a:rPr lang="en-US" altLang="ko-KR" sz="1300" b="1" dirty="0">
+                <a:solidFill>
+                  <a:srgbClr val="273A52"/>
+                </a:solidFill>
+                <a:latin typeface="맑은 고딕"/>
+                <a:ea typeface="맑은 고딕"/>
+              </a:rPr>
+              <a:t>] </a:t>
+            </a:r>
+            <a:r>
+              <a:rPr lang="ko-KR" altLang="en-US" sz="1300" b="1" dirty="0">
+                <a:solidFill>
+                  <a:srgbClr val="273A52"/>
+                </a:solidFill>
+                <a:latin typeface="맑은 고딕"/>
+                <a:ea typeface="맑은 고딕"/>
+              </a:rPr>
+              <a:t>전환 행렬</a:t>
+            </a:r>
+            <a:r>
               <a:rPr lang="ko-KR" sz="1300" b="1" dirty="0">
                 <a:solidFill>
                   <a:srgbClr val="273A52"/>
@@ -22723,8 +22844,25 @@
                 <a:latin typeface="맑은 고딕"/>
                 <a:ea typeface="맑은 고딕"/>
               </a:rPr>
-              <a:t>경로 이동 예시 — 완화 전(행) → 후(열) · 숫자는 예시</a:t>
-            </a:r>
+              <a:t> </a:t>
+            </a:r>
+            <a:r>
+              <a:rPr lang="ko-KR" altLang="en-US" sz="1300" b="1" dirty="0">
+                <a:solidFill>
+                  <a:srgbClr val="273A52"/>
+                </a:solidFill>
+                <a:latin typeface="맑은 고딕"/>
+                <a:ea typeface="맑은 고딕"/>
+              </a:rPr>
+              <a:t>구하기</a:t>
+            </a:r>
+            <a:endParaRPr lang="ko-KR" sz="1300" b="1" dirty="0">
+              <a:solidFill>
+                <a:srgbClr val="273A52"/>
+              </a:solidFill>
+              <a:latin typeface="맑은 고딕"/>
+              <a:ea typeface="맑은 고딕"/>
+            </a:endParaRPr>
           </a:p>
         </p:txBody>
       </p:sp>
@@ -23135,23 +23273,24 @@
                     </a:p>
                   </a:txBody>
                   <a:tcPr marL="45720" marR="45720" marT="27432" marB="27432" anchor="ctr">
-                    <a:lnL w="9525" cap="flat" cmpd="sng" algn="ctr">
+                    <a:lnL w="28575" cap="flat" cmpd="sng" algn="ctr">
                       <a:noFill/>
                       <a:prstDash val="solid"/>
                     </a:lnL>
-                    <a:lnR w="9525" cap="flat" cmpd="sng" algn="ctr">
+                    <a:lnR w="28575" cap="flat" cmpd="sng" algn="ctr">
+                      <a:solidFill>
+                        <a:srgbClr val="6D28D9"/>
+                      </a:solidFill>
+                      <a:prstDash val="solid"/>
+                    </a:lnR>
+                    <a:lnT w="28575" cap="flat" cmpd="sng" algn="ctr">
                       <a:noFill/>
                       <a:prstDash val="solid"/>
-                    </a:lnR>
-                    <a:lnT w="12700" cap="flat" cmpd="sng" algn="ctr">
-                      <a:noFill/>
-                      <a:prstDash val="solid"/>
-                      <a:round/>
-                      <a:headEnd type="none" w="med" len="med"/>
-                      <a:tailEnd type="none" w="med" len="med"/>
                     </a:lnT>
-                    <a:lnB w="9525" cap="flat" cmpd="sng" algn="ctr">
-                      <a:noFill/>
+                    <a:lnB w="28575" cap="flat" cmpd="sng" algn="ctr">
+                      <a:solidFill>
+                        <a:srgbClr val="6D28D9"/>
+                      </a:solidFill>
                       <a:prstDash val="solid"/>
                     </a:lnB>
                     <a:lnTlToBr w="12700" cmpd="sng">
@@ -23186,9 +23325,14 @@
                     </a:p>
                   </a:txBody>
                   <a:tcPr marL="45720" marR="45720" marT="27432" marB="27432" anchor="ctr">
-                    <a:lnL w="9525" cap="flat" cmpd="sng" algn="ctr">
-                      <a:noFill/>
+                    <a:lnL w="28575" cap="flat" cmpd="sng" algn="ctr">
+                      <a:solidFill>
+                        <a:srgbClr val="6D28D9"/>
+                      </a:solidFill>
                       <a:prstDash val="solid"/>
+                      <a:round/>
+                      <a:headEnd type="none" w="med" len="med"/>
+                      <a:tailEnd type="none" w="med" len="med"/>
                     </a:lnL>
                     <a:lnR w="9525" cap="flat" cmpd="sng" algn="ctr">
                       <a:noFill/>
@@ -23292,20 +23436,24 @@
                     </a:p>
                   </a:txBody>
                   <a:tcPr marL="45720" marR="45720" marT="27432" marB="27432" anchor="ctr">
-                    <a:lnL w="9525" cap="flat" cmpd="sng" algn="ctr">
+                    <a:lnL w="28575" cap="flat" cmpd="sng" algn="ctr">
                       <a:noFill/>
                       <a:prstDash val="solid"/>
                     </a:lnL>
-                    <a:lnR w="9525" cap="flat" cmpd="sng" algn="ctr">
-                      <a:noFill/>
+                    <a:lnR w="28575" cap="flat" cmpd="sng" algn="ctr">
+                      <a:solidFill>
+                        <a:srgbClr val="6D28D9"/>
+                      </a:solidFill>
                       <a:prstDash val="solid"/>
                     </a:lnR>
-                    <a:lnT w="9525" cap="flat" cmpd="sng" algn="ctr">
+                    <a:lnT w="28575" cap="flat" cmpd="sng" algn="ctr">
                       <a:noFill/>
                       <a:prstDash val="solid"/>
                     </a:lnT>
-                    <a:lnB w="9525" cap="flat" cmpd="sng" algn="ctr">
-                      <a:noFill/>
+                    <a:lnB w="28575" cap="flat" cmpd="sng" algn="ctr">
+                      <a:solidFill>
+                        <a:srgbClr val="6D28D9"/>
+                      </a:solidFill>
                       <a:prstDash val="solid"/>
                     </a:lnB>
                     <a:lnTlToBr w="12700" cmpd="sng">
@@ -23340,17 +23488,27 @@
                     </a:p>
                   </a:txBody>
                   <a:tcPr marL="45720" marR="45720" marT="27432" marB="27432" anchor="ctr">
-                    <a:lnL w="9525" cap="flat" cmpd="sng" algn="ctr">
-                      <a:noFill/>
+                    <a:lnL w="28575" cap="flat" cmpd="sng" algn="ctr">
+                      <a:solidFill>
+                        <a:srgbClr val="6D28D9"/>
+                      </a:solidFill>
                       <a:prstDash val="solid"/>
+                      <a:round/>
+                      <a:headEnd type="none" w="med" len="med"/>
+                      <a:tailEnd type="none" w="med" len="med"/>
                     </a:lnL>
                     <a:lnR w="9525" cap="flat" cmpd="sng" algn="ctr">
                       <a:noFill/>
                       <a:prstDash val="solid"/>
                     </a:lnR>
-                    <a:lnT w="9525" cap="flat" cmpd="sng" algn="ctr">
-                      <a:noFill/>
+                    <a:lnT w="28575" cap="flat" cmpd="sng" algn="ctr">
+                      <a:solidFill>
+                        <a:srgbClr val="6D28D9"/>
+                      </a:solidFill>
                       <a:prstDash val="solid"/>
+                      <a:round/>
+                      <a:headEnd type="none" w="med" len="med"/>
+                      <a:tailEnd type="none" w="med" len="med"/>
                     </a:lnT>
                     <a:lnB w="9525" cap="flat" cmpd="sng" algn="ctr">
                       <a:noFill/>
@@ -23499,9 +23657,14 @@
                       <a:noFill/>
                       <a:prstDash val="solid"/>
                     </a:lnR>
-                    <a:lnT w="9525" cap="flat" cmpd="sng" algn="ctr">
-                      <a:noFill/>
+                    <a:lnT w="28575" cap="flat" cmpd="sng" algn="ctr">
+                      <a:solidFill>
+                        <a:srgbClr val="6D28D9"/>
+                      </a:solidFill>
                       <a:prstDash val="solid"/>
+                      <a:round/>
+                      <a:headEnd type="none" w="med" len="med"/>
+                      <a:tailEnd type="none" w="med" len="med"/>
                     </a:lnT>
                     <a:lnB w="9525" cap="flat" cmpd="sng" algn="ctr">
                       <a:noFill/>
@@ -23751,7 +23914,7 @@
             <a:r>
               <a:rPr lang="en-US" sz="1080" b="1" dirty="0">
                 <a:solidFill>
-                  <a:srgbClr val="273A52"/>
+                  <a:srgbClr val="6D28D9"/>
                 </a:solidFill>
                 <a:latin typeface="맑은 고딕"/>
                 <a:ea typeface="맑은 고딕"/>
@@ -23766,7 +23929,7 @@
                 <a:latin typeface="맑은 고딕"/>
                 <a:ea typeface="맑은 고딕"/>
               </a:rPr>
-              <a:t>  정답↔오답 역전이 잦음 = 이득이 불안정·취약</a:t>
+              <a:t>  정답↔오답 역전(보라 테두리 칸)이 잦음 = 이득이 불안정·취약</a:t>
             </a:r>
           </a:p>
           <a:p>
@@ -23821,13 +23984,13 @@
         </p:spPr>
         <p:txBody>
           <a:bodyPr wrap="square" lIns="0" tIns="0" rIns="0" bIns="0">
-            <a:normAutofit/>
+            <a:normAutofit fontScale="92500"/>
           </a:bodyPr>
           <a:lstStyle/>
           <a:p>
             <a:pPr algn="l"/>
             <a:r>
-              <a:rPr lang="ko-KR" sz="1100" b="1" dirty="0">
+              <a:rPr lang="ko-KR" sz="1150" b="1" dirty="0">
                 <a:solidFill>
                   <a:srgbClr val="273A52"/>
                 </a:solidFill>
@@ -23837,17 +24000,27 @@
               <a:t>구하는 법 — 케이스별 전환 행렬마다 산출</a:t>
             </a:r>
             <a:r>
-              <a:rPr lang="ko-KR" sz="1000" b="0" dirty="0">
+              <a:rPr lang="ko-KR" sz="1150" b="0" dirty="0">
                 <a:solidFill>
                   <a:srgbClr val="6B7480"/>
                 </a:solidFill>
                 <a:latin typeface="맑은 고딕"/>
                 <a:ea typeface="맑은 고딕"/>
               </a:rPr>
-              <a:t>      L 정상 · W 오답 · A 기권,  </a:t>
-            </a:r>
-            <a:r>
-              <a:rPr lang="en-US" sz="1000" b="0" dirty="0">
+              <a:t>      </a:t>
+            </a:r>
+            <a:r>
+              <a:rPr lang="ko-KR" sz="1100" b="0" dirty="0">
+                <a:solidFill>
+                  <a:srgbClr val="6B7480"/>
+                </a:solidFill>
+                <a:latin typeface="맑은 고딕"/>
+                <a:ea typeface="맑은 고딕"/>
+              </a:rPr>
+              <a:t>L 정상 · W 오답 · A 기권,  </a:t>
+            </a:r>
+            <a:r>
+              <a:rPr lang="en-US" sz="1100" b="0" dirty="0">
                 <a:solidFill>
                   <a:srgbClr val="6B7480"/>
                 </a:solidFill>
@@ -23857,7 +24030,7 @@
               <a:t>n(i→j)</a:t>
             </a:r>
             <a:r>
-              <a:rPr lang="ko-KR" sz="1000" b="0" dirty="0">
+              <a:rPr lang="ko-KR" sz="1100" b="0" dirty="0">
                 <a:solidFill>
                   <a:srgbClr val="6B7480"/>
                 </a:solidFill>
@@ -23867,7 +24040,7 @@
               <a:t> = 전→후 칸 수,  </a:t>
             </a:r>
             <a:r>
-              <a:rPr lang="en-US" sz="1000" b="0" dirty="0">
+              <a:rPr lang="en-US" sz="1100" b="0" dirty="0">
                 <a:solidFill>
                   <a:srgbClr val="6B7480"/>
                 </a:solidFill>
@@ -23877,7 +24050,7 @@
               <a:t>N</a:t>
             </a:r>
             <a:r>
-              <a:rPr lang="ko-KR" sz="1000" b="0" dirty="0">
+              <a:rPr lang="ko-KR" sz="1100" b="0" dirty="0">
                 <a:solidFill>
                   <a:srgbClr val="6B7480"/>
                 </a:solidFill>
@@ -23897,7 +24070,7 @@
               </a:spcBef>
             </a:pPr>
             <a:r>
-              <a:rPr lang="ko-KR" sz="1000" b="1" dirty="0">
+              <a:rPr lang="ko-KR" sz="1100" b="1" dirty="0">
                 <a:solidFill>
                   <a:srgbClr val="1E7A6F"/>
                 </a:solidFill>
@@ -23907,7 +24080,7 @@
               <a:t>LGR</a:t>
             </a:r>
             <a:r>
-              <a:rPr lang="en-US" sz="1000" b="0" dirty="0">
+              <a:rPr lang="en-US" sz="1100" b="0" dirty="0">
                 <a:solidFill>
                   <a:srgbClr val="1E2227"/>
                 </a:solidFill>
@@ -23917,7 +24090,7 @@
               <a:t> = n(W→L) / ( n(W→L) + n(A→L) ) </a:t>
             </a:r>
             <a:r>
-              <a:rPr lang="en-US" sz="1000" b="0" dirty="0">
+              <a:rPr lang="en-US" sz="1100" b="0" dirty="0">
                 <a:solidFill>
                   <a:srgbClr val="6B7480"/>
                 </a:solidFill>
@@ -23927,7 +24100,7 @@
               <a:t>= 10/12 ≈ 0.83</a:t>
             </a:r>
             <a:r>
-              <a:rPr lang="ko-KR" sz="1000" b="0" dirty="0">
+              <a:rPr lang="ko-KR" sz="1100" b="0" dirty="0">
                 <a:solidFill>
                   <a:srgbClr val="6B7480"/>
                 </a:solidFill>
@@ -23937,7 +24110,7 @@
               <a:t>        ·        </a:t>
             </a:r>
             <a:r>
-              <a:rPr lang="ko-KR" sz="1000" b="1" dirty="0">
+              <a:rPr lang="ko-KR" sz="1100" b="1" dirty="0">
                 <a:solidFill>
                   <a:srgbClr val="C2410C"/>
                 </a:solidFill>
@@ -23947,7 +24120,7 @@
               <a:t>HR</a:t>
             </a:r>
             <a:r>
-              <a:rPr lang="en-US" sz="1000" b="0" dirty="0">
+              <a:rPr lang="en-US" sz="1100" b="0" dirty="0">
                 <a:solidFill>
                   <a:srgbClr val="1E2227"/>
                 </a:solidFill>
@@ -23957,7 +24130,7 @@
               <a:t> = ( n(L→W) + n(L→A) ) / Σn(L→j) </a:t>
             </a:r>
             <a:r>
-              <a:rPr lang="en-US" sz="1000" b="0" dirty="0">
+              <a:rPr lang="en-US" sz="1100" b="0" dirty="0">
                 <a:solidFill>
                   <a:srgbClr val="6B7480"/>
                 </a:solidFill>
@@ -23967,7 +24140,7 @@
               <a:t>= 5/43 ≈ 0.12</a:t>
             </a:r>
             <a:r>
-              <a:rPr lang="ko-KR" sz="1000" b="0" dirty="0">
+              <a:rPr lang="ko-KR" sz="1100" b="0" dirty="0">
                 <a:solidFill>
                   <a:srgbClr val="6B7480"/>
                 </a:solidFill>
@@ -23977,7 +24150,7 @@
               <a:t>        ·        </a:t>
             </a:r>
             <a:r>
-              <a:rPr lang="ko-KR" sz="1000" b="1" dirty="0">
+              <a:rPr lang="ko-KR" sz="1100" b="1" dirty="0">
                 <a:solidFill>
                   <a:srgbClr val="273A52"/>
                 </a:solidFill>
@@ -23987,7 +24160,7 @@
               <a:t>Flip</a:t>
             </a:r>
             <a:r>
-              <a:rPr lang="en-US" sz="1000" b="0" dirty="0">
+              <a:rPr lang="en-US" sz="1100" b="0" dirty="0">
                 <a:solidFill>
                   <a:srgbClr val="1E2227"/>
                 </a:solidFill>
@@ -23997,7 +24170,7 @@
               <a:t> = ( n(L→W) + n(W→L) ) / N </a:t>
             </a:r>
             <a:r>
-              <a:rPr lang="en-US" sz="1000" b="0" dirty="0">
+              <a:rPr lang="en-US" sz="1100" b="0" dirty="0">
                 <a:solidFill>
                   <a:srgbClr val="6B7480"/>
                 </a:solidFill>
@@ -24012,7 +24185,7 @@
     </p:spTree>
     <p:extLst>
       <p:ext uri="{BB962C8B-B14F-4D97-AF65-F5344CB8AC3E}">
-        <p14:creationId xmlns:p14="http://schemas.microsoft.com/office/powerpoint/2010/main" val="3659113317"/>
+        <p14:creationId xmlns:p14="http://schemas.microsoft.com/office/powerpoint/2010/main" val="62558462"/>
       </p:ext>
     </p:extLst>
   </p:cSld>
@@ -24336,7 +24509,7 @@
         <p:spPr>
           <a:xfrm>
             <a:off x="548640" y="3632200"/>
-            <a:ext cx="11091672" cy="2616200"/>
+            <a:ext cx="11091672" cy="2566924"/>
           </a:xfrm>
           <a:prstGeom prst="rect">
             <a:avLst/>
@@ -24397,16 +24570,36 @@
               <a:buChar char="•"/>
             </a:pPr>
             <a:r>
-              <a:rPr lang="ko-KR" sz="1200" b="1" dirty="0">
-                <a:solidFill>
-                  <a:srgbClr val="1E2227"/>
-                </a:solidFill>
-                <a:latin typeface="맑은 고딕"/>
-                <a:ea typeface="맑은 고딕"/>
-              </a:rPr>
-              <a:t>대조 1 (충돌 순효과). </a:t>
-            </a:r>
-            <a:endParaRPr lang="en-US" altLang="ko-KR" sz="1200" b="1" dirty="0">
+              <a:rPr lang="ko-KR" sz="1120" b="1" dirty="0">
+                <a:solidFill>
+                  <a:srgbClr val="1E2227"/>
+                </a:solidFill>
+                <a:latin typeface="맑은 고딕"/>
+                <a:ea typeface="맑은 고딕"/>
+              </a:rPr>
+              <a:t>대조 1 (충돌 </a:t>
+            </a:r>
+            <a:r>
+              <a:rPr lang="ko-KR" sz="1120" b="1" dirty="0" err="1">
+                <a:solidFill>
+                  <a:srgbClr val="1E2227"/>
+                </a:solidFill>
+                <a:latin typeface="맑은 고딕"/>
+                <a:ea typeface="맑은 고딕"/>
+              </a:rPr>
+              <a:t>순효과</a:t>
+            </a:r>
+            <a:r>
+              <a:rPr lang="ko-KR" sz="1120" b="1" dirty="0">
+                <a:solidFill>
+                  <a:srgbClr val="1E2227"/>
+                </a:solidFill>
+                <a:latin typeface="맑은 고딕"/>
+                <a:ea typeface="맑은 고딕"/>
+              </a:rPr>
+              <a:t>)</a:t>
+            </a:r>
+            <a:endParaRPr lang="en-US" altLang="ko-KR" sz="1120" b="1" dirty="0">
               <a:solidFill>
                 <a:srgbClr val="1E2227"/>
               </a:solidFill>
@@ -24426,7 +24619,7 @@
               <a:buChar char="•"/>
             </a:pPr>
             <a:r>
-              <a:rPr lang="ko-KR" sz="1200" b="0" dirty="0">
+              <a:rPr lang="ko-KR" sz="1120" b="0" dirty="0">
                 <a:solidFill>
                   <a:srgbClr val="1E2227"/>
                 </a:solidFill>
@@ -24436,7 +24629,7 @@
               <a:t>ⓐ vs ⓑ를 같은 문항에서 짝지어 대조 — 충돌만 켜고 끈다. 충돌 버전만 나빠지면 → </a:t>
             </a:r>
             <a:r>
-              <a:rPr lang="ko-KR" sz="1200" b="1" dirty="0">
+              <a:rPr lang="ko-KR" sz="1120" b="1" dirty="0">
                 <a:solidFill>
                   <a:srgbClr val="1E2227"/>
                 </a:solidFill>
@@ -24446,7 +24639,7 @@
               <a:t>충돌 고유의 실패(RQ3)</a:t>
             </a:r>
             <a:r>
-              <a:rPr lang="ko-KR" sz="1200" b="0" dirty="0">
+              <a:rPr lang="ko-KR" sz="1120" b="0" dirty="0">
                 <a:solidFill>
                   <a:srgbClr val="1E2227"/>
                 </a:solidFill>
@@ -24455,7 +24648,7 @@
               </a:rPr>
               <a:t>, 차이 없으면 난이도·문서 수 부수효과다.</a:t>
             </a:r>
-            <a:endParaRPr lang="en-US" altLang="ko-KR" sz="1200" b="0" dirty="0">
+            <a:endParaRPr lang="en-US" altLang="ko-KR" sz="1120" b="0" dirty="0">
               <a:solidFill>
                 <a:srgbClr val="1E2227"/>
               </a:solidFill>
@@ -24475,16 +24668,16 @@
               <a:buChar char="•"/>
             </a:pPr>
             <a:r>
-              <a:rPr lang="ko-KR" sz="1200" b="1" dirty="0">
-                <a:solidFill>
-                  <a:srgbClr val="1E2227"/>
-                </a:solidFill>
-                <a:latin typeface="맑은 고딕"/>
-                <a:ea typeface="맑은 고딕"/>
-              </a:rPr>
-              <a:t>대조 2 (타당성 점검). </a:t>
-            </a:r>
-            <a:endParaRPr lang="en-US" altLang="ko-KR" sz="1200" b="1" dirty="0">
+              <a:rPr lang="ko-KR" sz="1120" b="1" dirty="0">
+                <a:solidFill>
+                  <a:srgbClr val="1E2227"/>
+                </a:solidFill>
+                <a:latin typeface="맑은 고딕"/>
+                <a:ea typeface="맑은 고딕"/>
+              </a:rPr>
+              <a:t>대조 2 (타당성 점검) </a:t>
+            </a:r>
+            <a:endParaRPr lang="en-US" altLang="ko-KR" sz="1120" b="1" dirty="0">
               <a:solidFill>
                 <a:srgbClr val="1E2227"/>
               </a:solidFill>
@@ -24504,7 +24697,7 @@
               <a:buChar char="•"/>
             </a:pPr>
             <a:r>
-              <a:rPr lang="ko-KR" sz="1200" b="1" dirty="0">
+              <a:rPr lang="ko-KR" sz="1120" b="1" dirty="0">
                 <a:solidFill>
                   <a:srgbClr val="1E2227"/>
                 </a:solidFill>
@@ -24514,7 +24707,7 @@
               <a:t>ⓑ(인공 교체)</a:t>
             </a:r>
             <a:r>
-              <a:rPr lang="ko-KR" sz="1200" b="0" dirty="0">
+              <a:rPr lang="ko-KR" sz="1120" b="0" dirty="0">
                 <a:solidFill>
                   <a:srgbClr val="1E2227"/>
                 </a:solidFill>
@@ -24524,7 +24717,7 @@
               <a:t> 결과가 </a:t>
             </a:r>
             <a:r>
-              <a:rPr lang="ko-KR" sz="1200" b="1" dirty="0">
+              <a:rPr lang="ko-KR" sz="1120" b="1" dirty="0">
                 <a:solidFill>
                   <a:srgbClr val="1E2227"/>
                 </a:solidFill>
@@ -24534,7 +24727,7 @@
               <a:t>ⓒ 분포에 근접하는지</a:t>
             </a:r>
             <a:r>
-              <a:rPr lang="ko-KR" sz="1200" b="0" dirty="0">
+              <a:rPr lang="ko-KR" sz="1120" b="0" dirty="0">
                 <a:solidFill>
                   <a:srgbClr val="1E2227"/>
                 </a:solidFill>
@@ -24544,7 +24737,7 @@
               <a:t> 확인 — 난이도·문서 수 공변량 보정 후, </a:t>
             </a:r>
             <a:r>
-              <a:rPr lang="ko-KR" sz="1200" b="1" dirty="0">
+              <a:rPr lang="ko-KR" sz="1120" b="1" dirty="0">
                 <a:solidFill>
                   <a:srgbClr val="1E2227"/>
                 </a:solidFill>
@@ -24554,7 +24747,7 @@
               <a:t>동등성 검정(TOST · 사전 등록 마진)</a:t>
             </a:r>
             <a:r>
-              <a:rPr lang="ko-KR" sz="1200" b="0" dirty="0">
+              <a:rPr lang="ko-KR" sz="1120" b="0" dirty="0">
                 <a:solidFill>
                   <a:srgbClr val="1E2227"/>
                 </a:solidFill>
@@ -24563,7 +24756,7 @@
               </a:rPr>
               <a:t>으로 판정한다. </a:t>
             </a:r>
-            <a:endParaRPr lang="en-US" altLang="ko-KR" sz="1200" b="0" dirty="0">
+            <a:endParaRPr lang="en-US" altLang="ko-KR" sz="1120" b="0" dirty="0">
               <a:solidFill>
                 <a:srgbClr val="1E2227"/>
               </a:solidFill>
@@ -24583,7 +24776,7 @@
               <a:buChar char="•"/>
             </a:pPr>
             <a:r>
-              <a:rPr lang="ko-KR" sz="1200" b="0" dirty="0">
+              <a:rPr lang="ko-KR" sz="1120" b="0" dirty="0">
                 <a:solidFill>
                   <a:srgbClr val="1E2227"/>
                 </a:solidFill>
@@ -24605,7 +24798,7 @@
               <a:buChar char="•"/>
             </a:pPr>
             <a:r>
-              <a:rPr lang="ko-KR" sz="1200" b="1" dirty="0">
+              <a:rPr lang="ko-KR" sz="1120" b="1" dirty="0">
                 <a:solidFill>
                   <a:srgbClr val="1E2227"/>
                 </a:solidFill>
@@ -24615,7 +24808,7 @@
               <a:t>부정 대조 ⓑ′.</a:t>
             </a:r>
             <a:r>
-              <a:rPr lang="ko-KR" sz="1200" b="0" dirty="0">
+              <a:rPr lang="ko-KR" sz="1120" b="0" dirty="0">
                 <a:solidFill>
                   <a:srgbClr val="1E2227"/>
                 </a:solidFill>
@@ -24625,7 +24818,7 @@
               <a:t> 같은 문항에서 </a:t>
             </a:r>
             <a:r>
-              <a:rPr lang="ko-KR" sz="1200" b="1" dirty="0">
+              <a:rPr lang="ko-KR" sz="1120" b="1" dirty="0">
                 <a:solidFill>
                   <a:srgbClr val="1E2227"/>
                 </a:solidFill>
@@ -24635,7 +24828,7 @@
               <a:t>충돌과 무관한 청크만</a:t>
             </a:r>
             <a:r>
-              <a:rPr lang="ko-KR" sz="1200" b="0" dirty="0">
+              <a:rPr lang="ko-KR" sz="1120" b="0" dirty="0">
                 <a:solidFill>
                   <a:srgbClr val="1E2227"/>
                 </a:solidFill>
@@ -24657,16 +24850,16 @@
               <a:buChar char="•"/>
             </a:pPr>
             <a:r>
-              <a:rPr lang="ko-KR" sz="1200" b="1" dirty="0">
-                <a:solidFill>
-                  <a:srgbClr val="1E2227"/>
-                </a:solidFill>
-                <a:latin typeface="맑은 고딕"/>
-                <a:ea typeface="맑은 고딕"/>
-              </a:rPr>
-              <a:t>지표.</a:t>
-            </a:r>
-            <a:endParaRPr lang="en-US" altLang="ko-KR" sz="1200" b="1" dirty="0">
+              <a:rPr lang="ko-KR" sz="1120" b="1" dirty="0">
+                <a:solidFill>
+                  <a:srgbClr val="1E2227"/>
+                </a:solidFill>
+                <a:latin typeface="맑은 고딕"/>
+                <a:ea typeface="맑은 고딕"/>
+              </a:rPr>
+              <a:t>지표</a:t>
+            </a:r>
+            <a:endParaRPr lang="en-US" altLang="ko-KR" sz="1120" b="1" dirty="0">
               <a:solidFill>
                 <a:srgbClr val="1E2227"/>
               </a:solidFill>
@@ -24686,7 +24879,7 @@
               <a:buChar char="•"/>
             </a:pPr>
             <a:r>
-              <a:rPr lang="ko-KR" sz="1200" b="0" dirty="0">
+              <a:rPr lang="ko-KR" sz="1120" b="0" dirty="0">
                 <a:solidFill>
                   <a:srgbClr val="1E2227"/>
                 </a:solidFill>
@@ -24696,7 +24889,7 @@
               <a:t>주지표는 정답률(정확도). 충돌의 순 벌점을 </a:t>
             </a:r>
             <a:r>
-              <a:rPr lang="en-US" sz="1200" b="0" dirty="0">
+              <a:rPr lang="en-US" sz="1120" b="0" dirty="0">
                 <a:solidFill>
                   <a:srgbClr val="1E2227"/>
                 </a:solidFill>
@@ -24705,7 +24898,7 @@
               <a:t>Δ = Acc(</a:t>
             </a:r>
             <a:r>
-              <a:rPr lang="ko-KR" sz="1200" b="0" dirty="0">
+              <a:rPr lang="ko-KR" sz="1120" b="0" dirty="0">
                 <a:solidFill>
                   <a:srgbClr val="1E2227"/>
                 </a:solidFill>
@@ -24715,7 +24908,7 @@
               <a:t>ⓑ</a:t>
             </a:r>
             <a:r>
-              <a:rPr lang="en-US" sz="1200" b="0" dirty="0">
+              <a:rPr lang="en-US" sz="1120" b="0" dirty="0">
                 <a:solidFill>
                   <a:srgbClr val="1E2227"/>
                 </a:solidFill>
@@ -24724,7 +24917,7 @@
               <a:t>) − Acc(</a:t>
             </a:r>
             <a:r>
-              <a:rPr lang="ko-KR" sz="1200" b="0" dirty="0">
+              <a:rPr lang="ko-KR" sz="1120" b="0" dirty="0">
                 <a:solidFill>
                   <a:srgbClr val="1E2227"/>
                 </a:solidFill>
@@ -24734,7 +24927,7 @@
               <a:t>ⓐ</a:t>
             </a:r>
             <a:r>
-              <a:rPr lang="en-US" sz="1200" b="0" dirty="0">
+              <a:rPr lang="en-US" sz="1120" b="0" dirty="0">
                 <a:solidFill>
                   <a:srgbClr val="1E2227"/>
                 </a:solidFill>
@@ -24743,7 +24936,7 @@
               <a:t>)</a:t>
             </a:r>
             <a:r>
-              <a:rPr lang="ko-KR" sz="1200" b="0" dirty="0">
+              <a:rPr lang="ko-KR" sz="1120" b="0" dirty="0">
                 <a:solidFill>
                   <a:srgbClr val="1E2227"/>
                 </a:solidFill>
@@ -24753,7 +24946,7 @@
               <a:t> 로 정의해 </a:t>
             </a:r>
             <a:r>
-              <a:rPr lang="ko-KR" sz="1200" b="1" dirty="0">
+              <a:rPr lang="ko-KR" sz="1120" b="1" dirty="0">
                 <a:solidFill>
                   <a:srgbClr val="1E2227"/>
                 </a:solidFill>
@@ -24763,7 +24956,7 @@
               <a:t>문항 짝 대응으로 검정</a:t>
             </a:r>
             <a:r>
-              <a:rPr lang="ko-KR" sz="1200" b="0" dirty="0">
+              <a:rPr lang="ko-KR" sz="1120" b="0" dirty="0">
                 <a:solidFill>
                   <a:srgbClr val="1E2227"/>
                 </a:solidFill>
@@ -24773,7 +24966,7 @@
               <a:t>하고, 표본이 얇은 구간은 </a:t>
             </a:r>
             <a:r>
-              <a:rPr lang="ko-KR" sz="1200" b="1" dirty="0">
+              <a:rPr lang="ko-KR" sz="1120" b="1" dirty="0">
                 <a:solidFill>
                   <a:srgbClr val="1E2227"/>
                 </a:solidFill>
@@ -24783,7 +24976,7 @@
               <a:t>자기일관성(182건)</a:t>
             </a:r>
             <a:r>
-              <a:rPr lang="ko-KR" sz="1200" b="0" dirty="0">
+              <a:rPr lang="ko-KR" sz="1120" b="0" dirty="0">
                 <a:solidFill>
                   <a:srgbClr val="1E2227"/>
                 </a:solidFill>
@@ -24851,7 +25044,7 @@
               </a:spcAft>
             </a:pPr>
             <a:r>
-              <a:rPr lang="ko-KR" sz="1350" b="1" dirty="0">
+              <a:rPr lang="ko-KR" sz="1200" b="1" dirty="0">
                 <a:solidFill>
                   <a:srgbClr val="273A52"/>
                 </a:solidFill>
@@ -24871,7 +25064,7 @@
               </a:spcAft>
             </a:pPr>
             <a:r>
-              <a:rPr lang="ko-KR" sz="1100" b="1" dirty="0">
+              <a:rPr lang="ko-KR" sz="1120" b="1" dirty="0">
                 <a:solidFill>
                   <a:srgbClr val="273A52"/>
                 </a:solidFill>
@@ -24893,7 +25086,7 @@
               <a:buChar char="•"/>
             </a:pPr>
             <a:r>
-              <a:rPr lang="ko-KR" sz="1100" b="1" dirty="0" err="1">
+              <a:rPr lang="ko-KR" sz="1120" b="1" dirty="0" err="1">
                 <a:solidFill>
                   <a:srgbClr val="1E2227"/>
                 </a:solidFill>
@@ -24903,7 +25096,7 @@
               <a:t>DRAGged</a:t>
             </a:r>
             <a:r>
-              <a:rPr lang="ko-KR" sz="1100" b="0" dirty="0">
+              <a:rPr lang="ko-KR" sz="1120" b="0" dirty="0">
                 <a:solidFill>
                   <a:srgbClr val="1E2227"/>
                 </a:solidFill>
@@ -24912,7 +25105,7 @@
               </a:rPr>
               <a:t>  자연 충돌 182건</a:t>
             </a:r>
-            <a:endParaRPr lang="en-US" altLang="ko-KR" sz="1100" b="0" dirty="0">
+            <a:endParaRPr lang="en-US" altLang="ko-KR" sz="1120" b="0" dirty="0">
               <a:solidFill>
                 <a:srgbClr val="1E2227"/>
               </a:solidFill>
@@ -24932,7 +25125,7 @@
               <a:buChar char="•"/>
             </a:pPr>
             <a:r>
-              <a:rPr lang="ko-KR" sz="1100" b="1" dirty="0">
+              <a:rPr lang="ko-KR" sz="1120" b="1" dirty="0">
                 <a:solidFill>
                   <a:srgbClr val="1E2227"/>
                 </a:solidFill>
@@ -24942,7 +25135,7 @@
               <a:t>QACC</a:t>
             </a:r>
             <a:r>
-              <a:rPr lang="ko-KR" sz="1100" b="0" dirty="0">
+              <a:rPr lang="ko-KR" sz="1120" b="0" dirty="0">
                 <a:solidFill>
                   <a:srgbClr val="1E2227"/>
                 </a:solidFill>
@@ -24951,7 +25144,7 @@
               </a:rPr>
               <a:t>  충돌 ≈ 404건 (25%)</a:t>
             </a:r>
-            <a:endParaRPr lang="en-US" altLang="ko-KR" sz="1100" b="0" dirty="0">
+            <a:endParaRPr lang="en-US" altLang="ko-KR" sz="1120" b="0" dirty="0">
               <a:solidFill>
                 <a:srgbClr val="1E2227"/>
               </a:solidFill>
@@ -24971,7 +25164,7 @@
               <a:buChar char="•"/>
             </a:pPr>
             <a:r>
-              <a:rPr lang="ko-KR" sz="1100" b="1" dirty="0" err="1">
+              <a:rPr lang="ko-KR" sz="1120" b="1" dirty="0" err="1">
                 <a:solidFill>
                   <a:srgbClr val="1E2227"/>
                 </a:solidFill>
@@ -24981,7 +25174,7 @@
               <a:t>RAMDocs</a:t>
             </a:r>
             <a:r>
-              <a:rPr lang="ko-KR" sz="1100" b="0" dirty="0">
+              <a:rPr lang="ko-KR" sz="1120" b="0" dirty="0">
                 <a:solidFill>
                   <a:srgbClr val="1E2227"/>
                 </a:solidFill>
@@ -25004,7 +25197,7 @@
               </a:spcAft>
             </a:pPr>
             <a:r>
-              <a:rPr lang="ko-KR" sz="1100" b="1" dirty="0">
+              <a:rPr lang="ko-KR" sz="1120" b="1" dirty="0">
                 <a:solidFill>
                   <a:srgbClr val="273A52"/>
                 </a:solidFill>
@@ -25014,7 +25207,7 @@
               <a:t>역할  </a:t>
             </a:r>
             <a:r>
-              <a:rPr lang="ko-KR" sz="1100" b="0" dirty="0">
+              <a:rPr lang="ko-KR" sz="1120" b="0" dirty="0">
                 <a:solidFill>
                   <a:srgbClr val="1E2227"/>
                 </a:solidFill>
@@ -25082,6 +25275,16 @@
               </a:spcAft>
             </a:pPr>
             <a:r>
+              <a:rPr lang="ko-KR" sz="1200" b="1" dirty="0">
+                <a:solidFill>
+                  <a:srgbClr val="273A52"/>
+                </a:solidFill>
+                <a:latin typeface="맑은 고딕"/>
+                <a:ea typeface="맑은 고딕"/>
+              </a:rPr>
+              <a:t>ⓑ  충돌만 제거 (같은 문항</a:t>
+            </a:r>
+            <a:r>
               <a:rPr lang="ko-KR" sz="1350" b="1" dirty="0">
                 <a:solidFill>
                   <a:srgbClr val="273A52"/>
@@ -25089,7 +25292,7 @@
                 <a:latin typeface="맑은 고딕"/>
                 <a:ea typeface="맑은 고딕"/>
               </a:rPr>
-              <a:t>ⓑ  충돌만 제거 (같은 문항)</a:t>
+              <a:t>)</a:t>
             </a:r>
           </a:p>
           <a:p>
@@ -25102,7 +25305,7 @@
               </a:spcAft>
             </a:pPr>
             <a:r>
-              <a:rPr lang="ko-KR" sz="1100" b="1" dirty="0">
+              <a:rPr lang="ko-KR" sz="1120" b="1" dirty="0">
                 <a:solidFill>
                   <a:srgbClr val="273A52"/>
                 </a:solidFill>
@@ -25124,7 +25327,7 @@
               <a:buChar char="•"/>
             </a:pPr>
             <a:r>
-              <a:rPr lang="ko-KR" sz="1100" b="0" dirty="0">
+              <a:rPr lang="ko-KR" sz="1120" b="0" dirty="0">
                 <a:solidFill>
                   <a:srgbClr val="1E2227"/>
                 </a:solidFill>
@@ -25134,7 +25337,7 @@
               <a:t>ⓐ와 동일 문항에서 충돌 청크·오정보만 </a:t>
             </a:r>
             <a:r>
-              <a:rPr lang="ko-KR" sz="1100" b="0" dirty="0" err="1">
+              <a:rPr lang="ko-KR" sz="1120" b="0" dirty="0" err="1">
                 <a:solidFill>
                   <a:srgbClr val="1E2227"/>
                 </a:solidFill>
@@ -25144,7 +25347,7 @@
               <a:t>noise로</a:t>
             </a:r>
             <a:r>
-              <a:rPr lang="ko-KR" sz="1100" b="0" dirty="0">
+              <a:rPr lang="ko-KR" sz="1120" b="0" dirty="0">
                 <a:solidFill>
                   <a:srgbClr val="1E2227"/>
                 </a:solidFill>
@@ -25153,7 +25356,7 @@
               </a:rPr>
               <a:t> 교체</a:t>
             </a:r>
-            <a:endParaRPr lang="en-US" altLang="ko-KR" sz="1100" b="0" dirty="0">
+            <a:endParaRPr lang="en-US" altLang="ko-KR" sz="1120" b="0" dirty="0">
               <a:solidFill>
                 <a:srgbClr val="1E2227"/>
               </a:solidFill>
@@ -25173,7 +25376,7 @@
               <a:buChar char="•"/>
             </a:pPr>
             <a:r>
-              <a:rPr lang="ko-KR" sz="1100" b="0" dirty="0">
+              <a:rPr lang="ko-KR" sz="1120" b="0" dirty="0">
                 <a:solidFill>
                   <a:srgbClr val="1E2227"/>
                 </a:solidFill>
@@ -25196,7 +25399,7 @@
               </a:spcAft>
             </a:pPr>
             <a:r>
-              <a:rPr lang="ko-KR" sz="1100" b="1" dirty="0">
+              <a:rPr lang="ko-KR" sz="1120" b="1" dirty="0">
                 <a:solidFill>
                   <a:srgbClr val="273A52"/>
                 </a:solidFill>
@@ -25206,7 +25409,7 @@
               <a:t>역할  </a:t>
             </a:r>
             <a:r>
-              <a:rPr lang="ko-KR" sz="1100" b="0" dirty="0">
+              <a:rPr lang="ko-KR" sz="1120" b="0" dirty="0">
                 <a:solidFill>
                   <a:srgbClr val="1E2227"/>
                 </a:solidFill>
@@ -25274,7 +25477,7 @@
               </a:spcAft>
             </a:pPr>
             <a:r>
-              <a:rPr lang="ko-KR" sz="1350" b="1" dirty="0">
+              <a:rPr lang="ko-KR" sz="1200" b="1" dirty="0">
                 <a:solidFill>
                   <a:srgbClr val="273A52"/>
                 </a:solidFill>
@@ -25294,7 +25497,7 @@
               </a:spcAft>
             </a:pPr>
             <a:r>
-              <a:rPr lang="ko-KR" sz="1100" b="1" dirty="0">
+              <a:rPr lang="ko-KR" sz="1120" b="1" dirty="0">
                 <a:solidFill>
                   <a:srgbClr val="273A52"/>
                 </a:solidFill>
@@ -25303,7 +25506,7 @@
               </a:rPr>
               <a:t>출처</a:t>
             </a:r>
-            <a:endParaRPr lang="en-US" altLang="ko-KR" sz="1100" b="1" dirty="0">
+            <a:endParaRPr lang="en-US" altLang="ko-KR" sz="1120" b="1" dirty="0">
               <a:solidFill>
                 <a:srgbClr val="273A52"/>
               </a:solidFill>
@@ -25323,7 +25526,7 @@
               <a:buChar char="•"/>
             </a:pPr>
             <a:r>
-              <a:rPr lang="ko-KR" sz="1100" b="1" dirty="0" err="1">
+              <a:rPr lang="ko-KR" sz="1120" b="1" dirty="0" err="1">
                 <a:solidFill>
                   <a:srgbClr val="1E2227"/>
                 </a:solidFill>
@@ -25333,7 +25536,7 @@
               <a:t>DRAGged</a:t>
             </a:r>
             <a:r>
-              <a:rPr lang="ko-KR" sz="1100" b="0" dirty="0">
+              <a:rPr lang="ko-KR" sz="1120" b="0" dirty="0">
                 <a:solidFill>
                   <a:srgbClr val="1E2227"/>
                 </a:solidFill>
@@ -25342,7 +25545,7 @@
               </a:rPr>
               <a:t>  무충돌 276건</a:t>
             </a:r>
-            <a:endParaRPr lang="en-US" altLang="ko-KR" sz="1100" b="0" dirty="0">
+            <a:endParaRPr lang="en-US" altLang="ko-KR" sz="1120" b="0" dirty="0">
               <a:solidFill>
                 <a:srgbClr val="1E2227"/>
               </a:solidFill>
@@ -25362,7 +25565,7 @@
               <a:buChar char="•"/>
             </a:pPr>
             <a:r>
-              <a:rPr lang="ko-KR" sz="1100" b="1" dirty="0">
+              <a:rPr lang="ko-KR" sz="1120" b="1" dirty="0">
                 <a:solidFill>
                   <a:srgbClr val="1E2227"/>
                 </a:solidFill>
@@ -25372,7 +25575,7 @@
               <a:t>QACC</a:t>
             </a:r>
             <a:r>
-              <a:rPr lang="ko-KR" sz="1100" b="0" dirty="0">
+              <a:rPr lang="ko-KR" sz="1120" b="0" dirty="0">
                 <a:solidFill>
                   <a:srgbClr val="1E2227"/>
                 </a:solidFill>
@@ -25395,7 +25598,7 @@
               </a:spcAft>
             </a:pPr>
             <a:r>
-              <a:rPr lang="ko-KR" sz="1100" b="1" dirty="0">
+              <a:rPr lang="ko-KR" sz="1120" b="1" dirty="0">
                 <a:solidFill>
                   <a:srgbClr val="273A52"/>
                 </a:solidFill>
@@ -25405,7 +25608,7 @@
               <a:t>역할  </a:t>
             </a:r>
             <a:r>
-              <a:rPr lang="ko-KR" sz="1100" b="0" dirty="0">
+              <a:rPr lang="ko-KR" sz="1120" b="0" dirty="0">
                 <a:solidFill>
                   <a:srgbClr val="1E2227"/>
                 </a:solidFill>

</xml_diff>

<commit_message>
feat(schema): normalize dates to ISO and fill supported_answer for all datasets
</commit_message>
<xml_diff>
--- a/docs/ThinkConflict_연구보고.pptx
+++ b/docs/ThinkConflict_연구보고.pptx
@@ -26,10 +26,10 @@
     <p:sldId id="676" r:id="rId17"/>
     <p:sldId id="684" r:id="rId18"/>
     <p:sldId id="595" r:id="rId19"/>
-    <p:sldId id="644" r:id="rId20"/>
-    <p:sldId id="685" r:id="rId21"/>
-    <p:sldId id="646" r:id="rId22"/>
-    <p:sldId id="648" r:id="rId23"/>
+    <p:sldId id="686" r:id="rId20"/>
+    <p:sldId id="687" r:id="rId21"/>
+    <p:sldId id="698" r:id="rId22"/>
+    <p:sldId id="695" r:id="rId23"/>
     <p:sldId id="440" r:id="rId24"/>
     <p:sldId id="441" r:id="rId25"/>
     <p:sldId id="443" r:id="rId26"/>
@@ -920,6 +920,90 @@
 </file>
 
 <file path=ppt/notesSlides/notesSlide6.xml><?xml version="1.0" encoding="utf-8"?>
+<p:notes xmlns:a="http://schemas.openxmlformats.org/drawingml/2006/main" xmlns:r="http://schemas.openxmlformats.org/officeDocument/2006/relationships" xmlns:p="http://schemas.openxmlformats.org/presentationml/2006/main">
+  <p:cSld>
+    <p:spTree>
+      <p:nvGrpSpPr>
+        <p:cNvPr id="1" name=""/>
+        <p:cNvGrpSpPr/>
+        <p:nvPr/>
+      </p:nvGrpSpPr>
+      <p:grpSpPr>
+        <a:xfrm>
+          <a:off x="0" y="0"/>
+          <a:ext cx="0" cy="0"/>
+          <a:chOff x="0" y="0"/>
+          <a:chExt cx="0" cy="0"/>
+        </a:xfrm>
+      </p:grpSpPr>
+      <p:sp>
+        <p:nvSpPr>
+          <p:cNvPr id="2" name="슬라이드 이미지 개체 틀 1"/>
+          <p:cNvSpPr>
+            <a:spLocks noGrp="1" noRot="1" noChangeAspect="1"/>
+          </p:cNvSpPr>
+          <p:nvPr>
+            <p:ph type="sldImg"/>
+          </p:nvPr>
+        </p:nvSpPr>
+        <p:spPr/>
+      </p:sp>
+      <p:sp>
+        <p:nvSpPr>
+          <p:cNvPr id="3" name="슬라이드 노트 개체 틀 2"/>
+          <p:cNvSpPr>
+            <a:spLocks noGrp="1"/>
+          </p:cNvSpPr>
+          <p:nvPr>
+            <p:ph type="body" idx="1"/>
+          </p:nvPr>
+        </p:nvSpPr>
+        <p:spPr/>
+        <p:txBody>
+          <a:bodyPr/>
+          <a:lstStyle/>
+          <a:p>
+            <a:endParaRPr kumimoji="1" lang="ko-KR" altLang="en-US" dirty="0"/>
+          </a:p>
+        </p:txBody>
+      </p:sp>
+      <p:sp>
+        <p:nvSpPr>
+          <p:cNvPr id="4" name="슬라이드 번호 개체 틀 3"/>
+          <p:cNvSpPr>
+            <a:spLocks noGrp="1"/>
+          </p:cNvSpPr>
+          <p:nvPr>
+            <p:ph type="sldNum" sz="quarter" idx="5"/>
+          </p:nvPr>
+        </p:nvSpPr>
+        <p:spPr/>
+        <p:txBody>
+          <a:bodyPr/>
+          <a:lstStyle/>
+          <a:p>
+            <a:fld id="{79492483-278F-4C46-B567-3E1E49742A91}" type="slidenum">
+              <a:rPr kumimoji="1" lang="ko-KR" altLang="en-US" smtClean="0"/>
+              <a:t>20</a:t>
+            </a:fld>
+            <a:endParaRPr kumimoji="1" lang="ko-KR" altLang="en-US"/>
+          </a:p>
+        </p:txBody>
+      </p:sp>
+    </p:spTree>
+    <p:extLst>
+      <p:ext uri="{BB962C8B-B14F-4D97-AF65-F5344CB8AC3E}">
+        <p14:creationId xmlns:p14="http://schemas.microsoft.com/office/powerpoint/2010/main" val="2926750138"/>
+      </p:ext>
+    </p:extLst>
+  </p:cSld>
+  <p:clrMapOvr>
+    <a:masterClrMapping/>
+  </p:clrMapOvr>
+</p:notes>
+</file>
+
+<file path=ppt/notesSlides/notesSlide7.xml><?xml version="1.0" encoding="utf-8"?>
 <p:notes xmlns:a="http://schemas.openxmlformats.org/drawingml/2006/main" xmlns:r="http://schemas.openxmlformats.org/officeDocument/2006/relationships" xmlns:p="http://schemas.openxmlformats.org/presentationml/2006/main">
   <p:cSld>
     <p:spTree>
@@ -19058,14 +19142,14 @@
           <p:nvPr>
             <p:extLst>
               <p:ext uri="{D42A27DB-BD31-4B8C-83A1-F6EECF244321}">
-                <p14:modId xmlns:p14="http://schemas.microsoft.com/office/powerpoint/2010/main" val="1402298283"/>
+                <p14:modId xmlns:p14="http://schemas.microsoft.com/office/powerpoint/2010/main" val="1679383214"/>
               </p:ext>
             </p:extLst>
           </p:nvPr>
         </p:nvGraphicFramePr>
         <p:xfrm>
           <a:off x="548640" y="1600200"/>
-          <a:ext cx="11091672" cy="3487422"/>
+          <a:ext cx="11091672" cy="3653536"/>
         </p:xfrm>
         <a:graphic>
           <a:graphicData uri="http://schemas.openxmlformats.org/drawingml/2006/table">
@@ -19110,7 +19194,7 @@
                   </a:extLst>
                 </a:gridCol>
               </a:tblGrid>
-              <a:tr h="449137">
+              <a:tr h="468801">
                 <a:tc>
                   <a:txBody>
                     <a:bodyPr/>
@@ -19299,7 +19383,7 @@
                   </a:ext>
                 </a:extLst>
               </a:tr>
-              <a:tr h="607657">
+              <a:tr h="634261">
                 <a:tc>
                   <a:txBody>
                     <a:bodyPr/>
@@ -19521,7 +19605,7 @@
                   </a:ext>
                 </a:extLst>
               </a:tr>
-              <a:tr h="607657">
+              <a:tr h="634261">
                 <a:tc>
                   <a:txBody>
                     <a:bodyPr/>
@@ -19763,7 +19847,7 @@
                   </a:ext>
                 </a:extLst>
               </a:tr>
-              <a:tr h="607657">
+              <a:tr h="647691">
                 <a:tc>
                   <a:txBody>
                     <a:bodyPr/>
@@ -19891,6 +19975,16 @@
                         </a:spcAft>
                       </a:pPr>
                       <a:r>
+                        <a:rPr sz="1120" b="0" dirty="0">
+                          <a:solidFill>
+                            <a:srgbClr val="1E2227"/>
+                          </a:solidFill>
+                          <a:latin typeface="맑은 고딕"/>
+                          <a:ea typeface="맑은 고딕"/>
+                        </a:rPr>
+                        <a:t>충돌 시 여러 경로의 </a:t>
+                      </a:r>
+                      <a:r>
                         <a:rPr sz="1120" b="1" dirty="0">
                           <a:solidFill>
                             <a:srgbClr val="1E2227"/>
@@ -19898,7 +19992,7 @@
                           <a:latin typeface="맑은 고딕"/>
                           <a:ea typeface="맑은 고딕"/>
                         </a:rPr>
-                        <a:t>문서 간 충돌 자체를 겨냥</a:t>
+                        <a:t>로짓 차이를 최대화</a:t>
                       </a:r>
                       <a:r>
                         <a:rPr sz="1120" b="0" dirty="0">
@@ -19908,7 +20002,7 @@
                           <a:latin typeface="맑은 고딕"/>
                           <a:ea typeface="맑은 고딕"/>
                         </a:rPr>
-                        <a:t>한 대비 디코딩으로, 본 연구의 </a:t>
+                        <a:t>해 정답 쪽 </a:t>
                       </a:r>
                       <a:r>
                         <a:rPr sz="1120" b="1" dirty="0">
@@ -19918,7 +20012,47 @@
                           <a:latin typeface="맑은 고딕"/>
                           <a:ea typeface="맑은 고딕"/>
                         </a:rPr>
-                        <a:t>4경로 진단과 직접 맞물린다</a:t>
+                        <a:t>확신을 재보정</a:t>
+                      </a:r>
+                      <a:r>
+                        <a:rPr sz="1120" b="0" dirty="0">
+                          <a:solidFill>
+                            <a:srgbClr val="1E2227"/>
+                          </a:solidFill>
+                          <a:latin typeface="맑은 고딕"/>
+                          <a:ea typeface="맑은 고딕"/>
+                        </a:rPr>
+                        <a:t>하는 대비 디코딩(Conflict-Disentangle CD). CAD의 ‘문맥 유무’ 대비와 달리 </a:t>
+                      </a:r>
+                      <a:r>
+                        <a:rPr sz="1120" b="1" dirty="0">
+                          <a:solidFill>
+                            <a:srgbClr val="1E2227"/>
+                          </a:solidFill>
+                          <a:latin typeface="맑은 고딕"/>
+                          <a:ea typeface="맑은 고딕"/>
+                        </a:rPr>
+                        <a:t>충돌 자체를 분리·겨냥</a:t>
+                      </a:r>
+                      <a:r>
+                        <a:rPr sz="1120" b="0" dirty="0">
+                          <a:solidFill>
+                            <a:srgbClr val="1E2227"/>
+                          </a:solidFill>
+                          <a:latin typeface="맑은 고딕"/>
+                          <a:ea typeface="맑은 고딕"/>
+                        </a:rPr>
+                        <a:t>하므로, 본 연구의 </a:t>
+                      </a:r>
+                      <a:r>
+                        <a:rPr sz="1120" b="1" dirty="0">
+                          <a:solidFill>
+                            <a:srgbClr val="1E2227"/>
+                          </a:solidFill>
+                          <a:latin typeface="맑은 고딕"/>
+                          <a:ea typeface="맑은 고딕"/>
+                        </a:rPr>
+                        <a:t>4경로 진단(해소 L2)과 직접 맞물린다</a:t>
                       </a:r>
                       <a:r>
                         <a:rPr sz="1120" b="0" dirty="0">
@@ -19975,7 +20109,7 @@
                   </a:ext>
                 </a:extLst>
               </a:tr>
-              <a:tr h="607657">
+              <a:tr h="634261">
                 <a:tc>
                   <a:txBody>
                     <a:bodyPr/>
@@ -20227,7 +20361,7 @@
                   </a:ext>
                 </a:extLst>
               </a:tr>
-              <a:tr h="607657">
+              <a:tr h="634261">
                 <a:tc>
                   <a:txBody>
                     <a:bodyPr/>
@@ -20461,8 +20595,8 @@
         </p:nvSpPr>
         <p:spPr>
           <a:xfrm>
-            <a:off x="546100" y="5215128"/>
-            <a:ext cx="11091672" cy="1143000"/>
+            <a:off x="546100" y="5324856"/>
+            <a:ext cx="11091672" cy="1022096"/>
           </a:xfrm>
           <a:prstGeom prst="rect">
             <a:avLst/>
@@ -20762,7 +20896,7 @@
     </p:spTree>
     <p:extLst>
       <p:ext uri="{BB962C8B-B14F-4D97-AF65-F5344CB8AC3E}">
-        <p14:creationId xmlns:p14="http://schemas.microsoft.com/office/powerpoint/2010/main" val="783618228"/>
+        <p14:creationId xmlns:p14="http://schemas.microsoft.com/office/powerpoint/2010/main" val="2078279056"/>
       </p:ext>
     </p:extLst>
   </p:cSld>
@@ -22230,7 +22364,7 @@
         <p:spPr>
           <a:xfrm>
             <a:off x="548640" y="1270000"/>
-            <a:ext cx="11091672" cy="301236"/>
+            <a:ext cx="11091672" cy="285143"/>
           </a:xfrm>
           <a:prstGeom prst="rect">
             <a:avLst/>
@@ -22249,7 +22383,7 @@
               </a:lnSpc>
             </a:pPr>
             <a:r>
-              <a:rPr lang="ko-KR" sz="1300" b="1" dirty="0">
+              <a:rPr lang="ko-KR" sz="1200" b="1" dirty="0">
                 <a:solidFill>
                   <a:srgbClr val="273A52"/>
                 </a:solidFill>
@@ -22797,7 +22931,7 @@
           <a:p>
             <a:pPr algn="l"/>
             <a:r>
-              <a:rPr lang="en-US" altLang="ko-KR" sz="1300" b="1" dirty="0">
+              <a:rPr lang="en-US" altLang="ko-KR" sz="1200" b="1" dirty="0">
                 <a:solidFill>
                   <a:srgbClr val="273A52"/>
                 </a:solidFill>
@@ -22807,7 +22941,7 @@
               <a:t>[</a:t>
             </a:r>
             <a:r>
-              <a:rPr lang="ko-KR" altLang="en-US" sz="1300" b="1" dirty="0">
+              <a:rPr lang="ko-KR" altLang="en-US" sz="1200" b="1" dirty="0">
                 <a:solidFill>
                   <a:srgbClr val="273A52"/>
                 </a:solidFill>
@@ -22817,7 +22951,7 @@
               <a:t>예시</a:t>
             </a:r>
             <a:r>
-              <a:rPr lang="en-US" altLang="ko-KR" sz="1300" b="1" dirty="0">
+              <a:rPr lang="en-US" altLang="ko-KR" sz="1200" b="1" dirty="0">
                 <a:solidFill>
                   <a:srgbClr val="273A52"/>
                 </a:solidFill>
@@ -22827,7 +22961,7 @@
               <a:t>] </a:t>
             </a:r>
             <a:r>
-              <a:rPr lang="ko-KR" altLang="en-US" sz="1300" b="1" dirty="0">
+              <a:rPr lang="ko-KR" altLang="en-US" sz="1200" b="1" dirty="0">
                 <a:solidFill>
                   <a:srgbClr val="273A52"/>
                 </a:solidFill>
@@ -22837,7 +22971,7 @@
               <a:t>전환 행렬</a:t>
             </a:r>
             <a:r>
-              <a:rPr lang="ko-KR" sz="1300" b="1" dirty="0">
+              <a:rPr lang="ko-KR" sz="1200" b="1" dirty="0">
                 <a:solidFill>
                   <a:srgbClr val="273A52"/>
                 </a:solidFill>
@@ -22847,7 +22981,7 @@
               <a:t> </a:t>
             </a:r>
             <a:r>
-              <a:rPr lang="ko-KR" altLang="en-US" sz="1300" b="1" dirty="0">
+              <a:rPr lang="ko-KR" altLang="en-US" sz="1200" b="1" dirty="0">
                 <a:solidFill>
                   <a:srgbClr val="273A52"/>
                 </a:solidFill>
@@ -22856,7 +22990,7 @@
               </a:rPr>
               <a:t>구하기</a:t>
             </a:r>
-            <a:endParaRPr lang="ko-KR" sz="1300" b="1" dirty="0">
+            <a:endParaRPr lang="ko-KR" sz="1200" b="1" dirty="0">
               <a:solidFill>
                 <a:srgbClr val="273A52"/>
               </a:solidFill>
@@ -22878,7 +23012,13 @@
           <p:cNvGraphicFramePr>
             <a:graphicFrameLocks noGrp="1"/>
           </p:cNvGraphicFramePr>
-          <p:nvPr/>
+          <p:nvPr>
+            <p:extLst>
+              <p:ext uri="{D42A27DB-BD31-4B8C-83A1-F6EECF244321}">
+                <p14:modId xmlns:p14="http://schemas.microsoft.com/office/powerpoint/2010/main" val="1721765617"/>
+              </p:ext>
+            </p:extLst>
+          </p:nvPr>
         </p:nvGraphicFramePr>
         <p:xfrm>
           <a:off x="548640" y="4253200"/>
@@ -23261,9 +23401,9 @@
                     <a:p>
                       <a:pPr algn="ctr"/>
                       <a:r>
-                        <a:rPr lang="ko-KR" altLang="en-US" sz="1150" b="0" dirty="0">
-                          <a:solidFill>
-                            <a:srgbClr val="1E2227"/>
+                        <a:rPr lang="ko-KR" altLang="en-US" sz="1150" b="1" dirty="0">
+                          <a:solidFill>
+                            <a:srgbClr val="6D28D9"/>
                           </a:solidFill>
                           <a:latin typeface="맑은 고딕"/>
                           <a:ea typeface="맑은 고딕"/>
@@ -23273,26 +23413,12 @@
                     </a:p>
                   </a:txBody>
                   <a:tcPr marL="45720" marR="45720" marT="27432" marB="27432" anchor="ctr">
-                    <a:lnL w="28575" cap="flat" cmpd="sng" algn="ctr">
+                    <a:lnL>
                       <a:noFill/>
-                      <a:prstDash val="solid"/>
                     </a:lnL>
-                    <a:lnR w="28575" cap="flat" cmpd="sng" algn="ctr">
-                      <a:solidFill>
-                        <a:srgbClr val="6D28D9"/>
-                      </a:solidFill>
-                      <a:prstDash val="solid"/>
-                    </a:lnR>
-                    <a:lnT w="28575" cap="flat" cmpd="sng" algn="ctr">
+                    <a:lnT>
                       <a:noFill/>
-                      <a:prstDash val="solid"/>
                     </a:lnT>
-                    <a:lnB w="28575" cap="flat" cmpd="sng" algn="ctr">
-                      <a:solidFill>
-                        <a:srgbClr val="6D28D9"/>
-                      </a:solidFill>
-                      <a:prstDash val="solid"/>
-                    </a:lnB>
                     <a:lnTlToBr w="12700" cmpd="sng">
                       <a:noFill/>
                       <a:prstDash val="solid"/>
@@ -23325,15 +23451,6 @@
                     </a:p>
                   </a:txBody>
                   <a:tcPr marL="45720" marR="45720" marT="27432" marB="27432" anchor="ctr">
-                    <a:lnL w="28575" cap="flat" cmpd="sng" algn="ctr">
-                      <a:solidFill>
-                        <a:srgbClr val="6D28D9"/>
-                      </a:solidFill>
-                      <a:prstDash val="solid"/>
-                      <a:round/>
-                      <a:headEnd type="none" w="med" len="med"/>
-                      <a:tailEnd type="none" w="med" len="med"/>
-                    </a:lnL>
                     <a:lnR w="9525" cap="flat" cmpd="sng" algn="ctr">
                       <a:noFill/>
                       <a:prstDash val="solid"/>
@@ -23424,9 +23541,9 @@
                     <a:p>
                       <a:pPr algn="ctr"/>
                       <a:r>
-                        <a:rPr lang="ko-KR" altLang="en-US" sz="1150" b="0">
-                          <a:solidFill>
-                            <a:srgbClr val="1E2227"/>
+                        <a:rPr lang="ko-KR" altLang="en-US" sz="1150" b="1" dirty="0">
+                          <a:solidFill>
+                            <a:srgbClr val="6D28D9"/>
                           </a:solidFill>
                           <a:latin typeface="맑은 고딕"/>
                           <a:ea typeface="맑은 고딕"/>
@@ -23436,26 +23553,12 @@
                     </a:p>
                   </a:txBody>
                   <a:tcPr marL="45720" marR="45720" marT="27432" marB="27432" anchor="ctr">
-                    <a:lnL w="28575" cap="flat" cmpd="sng" algn="ctr">
+                    <a:lnL>
                       <a:noFill/>
-                      <a:prstDash val="solid"/>
                     </a:lnL>
-                    <a:lnR w="28575" cap="flat" cmpd="sng" algn="ctr">
-                      <a:solidFill>
-                        <a:srgbClr val="6D28D9"/>
-                      </a:solidFill>
-                      <a:prstDash val="solid"/>
-                    </a:lnR>
-                    <a:lnT w="28575" cap="flat" cmpd="sng" algn="ctr">
+                    <a:lnT>
                       <a:noFill/>
-                      <a:prstDash val="solid"/>
                     </a:lnT>
-                    <a:lnB w="28575" cap="flat" cmpd="sng" algn="ctr">
-                      <a:solidFill>
-                        <a:srgbClr val="6D28D9"/>
-                      </a:solidFill>
-                      <a:prstDash val="solid"/>
-                    </a:lnB>
                     <a:lnTlToBr w="12700" cmpd="sng">
                       <a:noFill/>
                       <a:prstDash val="solid"/>
@@ -23488,28 +23591,10 @@
                     </a:p>
                   </a:txBody>
                   <a:tcPr marL="45720" marR="45720" marT="27432" marB="27432" anchor="ctr">
-                    <a:lnL w="28575" cap="flat" cmpd="sng" algn="ctr">
-                      <a:solidFill>
-                        <a:srgbClr val="6D28D9"/>
-                      </a:solidFill>
-                      <a:prstDash val="solid"/>
-                      <a:round/>
-                      <a:headEnd type="none" w="med" len="med"/>
-                      <a:tailEnd type="none" w="med" len="med"/>
-                    </a:lnL>
                     <a:lnR w="9525" cap="flat" cmpd="sng" algn="ctr">
                       <a:noFill/>
                       <a:prstDash val="solid"/>
                     </a:lnR>
-                    <a:lnT w="28575" cap="flat" cmpd="sng" algn="ctr">
-                      <a:solidFill>
-                        <a:srgbClr val="6D28D9"/>
-                      </a:solidFill>
-                      <a:prstDash val="solid"/>
-                      <a:round/>
-                      <a:headEnd type="none" w="med" len="med"/>
-                      <a:tailEnd type="none" w="med" len="med"/>
-                    </a:lnT>
                     <a:lnB w="9525" cap="flat" cmpd="sng" algn="ctr">
                       <a:noFill/>
                       <a:prstDash val="solid"/>
@@ -23657,15 +23742,6 @@
                       <a:noFill/>
                       <a:prstDash val="solid"/>
                     </a:lnR>
-                    <a:lnT w="28575" cap="flat" cmpd="sng" algn="ctr">
-                      <a:solidFill>
-                        <a:srgbClr val="6D28D9"/>
-                      </a:solidFill>
-                      <a:prstDash val="solid"/>
-                      <a:round/>
-                      <a:headEnd type="none" w="med" len="med"/>
-                      <a:tailEnd type="none" w="med" len="med"/>
-                    </a:lnT>
                     <a:lnB w="9525" cap="flat" cmpd="sng" algn="ctr">
                       <a:noFill/>
                       <a:prstDash val="solid"/>
@@ -23929,7 +24005,7 @@
                 <a:latin typeface="맑은 고딕"/>
                 <a:ea typeface="맑은 고딕"/>
               </a:rPr>
-              <a:t>  정답↔오답 역전(보라 테두리 칸)이 잦음 = 이득이 불안정·취약</a:t>
+              <a:t>  정답↔오답 역전(보라 숫자 칸)이 잦음 = 이득이 불안정·취약</a:t>
             </a:r>
           </a:p>
           <a:p>
@@ -24185,7 +24261,7 @@
     </p:spTree>
     <p:extLst>
       <p:ext uri="{BB962C8B-B14F-4D97-AF65-F5344CB8AC3E}">
-        <p14:creationId xmlns:p14="http://schemas.microsoft.com/office/powerpoint/2010/main" val="62558462"/>
+        <p14:creationId xmlns:p14="http://schemas.microsoft.com/office/powerpoint/2010/main" val="2607014197"/>
       </p:ext>
     </p:extLst>
   </p:cSld>
@@ -24509,7 +24585,7 @@
         <p:spPr>
           <a:xfrm>
             <a:off x="548640" y="3632200"/>
-            <a:ext cx="11091672" cy="2566924"/>
+            <a:ext cx="11091672" cy="2667508"/>
           </a:xfrm>
           <a:prstGeom prst="rect">
             <a:avLst/>
@@ -24704,7 +24780,7 @@
                 <a:latin typeface="맑은 고딕"/>
                 <a:ea typeface="맑은 고딕"/>
               </a:rPr>
-              <a:t>ⓑ(인공 교체)</a:t>
+              <a:t>현실성 점검(ⓑ↔ⓒ): </a:t>
             </a:r>
             <a:r>
               <a:rPr lang="ko-KR" sz="1120" b="0" dirty="0">
@@ -24714,7 +24790,7 @@
                 <a:latin typeface="맑은 고딕"/>
                 <a:ea typeface="맑은 고딕"/>
               </a:rPr>
-              <a:t> 결과가 </a:t>
+              <a:t>충돌 없앤 ⓑ의 정답률이 자연 무충돌 ⓒ 수준으로 돌아오는지, 난이도·문서 수 보정 후 </a:t>
             </a:r>
             <a:r>
               <a:rPr lang="ko-KR" sz="1120" b="1" dirty="0">
@@ -24724,7 +24800,7 @@
                 <a:latin typeface="맑은 고딕"/>
                 <a:ea typeface="맑은 고딕"/>
               </a:rPr>
-              <a:t>ⓒ 분포에 근접하는지</a:t>
+              <a:t>동등성 검정(TOST)</a:t>
             </a:r>
             <a:r>
               <a:rPr lang="ko-KR" sz="1120" b="0" dirty="0">
@@ -24734,7 +24810,7 @@
                 <a:latin typeface="맑은 고딕"/>
                 <a:ea typeface="맑은 고딕"/>
               </a:rPr>
-              <a:t> 확인 — 난이도·문서 수 공변량 보정 후, </a:t>
+              <a:t>으로 판정</a:t>
             </a:r>
             <a:r>
               <a:rPr lang="ko-KR" sz="1120" b="1" dirty="0">
@@ -24744,7 +24820,66 @@
                 <a:latin typeface="맑은 고딕"/>
                 <a:ea typeface="맑은 고딕"/>
               </a:rPr>
-              <a:t>동등성 검정(TOST · 사전 등록 마진)</a:t>
+              <a:t>.</a:t>
+            </a:r>
+            <a:r>
+              <a:rPr lang="en-US" altLang="ko-KR" sz="1120" b="1" dirty="0">
+                <a:solidFill>
+                  <a:srgbClr val="1E2227"/>
+                </a:solidFill>
+                <a:latin typeface="맑은 고딕"/>
+                <a:ea typeface="맑은 고딕"/>
+              </a:rPr>
+              <a:t> </a:t>
+            </a:r>
+            <a:br>
+              <a:rPr lang="en-US" altLang="ko-KR" sz="1120" b="1" dirty="0">
+                <a:solidFill>
+                  <a:srgbClr val="1E2227"/>
+                </a:solidFill>
+                <a:latin typeface="맑은 고딕"/>
+                <a:ea typeface="맑은 고딕"/>
+              </a:rPr>
+            </a:br>
+            <a:r>
+              <a:rPr lang="en-US" altLang="ko-KR" sz="1120" dirty="0">
+                <a:solidFill>
+                  <a:srgbClr val="1E2227"/>
+                </a:solidFill>
+                <a:latin typeface="맑은 고딕"/>
+                <a:ea typeface="맑은 고딕"/>
+              </a:rPr>
+              <a:t>(</a:t>
+            </a:r>
+            <a:r>
+              <a:rPr lang="ko-KR" sz="1120" dirty="0">
+                <a:solidFill>
+                  <a:srgbClr val="1E2227"/>
+                </a:solidFill>
+                <a:latin typeface="맑은 고딕"/>
+                <a:ea typeface="맑은 고딕"/>
+              </a:rPr>
+              <a:t>ⓒ</a:t>
+            </a:r>
+            <a:r>
+              <a:rPr lang="ko-KR" altLang="en-US" sz="1120" dirty="0">
+                <a:solidFill>
+                  <a:srgbClr val="1E2227"/>
+                </a:solidFill>
+                <a:latin typeface="맑은 고딕"/>
+                <a:ea typeface="맑은 고딕"/>
+              </a:rPr>
+              <a:t>는</a:t>
+            </a:r>
+            <a:r>
+              <a:rPr lang="ko-KR" sz="1120" b="1" dirty="0">
+                <a:solidFill>
+                  <a:srgbClr val="1E2227"/>
+                </a:solidFill>
+                <a:latin typeface="맑은 고딕"/>
+                <a:ea typeface="맑은 고딕"/>
+              </a:rPr>
+              <a:t> </a:t>
             </a:r>
             <a:r>
               <a:rPr lang="ko-KR" sz="1120" b="0" dirty="0">
@@ -24754,9 +24889,19 @@
                 <a:latin typeface="맑은 고딕"/>
                 <a:ea typeface="맑은 고딕"/>
               </a:rPr>
-              <a:t>으로 판정한다. </a:t>
-            </a:r>
-            <a:endParaRPr lang="en-US" altLang="ko-KR" sz="1120" b="0" dirty="0">
+              <a:t>목표 점수가 아니라, 우리 세팅이 현실적인지 보는 참고용.</a:t>
+            </a:r>
+            <a:r>
+              <a:rPr lang="en-US" altLang="ko-KR" sz="1120" b="0" dirty="0">
+                <a:solidFill>
+                  <a:srgbClr val="1E2227"/>
+                </a:solidFill>
+                <a:latin typeface="맑은 고딕"/>
+                <a:ea typeface="맑은 고딕"/>
+              </a:rPr>
+              <a:t>)</a:t>
+            </a:r>
+            <a:endParaRPr lang="ko-KR" sz="1120" b="0" dirty="0">
               <a:solidFill>
                 <a:srgbClr val="1E2227"/>
               </a:solidFill>
@@ -24776,6 +24921,16 @@
               <a:buChar char="•"/>
             </a:pPr>
             <a:r>
+              <a:rPr lang="ko-KR" sz="1120" b="1" dirty="0">
+                <a:solidFill>
+                  <a:srgbClr val="1E2227"/>
+                </a:solidFill>
+                <a:latin typeface="맑은 고딕"/>
+                <a:ea typeface="맑은 고딕"/>
+              </a:rPr>
+              <a:t>부작용 차단(ⓑ′): </a:t>
+            </a:r>
+            <a:r>
               <a:rPr lang="ko-KR" sz="1120" b="0" dirty="0">
                 <a:solidFill>
                   <a:srgbClr val="1E2227"/>
@@ -24783,7 +24938,65 @@
                 <a:latin typeface="맑은 고딕"/>
                 <a:ea typeface="맑은 고딕"/>
               </a:rPr>
-              <a:t>ⓒ는 난이도 기준선이 아니라 생태적 타당성 참고로만 해석한다.</a:t>
+              <a:t>ⓑ는 [충돌 청크]를 noise로 교체(충돌 제거)하지만, ⓑ′은 [무관한 청크]를 같은 양 교체(충돌 그대로). </a:t>
+            </a:r>
+            <a:br>
+              <a:rPr lang="en-US" altLang="ko-KR" sz="1120" b="0" dirty="0">
+                <a:solidFill>
+                  <a:srgbClr val="1E2227"/>
+                </a:solidFill>
+                <a:latin typeface="맑은 고딕"/>
+                <a:ea typeface="맑은 고딕"/>
+              </a:rPr>
+            </a:br>
+            <a:r>
+              <a:rPr lang="ko-KR" sz="1120" b="1" dirty="0">
+                <a:solidFill>
+                  <a:srgbClr val="1E2227"/>
+                </a:solidFill>
+                <a:latin typeface="맑은 고딕"/>
+                <a:ea typeface="맑은 고딕"/>
+              </a:rPr>
+              <a:t>ⓑ′의 정답률이 ⓐ와 같으면</a:t>
+            </a:r>
+            <a:r>
+              <a:rPr lang="ko-KR" sz="1120" b="0" dirty="0">
+                <a:solidFill>
+                  <a:srgbClr val="1E2227"/>
+                </a:solidFill>
+                <a:latin typeface="맑은 고딕"/>
+                <a:ea typeface="맑은 고딕"/>
+              </a:rPr>
+              <a:t> ‘noise 교체 행위’ 자체는 무해 → ⓑ 변화는 순수 충돌 제거 효과.</a:t>
+            </a:r>
+            <a:endParaRPr lang="en-US" altLang="ko-KR" sz="1120" b="1" dirty="0">
+              <a:solidFill>
+                <a:srgbClr val="1E2227"/>
+              </a:solidFill>
+              <a:latin typeface="맑은 고딕"/>
+              <a:ea typeface="맑은 고딕"/>
+            </a:endParaRPr>
+          </a:p>
+          <a:p>
+            <a:pPr marL="171450" indent="-171450">
+              <a:lnSpc>
+                <a:spcPct val="130000"/>
+              </a:lnSpc>
+              <a:spcAft>
+                <a:spcPts val="300"/>
+              </a:spcAft>
+              <a:buFont typeface="Arial"/>
+              <a:buChar char="•"/>
+            </a:pPr>
+            <a:r>
+              <a:rPr lang="ko-KR" sz="1120" b="1" dirty="0">
+                <a:solidFill>
+                  <a:srgbClr val="1E2227"/>
+                </a:solidFill>
+                <a:latin typeface="맑은 고딕"/>
+                <a:ea typeface="맑은 고딕"/>
+              </a:rPr>
+              <a:t>지표</a:t>
             </a:r>
           </a:p>
           <a:p>
@@ -24794,10 +25007,77 @@
               <a:spcAft>
                 <a:spcPts val="300"/>
               </a:spcAft>
-              <a:buFont typeface="Arial" panose="020B0604020202020204" pitchFamily="34" charset="0"/>
+              <a:buFont typeface="Arial"/>
               <a:buChar char="•"/>
             </a:pPr>
             <a:r>
+              <a:rPr lang="ko-KR" sz="1120" b="0" dirty="0">
+                <a:solidFill>
+                  <a:srgbClr val="1E2227"/>
+                </a:solidFill>
+                <a:latin typeface="맑은 고딕"/>
+                <a:ea typeface="맑은 고딕"/>
+              </a:rPr>
+              <a:t>주지표는 정답률(정확도). 충돌의 순 벌점을 </a:t>
+            </a:r>
+            <a:r>
+              <a:rPr lang="en-US" sz="1120" b="0" dirty="0">
+                <a:solidFill>
+                  <a:srgbClr val="1E2227"/>
+                </a:solidFill>
+                <a:latin typeface="Cambria Math"/>
+              </a:rPr>
+              <a:t>Δ = Acc(</a:t>
+            </a:r>
+            <a:r>
+              <a:rPr lang="ko-KR" sz="1120" b="0" dirty="0">
+                <a:solidFill>
+                  <a:srgbClr val="1E2227"/>
+                </a:solidFill>
+                <a:latin typeface="맑은 고딕"/>
+                <a:ea typeface="맑은 고딕"/>
+              </a:rPr>
+              <a:t>ⓑ</a:t>
+            </a:r>
+            <a:r>
+              <a:rPr lang="en-US" sz="1120" b="0" dirty="0">
+                <a:solidFill>
+                  <a:srgbClr val="1E2227"/>
+                </a:solidFill>
+                <a:latin typeface="Cambria Math"/>
+              </a:rPr>
+              <a:t>) − Acc(</a:t>
+            </a:r>
+            <a:r>
+              <a:rPr lang="ko-KR" sz="1120" b="0" dirty="0">
+                <a:solidFill>
+                  <a:srgbClr val="1E2227"/>
+                </a:solidFill>
+                <a:latin typeface="맑은 고딕"/>
+                <a:ea typeface="맑은 고딕"/>
+              </a:rPr>
+              <a:t>ⓐ</a:t>
+            </a:r>
+            <a:r>
+              <a:rPr lang="en-US" sz="1120" b="0" dirty="0">
+                <a:solidFill>
+                  <a:srgbClr val="1E2227"/>
+                </a:solidFill>
+                <a:latin typeface="Cambria Math"/>
+              </a:rPr>
+              <a:t>)</a:t>
+            </a:r>
+            <a:r>
+              <a:rPr lang="ko-KR" sz="1120" b="0" dirty="0">
+                <a:solidFill>
+                  <a:srgbClr val="1E2227"/>
+                </a:solidFill>
+                <a:latin typeface="맑은 고딕"/>
+                <a:ea typeface="맑은 고딕"/>
+              </a:rPr>
+              <a:t> 로 정의해 </a:t>
+            </a:r>
+            <a:r>
               <a:rPr lang="ko-KR" sz="1120" b="1" dirty="0">
                 <a:solidFill>
                   <a:srgbClr val="1E2227"/>
@@ -24805,186 +25085,35 @@
                 <a:latin typeface="맑은 고딕"/>
                 <a:ea typeface="맑은 고딕"/>
               </a:rPr>
-              <a:t>부정 대조 ⓑ′.</a:t>
-            </a:r>
-            <a:r>
-              <a:rPr lang="ko-KR" sz="1120" b="0" dirty="0">
-                <a:solidFill>
-                  <a:srgbClr val="1E2227"/>
-                </a:solidFill>
-                <a:latin typeface="맑은 고딕"/>
-                <a:ea typeface="맑은 고딕"/>
-              </a:rPr>
-              <a:t> 같은 문항에서 </a:t>
-            </a:r>
-            <a:r>
-              <a:rPr lang="ko-KR" sz="1120" b="1" dirty="0">
-                <a:solidFill>
-                  <a:srgbClr val="1E2227"/>
-                </a:solidFill>
-                <a:latin typeface="맑은 고딕"/>
-                <a:ea typeface="맑은 고딕"/>
-              </a:rPr>
-              <a:t>충돌과 무관한 청크만</a:t>
-            </a:r>
-            <a:r>
-              <a:rPr lang="ko-KR" sz="1120" b="0" dirty="0">
-                <a:solidFill>
-                  <a:srgbClr val="1E2227"/>
-                </a:solidFill>
-                <a:latin typeface="맑은 고딕"/>
-                <a:ea typeface="맑은 고딕"/>
-              </a:rPr>
-              <a:t> noise로 교체해 ‘교체 행위 자체’의 효과를 충돌 제거 효과와 분리한다.</a:t>
-            </a:r>
-          </a:p>
-          <a:p>
-            <a:pPr marL="171450" indent="-171450">
-              <a:lnSpc>
-                <a:spcPct val="130000"/>
-              </a:lnSpc>
-              <a:spcAft>
-                <a:spcPts val="300"/>
-              </a:spcAft>
-              <a:buFont typeface="Arial" panose="020B0604020202020204" pitchFamily="34" charset="0"/>
-              <a:buChar char="•"/>
-            </a:pPr>
-            <a:r>
-              <a:rPr lang="ko-KR" sz="1120" b="1" dirty="0">
-                <a:solidFill>
-                  <a:srgbClr val="1E2227"/>
-                </a:solidFill>
-                <a:latin typeface="맑은 고딕"/>
-                <a:ea typeface="맑은 고딕"/>
-              </a:rPr>
-              <a:t>지표</a:t>
-            </a:r>
-            <a:endParaRPr lang="en-US" altLang="ko-KR" sz="1120" b="1" dirty="0">
+              <a:t>문항 짝 대응으로 검정</a:t>
+            </a:r>
+            <a:r>
+              <a:rPr lang="ko-KR" altLang="en-US" sz="1120" dirty="0">
+                <a:solidFill>
+                  <a:srgbClr val="1E2227"/>
+                </a:solidFill>
+                <a:latin typeface="맑은 고딕"/>
+                <a:ea typeface="맑은 고딕"/>
+              </a:rPr>
+              <a:t>한다</a:t>
+            </a:r>
+            <a:r>
+              <a:rPr lang="en-US" altLang="ko-KR" sz="1120" dirty="0">
+                <a:solidFill>
+                  <a:srgbClr val="1E2227"/>
+                </a:solidFill>
+                <a:latin typeface="맑은 고딕"/>
+                <a:ea typeface="맑은 고딕"/>
+              </a:rPr>
+              <a:t>.</a:t>
+            </a:r>
+            <a:endParaRPr lang="ko-KR" sz="1120" b="0" dirty="0">
               <a:solidFill>
                 <a:srgbClr val="1E2227"/>
               </a:solidFill>
               <a:latin typeface="맑은 고딕"/>
               <a:ea typeface="맑은 고딕"/>
             </a:endParaRPr>
-          </a:p>
-          <a:p>
-            <a:pPr marL="628650" lvl="1" indent="-171450">
-              <a:lnSpc>
-                <a:spcPct val="130000"/>
-              </a:lnSpc>
-              <a:spcAft>
-                <a:spcPts val="300"/>
-              </a:spcAft>
-              <a:buFont typeface="Arial" panose="020B0604020202020204" pitchFamily="34" charset="0"/>
-              <a:buChar char="•"/>
-            </a:pPr>
-            <a:r>
-              <a:rPr lang="ko-KR" sz="1120" b="0" dirty="0">
-                <a:solidFill>
-                  <a:srgbClr val="1E2227"/>
-                </a:solidFill>
-                <a:latin typeface="맑은 고딕"/>
-                <a:ea typeface="맑은 고딕"/>
-              </a:rPr>
-              <a:t>주지표는 정답률(정확도). 충돌의 순 벌점을 </a:t>
-            </a:r>
-            <a:r>
-              <a:rPr lang="en-US" sz="1120" b="0" dirty="0">
-                <a:solidFill>
-                  <a:srgbClr val="1E2227"/>
-                </a:solidFill>
-                <a:latin typeface="Cambria Math"/>
-              </a:rPr>
-              <a:t>Δ = Acc(</a:t>
-            </a:r>
-            <a:r>
-              <a:rPr lang="ko-KR" sz="1120" b="0" dirty="0">
-                <a:solidFill>
-                  <a:srgbClr val="1E2227"/>
-                </a:solidFill>
-                <a:latin typeface="맑은 고딕"/>
-                <a:ea typeface="맑은 고딕"/>
-              </a:rPr>
-              <a:t>ⓑ</a:t>
-            </a:r>
-            <a:r>
-              <a:rPr lang="en-US" sz="1120" b="0" dirty="0">
-                <a:solidFill>
-                  <a:srgbClr val="1E2227"/>
-                </a:solidFill>
-                <a:latin typeface="Cambria Math"/>
-              </a:rPr>
-              <a:t>) − Acc(</a:t>
-            </a:r>
-            <a:r>
-              <a:rPr lang="ko-KR" sz="1120" b="0" dirty="0">
-                <a:solidFill>
-                  <a:srgbClr val="1E2227"/>
-                </a:solidFill>
-                <a:latin typeface="맑은 고딕"/>
-                <a:ea typeface="맑은 고딕"/>
-              </a:rPr>
-              <a:t>ⓐ</a:t>
-            </a:r>
-            <a:r>
-              <a:rPr lang="en-US" sz="1120" b="0" dirty="0">
-                <a:solidFill>
-                  <a:srgbClr val="1E2227"/>
-                </a:solidFill>
-                <a:latin typeface="Cambria Math"/>
-              </a:rPr>
-              <a:t>)</a:t>
-            </a:r>
-            <a:r>
-              <a:rPr lang="ko-KR" sz="1120" b="0" dirty="0">
-                <a:solidFill>
-                  <a:srgbClr val="1E2227"/>
-                </a:solidFill>
-                <a:latin typeface="맑은 고딕"/>
-                <a:ea typeface="맑은 고딕"/>
-              </a:rPr>
-              <a:t> 로 정의해 </a:t>
-            </a:r>
-            <a:r>
-              <a:rPr lang="ko-KR" sz="1120" b="1" dirty="0">
-                <a:solidFill>
-                  <a:srgbClr val="1E2227"/>
-                </a:solidFill>
-                <a:latin typeface="맑은 고딕"/>
-                <a:ea typeface="맑은 고딕"/>
-              </a:rPr>
-              <a:t>문항 짝 대응으로 검정</a:t>
-            </a:r>
-            <a:r>
-              <a:rPr lang="ko-KR" sz="1120" b="0" dirty="0">
-                <a:solidFill>
-                  <a:srgbClr val="1E2227"/>
-                </a:solidFill>
-                <a:latin typeface="맑은 고딕"/>
-                <a:ea typeface="맑은 고딕"/>
-              </a:rPr>
-              <a:t>하고, 표본이 얇은 구간은 </a:t>
-            </a:r>
-            <a:r>
-              <a:rPr lang="ko-KR" sz="1120" b="1" dirty="0">
-                <a:solidFill>
-                  <a:srgbClr val="1E2227"/>
-                </a:solidFill>
-                <a:latin typeface="맑은 고딕"/>
-                <a:ea typeface="맑은 고딕"/>
-              </a:rPr>
-              <a:t>자기일관성(182건)</a:t>
-            </a:r>
-            <a:r>
-              <a:rPr lang="ko-KR" sz="1120" b="0" dirty="0">
-                <a:solidFill>
-                  <a:srgbClr val="1E2227"/>
-                </a:solidFill>
-                <a:latin typeface="맑은 고딕"/>
-                <a:ea typeface="맑은 고딕"/>
-              </a:rPr>
-              <a:t>으로 보완한다.</a:t>
-            </a:r>
           </a:p>
         </p:txBody>
       </p:sp>
@@ -25206,6 +25335,28 @@
               </a:rPr>
               <a:t>역할  </a:t>
             </a:r>
+            <a:endParaRPr lang="en-US" altLang="ko-KR" sz="1120" b="1" dirty="0">
+              <a:solidFill>
+                <a:srgbClr val="273A52"/>
+              </a:solidFill>
+              <a:latin typeface="맑은 고딕"/>
+              <a:ea typeface="맑은 고딕"/>
+            </a:endParaRPr>
+          </a:p>
+          <a:p>
+            <a:pPr marL="171450" indent="-171450" algn="l">
+              <a:lnSpc>
+                <a:spcPct val="116000"/>
+              </a:lnSpc>
+              <a:spcBef>
+                <a:spcPts val="300"/>
+              </a:spcBef>
+              <a:spcAft>
+                <a:spcPts val="0"/>
+              </a:spcAft>
+              <a:buFont typeface="Arial" panose="020B0604020202020204" pitchFamily="34" charset="0"/>
+              <a:buChar char="•"/>
+            </a:pPr>
             <a:r>
               <a:rPr lang="ko-KR" sz="1120" b="0" dirty="0">
                 <a:solidFill>
@@ -25408,6 +25559,28 @@
               </a:rPr>
               <a:t>역할  </a:t>
             </a:r>
+            <a:endParaRPr lang="en-US" altLang="ko-KR" sz="1120" b="1" dirty="0">
+              <a:solidFill>
+                <a:srgbClr val="273A52"/>
+              </a:solidFill>
+              <a:latin typeface="맑은 고딕"/>
+              <a:ea typeface="맑은 고딕"/>
+            </a:endParaRPr>
+          </a:p>
+          <a:p>
+            <a:pPr marL="171450" indent="-171450" algn="l">
+              <a:lnSpc>
+                <a:spcPct val="116000"/>
+              </a:lnSpc>
+              <a:spcBef>
+                <a:spcPts val="300"/>
+              </a:spcBef>
+              <a:spcAft>
+                <a:spcPts val="0"/>
+              </a:spcAft>
+              <a:buFont typeface="Arial" panose="020B0604020202020204" pitchFamily="34" charset="0"/>
+              <a:buChar char="•"/>
+            </a:pPr>
             <a:r>
               <a:rPr lang="ko-KR" sz="1120" b="0" dirty="0">
                 <a:solidFill>
@@ -25416,7 +25589,37 @@
                 <a:latin typeface="맑은 고딕"/>
                 <a:ea typeface="맑은 고딕"/>
               </a:rPr>
-              <a:t>within-item 대조로 충돌의 순효과만 분리</a:t>
+              <a:t>같은 문항을 충돌 </a:t>
+            </a:r>
+            <a:r>
+              <a:rPr lang="ko-KR" sz="1120" b="0" dirty="0" err="1">
+                <a:solidFill>
+                  <a:srgbClr val="1E2227"/>
+                </a:solidFill>
+                <a:latin typeface="맑은 고딕"/>
+                <a:ea typeface="맑은 고딕"/>
+              </a:rPr>
+              <a:t>있음↔없음으로만</a:t>
+            </a:r>
+            <a:r>
+              <a:rPr lang="ko-KR" sz="1120" b="0" dirty="0">
+                <a:solidFill>
+                  <a:srgbClr val="1E2227"/>
+                </a:solidFill>
+                <a:latin typeface="맑은 고딕"/>
+                <a:ea typeface="맑은 고딕"/>
+              </a:rPr>
+              <a:t> 비교 → </a:t>
+            </a:r>
+            <a:r>
+              <a:rPr lang="ko-KR" sz="1120" b="1" dirty="0">
+                <a:solidFill>
+                  <a:srgbClr val="1E2227"/>
+                </a:solidFill>
+                <a:latin typeface="맑은 고딕"/>
+                <a:ea typeface="맑은 고딕"/>
+              </a:rPr>
+              <a:t>충돌의 순효과만 분리</a:t>
             </a:r>
           </a:p>
         </p:txBody>
@@ -25607,6 +25810,28 @@
               </a:rPr>
               <a:t>역할  </a:t>
             </a:r>
+            <a:endParaRPr lang="en-US" altLang="ko-KR" sz="1120" b="1" dirty="0">
+              <a:solidFill>
+                <a:srgbClr val="273A52"/>
+              </a:solidFill>
+              <a:latin typeface="맑은 고딕"/>
+              <a:ea typeface="맑은 고딕"/>
+            </a:endParaRPr>
+          </a:p>
+          <a:p>
+            <a:pPr marL="171450" indent="-171450" algn="l">
+              <a:lnSpc>
+                <a:spcPct val="116000"/>
+              </a:lnSpc>
+              <a:spcBef>
+                <a:spcPts val="300"/>
+              </a:spcBef>
+              <a:spcAft>
+                <a:spcPts val="0"/>
+              </a:spcAft>
+              <a:buFont typeface="Arial" panose="020B0604020202020204" pitchFamily="34" charset="0"/>
+              <a:buChar char="•"/>
+            </a:pPr>
             <a:r>
               <a:rPr lang="ko-KR" sz="1120" b="0" dirty="0">
                 <a:solidFill>
@@ -25710,7 +25935,7 @@
     </p:spTree>
     <p:extLst>
       <p:ext uri="{BB962C8B-B14F-4D97-AF65-F5344CB8AC3E}">
-        <p14:creationId xmlns:p14="http://schemas.microsoft.com/office/powerpoint/2010/main" val="4177291566"/>
+        <p14:creationId xmlns:p14="http://schemas.microsoft.com/office/powerpoint/2010/main" val="1136205279"/>
       </p:ext>
     </p:extLst>
   </p:cSld>
@@ -25745,7 +25970,7 @@
         </p:nvSpPr>
         <p:spPr>
           <a:xfrm>
-            <a:off x="548640" y="329184"/>
+            <a:off x="536448" y="329184"/>
             <a:ext cx="11091672" cy="210955"/>
           </a:xfrm>
           <a:prstGeom prst="rect">
@@ -25947,7 +26172,7 @@
         <p:spPr>
           <a:xfrm>
             <a:off x="548640" y="1270000"/>
-            <a:ext cx="11091672" cy="992708"/>
+            <a:ext cx="11091672" cy="1208601"/>
           </a:xfrm>
           <a:prstGeom prst="rect">
             <a:avLst/>
@@ -25973,7 +26198,7 @@
                 <a:latin typeface="맑은 고딕"/>
                 <a:ea typeface="맑은 고딕"/>
               </a:rPr>
-              <a:t>① 1단계 — thinking on/off 격리 · go/no-go 게이트</a:t>
+              <a:t>① 1단계 — 추론 켜고/끄기 비교(thinking on/off) · 진행 게이트(go/no-go)</a:t>
             </a:r>
           </a:p>
           <a:p>
@@ -25988,6 +26213,16 @@
               <a:buChar char="•"/>
             </a:pPr>
             <a:r>
+              <a:rPr lang="ko-KR" sz="1150" b="1" dirty="0">
+                <a:solidFill>
+                  <a:srgbClr val="1E2227"/>
+                </a:solidFill>
+                <a:latin typeface="맑은 고딕"/>
+                <a:ea typeface="맑은 고딕"/>
+              </a:rPr>
+              <a:t>대조 방법: </a:t>
+            </a:r>
+            <a:r>
               <a:rPr lang="ko-KR" sz="1150" b="0" dirty="0">
                 <a:solidFill>
                   <a:srgbClr val="1E2227"/>
@@ -25995,7 +26230,26 @@
                 <a:latin typeface="맑은 고딕"/>
                 <a:ea typeface="맑은 고딕"/>
               </a:rPr>
-              <a:t>추론 채널이 (i) 충돌 해소 정확도를 올리는지, (ii) 새 실패 양식(</a:t>
+              <a:t>같은 문항을 추론 OFF↔ON으로 돌려 답 변화를 전환 행렬(실험 1과 동일)로 짝지어 비교 </a:t>
+            </a:r>
+            <a:br>
+              <a:rPr lang="en-US" altLang="ko-KR" sz="1150" b="0" dirty="0">
+                <a:solidFill>
+                  <a:srgbClr val="1E2227"/>
+                </a:solidFill>
+                <a:latin typeface="맑은 고딕"/>
+                <a:ea typeface="맑은 고딕"/>
+              </a:rPr>
+            </a:br>
+            <a:r>
+              <a:rPr lang="ko-KR" sz="1150" b="0" dirty="0">
+                <a:solidFill>
+                  <a:srgbClr val="1E2227"/>
+                </a:solidFill>
+                <a:latin typeface="맑은 고딕"/>
+                <a:ea typeface="맑은 고딕"/>
+              </a:rPr>
+              <a:t>— (i) 충돌 해소↑(이득), (ii) 새 실패 </a:t>
             </a:r>
             <a:r>
               <a:rPr lang="ko-KR" sz="1150" b="1" dirty="0">
@@ -26015,7 +26269,7 @@
                 <a:latin typeface="맑은 고딕"/>
                 <a:ea typeface="맑은 고딕"/>
               </a:rPr>
-              <a:t>)을 만드는지 두 모드에서 대조한다.</a:t>
+              <a:t>(부작용)을 함께 확인.</a:t>
             </a:r>
           </a:p>
           <a:p>
@@ -26037,7 +26291,7 @@
                 <a:latin typeface="맑은 고딕"/>
                 <a:ea typeface="맑은 고딕"/>
               </a:rPr>
-              <a:t>go/no-go 게이트: </a:t>
+              <a:t>진행 게이트(go/no-go): </a:t>
             </a:r>
             <a:r>
               <a:rPr lang="ko-KR" sz="1150" b="0" dirty="0">
@@ -26047,7 +26301,7 @@
                 <a:latin typeface="맑은 고딕"/>
                 <a:ea typeface="맑은 고딕"/>
               </a:rPr>
-              <a:t>&lt;think&gt; 전체를 마스킹해도 답 분포가 안 바뀌면 추론 채널은 장식 → 진단 중단.</a:t>
+              <a:t>추론 과정(&lt;think&gt;)을 통째로 가려도 답이 안 바뀌면 추론은 겉치레 → 진단 중단(바뀌면 진행).</a:t>
             </a:r>
           </a:p>
           <a:p>
@@ -26079,7 +26333,7 @@
                 <a:latin typeface="맑은 고딕"/>
                 <a:ea typeface="맑은 고딕"/>
               </a:rPr>
-              <a:t>주력 Qwen3.6-27B(동일 가중치 하드 토글) · 보조 gpt-oss-20b(참고용).</a:t>
+              <a:t>같은 모델을 가중치 그대로 두고 추론 스위치만 켜고/끔(하드 토글) — 주력 Qwen3.6-27B · 보조 gpt-oss-20b(참고용).</a:t>
             </a:r>
           </a:p>
         </p:txBody>
@@ -26092,7 +26346,7 @@
         </p:nvSpPr>
         <p:spPr>
           <a:xfrm>
-            <a:off x="548640" y="4838700"/>
+            <a:off x="548640" y="5472684"/>
             <a:ext cx="11091672" cy="838200"/>
           </a:xfrm>
           <a:prstGeom prst="rect">
@@ -26226,7 +26480,7 @@
         </p:nvSpPr>
         <p:spPr>
           <a:xfrm>
-            <a:off x="548640" y="2362200"/>
+            <a:off x="548640" y="2667000"/>
             <a:ext cx="11087100" cy="254000"/>
           </a:xfrm>
           <a:prstGeom prst="rect">
@@ -26260,11 +26514,17 @@
           <p:cNvGraphicFramePr>
             <a:graphicFrameLocks noGrp="1"/>
           </p:cNvGraphicFramePr>
-          <p:nvPr/>
+          <p:nvPr>
+            <p:extLst>
+              <p:ext uri="{D42A27DB-BD31-4B8C-83A1-F6EECF244321}">
+                <p14:modId xmlns:p14="http://schemas.microsoft.com/office/powerpoint/2010/main" val="1567363040"/>
+              </p:ext>
+            </p:extLst>
+          </p:nvPr>
         </p:nvGraphicFramePr>
         <p:xfrm>
-          <a:off x="548640" y="2717800"/>
-          <a:ext cx="11091672" cy="2065401"/>
+          <a:off x="548640" y="3022600"/>
+          <a:ext cx="11091672" cy="2354070"/>
         </p:xfrm>
         <a:graphic>
           <a:graphicData uri="http://schemas.openxmlformats.org/drawingml/2006/table">
@@ -26295,7 +26555,7 @@
                   </a:extLst>
                 </a:gridCol>
               </a:tblGrid>
-              <a:tr h="365760">
+              <a:tr h="416880">
                 <a:tc>
                   <a:txBody>
                     <a:bodyPr/>
@@ -26395,7 +26655,7 @@
                   </a:ext>
                 </a:extLst>
               </a:tr>
-              <a:tr h="365760">
+              <a:tr h="506770">
                 <a:tc>
                   <a:txBody>
                     <a:bodyPr/>
@@ -26515,7 +26775,7 @@
                   </a:ext>
                 </a:extLst>
               </a:tr>
-              <a:tr h="365760">
+              <a:tr h="416880">
                 <a:tc>
                   <a:txBody>
                     <a:bodyPr/>
@@ -26635,7 +26895,7 @@
                   </a:ext>
                 </a:extLst>
               </a:tr>
-              <a:tr h="365760">
+              <a:tr h="506770">
                 <a:tc>
                   <a:txBody>
                     <a:bodyPr/>
@@ -26712,34 +26972,294 @@
                         </a:spcAft>
                       </a:pPr>
                       <a:r>
-                        <a:rPr sz="1120" b="0">
+                        <a:rPr sz="1120" b="0" dirty="0" err="1">
                           <a:solidFill>
                             <a:srgbClr val="1E2227"/>
                           </a:solidFill>
                           <a:latin typeface="맑은 고딕"/>
                           <a:ea typeface="맑은 고딕"/>
                         </a:rPr>
-                        <a:t>절단 구간을 같은 길이의 무의미한 토큰으로 바꿔, 성능 하락이 </a:t>
-                      </a:r>
-                      <a:r>
-                        <a:rPr sz="1120" b="1">
+                        <a:t>절단</a:t>
+                      </a:r>
+                      <a:r>
+                        <a:rPr sz="1120" b="0" dirty="0">
                           <a:solidFill>
                             <a:srgbClr val="1E2227"/>
                           </a:solidFill>
                           <a:latin typeface="맑은 고딕"/>
                           <a:ea typeface="맑은 고딕"/>
                         </a:rPr>
-                        <a:t>내용이 사라져서인지, 길이·형식이 무너져서인지</a:t>
-                      </a:r>
-                      <a:r>
-                        <a:rPr sz="1120" b="0">
+                        <a:t> </a:t>
+                      </a:r>
+                      <a:r>
+                        <a:rPr sz="1120" b="0" dirty="0" err="1">
                           <a:solidFill>
                             <a:srgbClr val="1E2227"/>
                           </a:solidFill>
                           <a:latin typeface="맑은 고딕"/>
                           <a:ea typeface="맑은 고딕"/>
                         </a:rPr>
-                        <a:t>를 구분합니다.</a:t>
+                        <a:t>구간을</a:t>
+                      </a:r>
+                      <a:r>
+                        <a:rPr sz="1120" b="0" dirty="0">
+                          <a:solidFill>
+                            <a:srgbClr val="1E2227"/>
+                          </a:solidFill>
+                          <a:latin typeface="맑은 고딕"/>
+                          <a:ea typeface="맑은 고딕"/>
+                        </a:rPr>
+                        <a:t> </a:t>
+                      </a:r>
+                      <a:r>
+                        <a:rPr sz="1120" b="0" dirty="0" err="1">
+                          <a:solidFill>
+                            <a:srgbClr val="1E2227"/>
+                          </a:solidFill>
+                          <a:latin typeface="맑은 고딕"/>
+                          <a:ea typeface="맑은 고딕"/>
+                        </a:rPr>
+                        <a:t>같은</a:t>
+                      </a:r>
+                      <a:r>
+                        <a:rPr sz="1120" b="0" dirty="0">
+                          <a:solidFill>
+                            <a:srgbClr val="1E2227"/>
+                          </a:solidFill>
+                          <a:latin typeface="맑은 고딕"/>
+                          <a:ea typeface="맑은 고딕"/>
+                        </a:rPr>
+                        <a:t> </a:t>
+                      </a:r>
+                      <a:r>
+                        <a:rPr sz="1120" b="0" dirty="0" err="1">
+                          <a:solidFill>
+                            <a:srgbClr val="1E2227"/>
+                          </a:solidFill>
+                          <a:latin typeface="맑은 고딕"/>
+                          <a:ea typeface="맑은 고딕"/>
+                        </a:rPr>
+                        <a:t>길이의</a:t>
+                      </a:r>
+                      <a:r>
+                        <a:rPr sz="1120" b="0" dirty="0">
+                          <a:solidFill>
+                            <a:srgbClr val="1E2227"/>
+                          </a:solidFill>
+                          <a:latin typeface="맑은 고딕"/>
+                          <a:ea typeface="맑은 고딕"/>
+                        </a:rPr>
+                        <a:t> </a:t>
+                      </a:r>
+                      <a:r>
+                        <a:rPr sz="1120" b="0" dirty="0" err="1">
+                          <a:solidFill>
+                            <a:srgbClr val="1E2227"/>
+                          </a:solidFill>
+                          <a:latin typeface="맑은 고딕"/>
+                          <a:ea typeface="맑은 고딕"/>
+                        </a:rPr>
+                        <a:t>무의미한</a:t>
+                      </a:r>
+                      <a:r>
+                        <a:rPr sz="1120" b="0" dirty="0">
+                          <a:solidFill>
+                            <a:srgbClr val="1E2227"/>
+                          </a:solidFill>
+                          <a:latin typeface="맑은 고딕"/>
+                          <a:ea typeface="맑은 고딕"/>
+                        </a:rPr>
+                        <a:t> </a:t>
+                      </a:r>
+                      <a:r>
+                        <a:rPr sz="1120" b="0" dirty="0" err="1">
+                          <a:solidFill>
+                            <a:srgbClr val="1E2227"/>
+                          </a:solidFill>
+                          <a:latin typeface="맑은 고딕"/>
+                          <a:ea typeface="맑은 고딕"/>
+                        </a:rPr>
+                        <a:t>토큰으로</a:t>
+                      </a:r>
+                      <a:r>
+                        <a:rPr sz="1120" b="0" dirty="0">
+                          <a:solidFill>
+                            <a:srgbClr val="1E2227"/>
+                          </a:solidFill>
+                          <a:latin typeface="맑은 고딕"/>
+                          <a:ea typeface="맑은 고딕"/>
+                        </a:rPr>
+                        <a:t> </a:t>
+                      </a:r>
+                      <a:r>
+                        <a:rPr sz="1120" b="0" dirty="0" err="1">
+                          <a:solidFill>
+                            <a:srgbClr val="1E2227"/>
+                          </a:solidFill>
+                          <a:latin typeface="맑은 고딕"/>
+                          <a:ea typeface="맑은 고딕"/>
+                        </a:rPr>
+                        <a:t>바꿔</a:t>
+                      </a:r>
+                      <a:r>
+                        <a:rPr sz="1120" b="0" dirty="0">
+                          <a:solidFill>
+                            <a:srgbClr val="1E2227"/>
+                          </a:solidFill>
+                          <a:latin typeface="맑은 고딕"/>
+                          <a:ea typeface="맑은 고딕"/>
+                        </a:rPr>
+                        <a:t>, </a:t>
+                      </a:r>
+                      <a:r>
+                        <a:rPr sz="1120" b="0" dirty="0" err="1">
+                          <a:solidFill>
+                            <a:srgbClr val="1E2227"/>
+                          </a:solidFill>
+                          <a:latin typeface="맑은 고딕"/>
+                          <a:ea typeface="맑은 고딕"/>
+                        </a:rPr>
+                        <a:t>성능</a:t>
+                      </a:r>
+                      <a:r>
+                        <a:rPr sz="1120" b="0" dirty="0">
+                          <a:solidFill>
+                            <a:srgbClr val="1E2227"/>
+                          </a:solidFill>
+                          <a:latin typeface="맑은 고딕"/>
+                          <a:ea typeface="맑은 고딕"/>
+                        </a:rPr>
+                        <a:t> </a:t>
+                      </a:r>
+                      <a:r>
+                        <a:rPr sz="1120" b="0" dirty="0" err="1">
+                          <a:solidFill>
+                            <a:srgbClr val="1E2227"/>
+                          </a:solidFill>
+                          <a:latin typeface="맑은 고딕"/>
+                          <a:ea typeface="맑은 고딕"/>
+                        </a:rPr>
+                        <a:t>하락이</a:t>
+                      </a:r>
+                      <a:r>
+                        <a:rPr sz="1120" b="0" dirty="0">
+                          <a:solidFill>
+                            <a:srgbClr val="1E2227"/>
+                          </a:solidFill>
+                          <a:latin typeface="맑은 고딕"/>
+                          <a:ea typeface="맑은 고딕"/>
+                        </a:rPr>
+                        <a:t> </a:t>
+                      </a:r>
+                      <a:r>
+                        <a:rPr sz="1120" b="1" dirty="0" err="1">
+                          <a:solidFill>
+                            <a:srgbClr val="1E2227"/>
+                          </a:solidFill>
+                          <a:latin typeface="맑은 고딕"/>
+                          <a:ea typeface="맑은 고딕"/>
+                        </a:rPr>
+                        <a:t>내용이</a:t>
+                      </a:r>
+                      <a:r>
+                        <a:rPr sz="1120" b="1" dirty="0">
+                          <a:solidFill>
+                            <a:srgbClr val="1E2227"/>
+                          </a:solidFill>
+                          <a:latin typeface="맑은 고딕"/>
+                          <a:ea typeface="맑은 고딕"/>
+                        </a:rPr>
+                        <a:t> </a:t>
+                      </a:r>
+                      <a:r>
+                        <a:rPr sz="1120" b="1" dirty="0" err="1">
+                          <a:solidFill>
+                            <a:srgbClr val="1E2227"/>
+                          </a:solidFill>
+                          <a:latin typeface="맑은 고딕"/>
+                          <a:ea typeface="맑은 고딕"/>
+                        </a:rPr>
+                        <a:t>사라져서인지</a:t>
+                      </a:r>
+                      <a:r>
+                        <a:rPr sz="1120" b="1" dirty="0">
+                          <a:solidFill>
+                            <a:srgbClr val="1E2227"/>
+                          </a:solidFill>
+                          <a:latin typeface="맑은 고딕"/>
+                          <a:ea typeface="맑은 고딕"/>
+                        </a:rPr>
+                        <a:t>, </a:t>
+                      </a:r>
+                      <a:r>
+                        <a:rPr sz="1120" b="1" dirty="0" err="1">
+                          <a:solidFill>
+                            <a:srgbClr val="1E2227"/>
+                          </a:solidFill>
+                          <a:latin typeface="맑은 고딕"/>
+                          <a:ea typeface="맑은 고딕"/>
+                        </a:rPr>
+                        <a:t>길이·형식이</a:t>
+                      </a:r>
+                      <a:r>
+                        <a:rPr sz="1120" b="1" dirty="0">
+                          <a:solidFill>
+                            <a:srgbClr val="1E2227"/>
+                          </a:solidFill>
+                          <a:latin typeface="맑은 고딕"/>
+                          <a:ea typeface="맑은 고딕"/>
+                        </a:rPr>
+                        <a:t> </a:t>
+                      </a:r>
+                      <a:r>
+                        <a:rPr sz="1120" b="1" dirty="0" err="1">
+                          <a:solidFill>
+                            <a:srgbClr val="1E2227"/>
+                          </a:solidFill>
+                          <a:latin typeface="맑은 고딕"/>
+                          <a:ea typeface="맑은 고딕"/>
+                        </a:rPr>
+                        <a:t>무너져서인지</a:t>
+                      </a:r>
+                      <a:r>
+                        <a:rPr sz="1120" b="0" dirty="0" err="1">
+                          <a:solidFill>
+                            <a:srgbClr val="1E2227"/>
+                          </a:solidFill>
+                          <a:latin typeface="맑은 고딕"/>
+                          <a:ea typeface="맑은 고딕"/>
+                        </a:rPr>
+                        <a:t>를</a:t>
+                      </a:r>
+                      <a:r>
+                        <a:rPr sz="1120" b="0" dirty="0">
+                          <a:solidFill>
+                            <a:srgbClr val="1E2227"/>
+                          </a:solidFill>
+                          <a:latin typeface="맑은 고딕"/>
+                          <a:ea typeface="맑은 고딕"/>
+                        </a:rPr>
+                        <a:t> </a:t>
+                      </a:r>
+                      <a:r>
+                        <a:rPr sz="1120" b="0" dirty="0" err="1">
+                          <a:solidFill>
+                            <a:srgbClr val="1E2227"/>
+                          </a:solidFill>
+                          <a:latin typeface="맑은 고딕"/>
+                          <a:ea typeface="맑은 고딕"/>
+                        </a:rPr>
+                        <a:t>구분합니다</a:t>
+                      </a:r>
+                      <a:r>
+                        <a:rPr sz="1120" b="0" dirty="0">
+                          <a:solidFill>
+                            <a:srgbClr val="1E2227"/>
+                          </a:solidFill>
+                          <a:latin typeface="맑은 고딕"/>
+                          <a:ea typeface="맑은 고딕"/>
+                        </a:rPr>
+                        <a:t>.</a:t>
                       </a:r>
                     </a:p>
                   </a:txBody>
@@ -26755,7 +27275,7 @@
                   </a:ext>
                 </a:extLst>
               </a:tr>
-              <a:tr h="365760">
+              <a:tr h="506770">
                 <a:tc>
                   <a:txBody>
                     <a:bodyPr/>
@@ -26832,34 +27352,354 @@
                         </a:spcAft>
                       </a:pPr>
                       <a:r>
-                        <a:rPr sz="1120" b="0">
+                        <a:rPr sz="1120" b="0" dirty="0" err="1">
                           <a:solidFill>
                             <a:srgbClr val="1E2227"/>
                           </a:solidFill>
                           <a:latin typeface="맑은 고딕"/>
                           <a:ea typeface="맑은 고딕"/>
                         </a:rPr>
-                        <a:t>모델이 스스로 추론을 끝낸 지점(&lt;/think&gt;)에서 절단해 무개입 기준선을 만들고, </a:t>
-                      </a:r>
-                      <a:r>
-                        <a:rPr sz="1120" b="1">
+                        <a:t>모델이</a:t>
+                      </a:r>
+                      <a:r>
+                        <a:rPr sz="1120" b="0" dirty="0">
                           <a:solidFill>
                             <a:srgbClr val="1E2227"/>
                           </a:solidFill>
                           <a:latin typeface="맑은 고딕"/>
                           <a:ea typeface="맑은 고딕"/>
                         </a:rPr>
-                        <a:t>절단 절차 자체가 만드는 교란의 크기</a:t>
-                      </a:r>
-                      <a:r>
-                        <a:rPr sz="1120" b="0">
+                        <a:t> </a:t>
+                      </a:r>
+                      <a:r>
+                        <a:rPr sz="1120" b="0" dirty="0" err="1">
                           <a:solidFill>
                             <a:srgbClr val="1E2227"/>
                           </a:solidFill>
                           <a:latin typeface="맑은 고딕"/>
                           <a:ea typeface="맑은 고딕"/>
                         </a:rPr>
-                        <a:t>를 측정합니다.</a:t>
+                        <a:t>스스로</a:t>
+                      </a:r>
+                      <a:r>
+                        <a:rPr sz="1120" b="0" dirty="0">
+                          <a:solidFill>
+                            <a:srgbClr val="1E2227"/>
+                          </a:solidFill>
+                          <a:latin typeface="맑은 고딕"/>
+                          <a:ea typeface="맑은 고딕"/>
+                        </a:rPr>
+                        <a:t> </a:t>
+                      </a:r>
+                      <a:r>
+                        <a:rPr sz="1120" b="0" dirty="0" err="1">
+                          <a:solidFill>
+                            <a:srgbClr val="1E2227"/>
+                          </a:solidFill>
+                          <a:latin typeface="맑은 고딕"/>
+                          <a:ea typeface="맑은 고딕"/>
+                        </a:rPr>
+                        <a:t>추론을</a:t>
+                      </a:r>
+                      <a:r>
+                        <a:rPr sz="1120" b="0" dirty="0">
+                          <a:solidFill>
+                            <a:srgbClr val="1E2227"/>
+                          </a:solidFill>
+                          <a:latin typeface="맑은 고딕"/>
+                          <a:ea typeface="맑은 고딕"/>
+                        </a:rPr>
+                        <a:t> </a:t>
+                      </a:r>
+                      <a:r>
+                        <a:rPr sz="1120" b="0" dirty="0" err="1">
+                          <a:solidFill>
+                            <a:srgbClr val="1E2227"/>
+                          </a:solidFill>
+                          <a:latin typeface="맑은 고딕"/>
+                          <a:ea typeface="맑은 고딕"/>
+                        </a:rPr>
+                        <a:t>끝낸</a:t>
+                      </a:r>
+                      <a:r>
+                        <a:rPr sz="1120" b="0" dirty="0">
+                          <a:solidFill>
+                            <a:srgbClr val="1E2227"/>
+                          </a:solidFill>
+                          <a:latin typeface="맑은 고딕"/>
+                          <a:ea typeface="맑은 고딕"/>
+                        </a:rPr>
+                        <a:t> </a:t>
+                      </a:r>
+                      <a:r>
+                        <a:rPr sz="1120" b="0" dirty="0" err="1">
+                          <a:solidFill>
+                            <a:srgbClr val="1E2227"/>
+                          </a:solidFill>
+                          <a:latin typeface="맑은 고딕"/>
+                          <a:ea typeface="맑은 고딕"/>
+                        </a:rPr>
+                        <a:t>지점</a:t>
+                      </a:r>
+                      <a:r>
+                        <a:rPr sz="1120" b="0" dirty="0">
+                          <a:solidFill>
+                            <a:srgbClr val="1E2227"/>
+                          </a:solidFill>
+                          <a:latin typeface="맑은 고딕"/>
+                          <a:ea typeface="맑은 고딕"/>
+                        </a:rPr>
+                        <a:t>(&lt;/think&gt;)</a:t>
+                      </a:r>
+                      <a:r>
+                        <a:rPr sz="1120" b="0" dirty="0" err="1">
+                          <a:solidFill>
+                            <a:srgbClr val="1E2227"/>
+                          </a:solidFill>
+                          <a:latin typeface="맑은 고딕"/>
+                          <a:ea typeface="맑은 고딕"/>
+                        </a:rPr>
+                        <a:t>에서</a:t>
+                      </a:r>
+                      <a:r>
+                        <a:rPr sz="1120" b="0" dirty="0">
+                          <a:solidFill>
+                            <a:srgbClr val="1E2227"/>
+                          </a:solidFill>
+                          <a:latin typeface="맑은 고딕"/>
+                          <a:ea typeface="맑은 고딕"/>
+                        </a:rPr>
+                        <a:t> </a:t>
+                      </a:r>
+                      <a:r>
+                        <a:rPr sz="1120" b="0" dirty="0" err="1">
+                          <a:solidFill>
+                            <a:srgbClr val="1E2227"/>
+                          </a:solidFill>
+                          <a:latin typeface="맑은 고딕"/>
+                          <a:ea typeface="맑은 고딕"/>
+                        </a:rPr>
+                        <a:t>절단해</a:t>
+                      </a:r>
+                      <a:r>
+                        <a:rPr sz="1120" b="0" dirty="0">
+                          <a:solidFill>
+                            <a:srgbClr val="1E2227"/>
+                          </a:solidFill>
+                          <a:latin typeface="맑은 고딕"/>
+                          <a:ea typeface="맑은 고딕"/>
+                        </a:rPr>
+                        <a:t> </a:t>
+                      </a:r>
+                      <a:r>
+                        <a:rPr sz="1120" b="0" dirty="0" err="1">
+                          <a:solidFill>
+                            <a:srgbClr val="1E2227"/>
+                          </a:solidFill>
+                          <a:latin typeface="맑은 고딕"/>
+                          <a:ea typeface="맑은 고딕"/>
+                        </a:rPr>
+                        <a:t>무개입</a:t>
+                      </a:r>
+                      <a:r>
+                        <a:rPr sz="1120" b="0" dirty="0">
+                          <a:solidFill>
+                            <a:srgbClr val="1E2227"/>
+                          </a:solidFill>
+                          <a:latin typeface="맑은 고딕"/>
+                          <a:ea typeface="맑은 고딕"/>
+                        </a:rPr>
+                        <a:t> </a:t>
+                      </a:r>
+                      <a:r>
+                        <a:rPr sz="1120" b="0" dirty="0" err="1">
+                          <a:solidFill>
+                            <a:srgbClr val="1E2227"/>
+                          </a:solidFill>
+                          <a:latin typeface="맑은 고딕"/>
+                          <a:ea typeface="맑은 고딕"/>
+                        </a:rPr>
+                        <a:t>기준선을</a:t>
+                      </a:r>
+                      <a:r>
+                        <a:rPr sz="1120" b="0" dirty="0">
+                          <a:solidFill>
+                            <a:srgbClr val="1E2227"/>
+                          </a:solidFill>
+                          <a:latin typeface="맑은 고딕"/>
+                          <a:ea typeface="맑은 고딕"/>
+                        </a:rPr>
+                        <a:t> </a:t>
+                      </a:r>
+                      <a:r>
+                        <a:rPr sz="1120" b="0" dirty="0" err="1">
+                          <a:solidFill>
+                            <a:srgbClr val="1E2227"/>
+                          </a:solidFill>
+                          <a:latin typeface="맑은 고딕"/>
+                          <a:ea typeface="맑은 고딕"/>
+                        </a:rPr>
+                        <a:t>만들고</a:t>
+                      </a:r>
+                      <a:r>
+                        <a:rPr sz="1120" b="0" dirty="0">
+                          <a:solidFill>
+                            <a:srgbClr val="1E2227"/>
+                          </a:solidFill>
+                          <a:latin typeface="맑은 고딕"/>
+                          <a:ea typeface="맑은 고딕"/>
+                        </a:rPr>
+                        <a:t>, </a:t>
+                      </a:r>
+                      <a:r>
+                        <a:rPr sz="1120" b="1" dirty="0" err="1">
+                          <a:solidFill>
+                            <a:srgbClr val="1E2227"/>
+                          </a:solidFill>
+                          <a:latin typeface="맑은 고딕"/>
+                          <a:ea typeface="맑은 고딕"/>
+                        </a:rPr>
+                        <a:t>절단</a:t>
+                      </a:r>
+                      <a:r>
+                        <a:rPr sz="1120" b="1" dirty="0">
+                          <a:solidFill>
+                            <a:srgbClr val="1E2227"/>
+                          </a:solidFill>
+                          <a:latin typeface="맑은 고딕"/>
+                          <a:ea typeface="맑은 고딕"/>
+                        </a:rPr>
+                        <a:t> </a:t>
+                      </a:r>
+                      <a:r>
+                        <a:rPr sz="1120" b="1" dirty="0" err="1">
+                          <a:solidFill>
+                            <a:srgbClr val="1E2227"/>
+                          </a:solidFill>
+                          <a:latin typeface="맑은 고딕"/>
+                          <a:ea typeface="맑은 고딕"/>
+                        </a:rPr>
+                        <a:t>절차</a:t>
+                      </a:r>
+                      <a:r>
+                        <a:rPr sz="1120" b="1" dirty="0">
+                          <a:solidFill>
+                            <a:srgbClr val="1E2227"/>
+                          </a:solidFill>
+                          <a:latin typeface="맑은 고딕"/>
+                          <a:ea typeface="맑은 고딕"/>
+                        </a:rPr>
+                        <a:t> </a:t>
+                      </a:r>
+                      <a:r>
+                        <a:rPr sz="1120" b="1" dirty="0" err="1">
+                          <a:solidFill>
+                            <a:srgbClr val="1E2227"/>
+                          </a:solidFill>
+                          <a:latin typeface="맑은 고딕"/>
+                          <a:ea typeface="맑은 고딕"/>
+                        </a:rPr>
+                        <a:t>자체가</a:t>
+                      </a:r>
+                      <a:r>
+                        <a:rPr sz="1120" b="1" dirty="0">
+                          <a:solidFill>
+                            <a:srgbClr val="1E2227"/>
+                          </a:solidFill>
+                          <a:latin typeface="맑은 고딕"/>
+                          <a:ea typeface="맑은 고딕"/>
+                        </a:rPr>
+                        <a:t> </a:t>
+                      </a:r>
+                      <a:r>
+                        <a:rPr sz="1120" b="1" dirty="0" err="1">
+                          <a:solidFill>
+                            <a:srgbClr val="1E2227"/>
+                          </a:solidFill>
+                          <a:latin typeface="맑은 고딕"/>
+                          <a:ea typeface="맑은 고딕"/>
+                        </a:rPr>
+                        <a:t>만드는</a:t>
+                      </a:r>
+                      <a:r>
+                        <a:rPr sz="1120" b="1" dirty="0">
+                          <a:solidFill>
+                            <a:srgbClr val="1E2227"/>
+                          </a:solidFill>
+                          <a:latin typeface="맑은 고딕"/>
+                          <a:ea typeface="맑은 고딕"/>
+                        </a:rPr>
+                        <a:t> </a:t>
+                      </a:r>
+                      <a:r>
+                        <a:rPr sz="1120" b="1" dirty="0" err="1">
+                          <a:solidFill>
+                            <a:srgbClr val="1E2227"/>
+                          </a:solidFill>
+                          <a:latin typeface="맑은 고딕"/>
+                          <a:ea typeface="맑은 고딕"/>
+                        </a:rPr>
+                        <a:t>교란의</a:t>
+                      </a:r>
+                      <a:r>
+                        <a:rPr sz="1120" b="1" dirty="0">
+                          <a:solidFill>
+                            <a:srgbClr val="1E2227"/>
+                          </a:solidFill>
+                          <a:latin typeface="맑은 고딕"/>
+                          <a:ea typeface="맑은 고딕"/>
+                        </a:rPr>
+                        <a:t> </a:t>
+                      </a:r>
+                      <a:r>
+                        <a:rPr sz="1120" b="1" dirty="0" err="1">
+                          <a:solidFill>
+                            <a:srgbClr val="1E2227"/>
+                          </a:solidFill>
+                          <a:latin typeface="맑은 고딕"/>
+                          <a:ea typeface="맑은 고딕"/>
+                        </a:rPr>
+                        <a:t>크기</a:t>
+                      </a:r>
+                      <a:r>
+                        <a:rPr sz="1120" b="0" dirty="0" err="1">
+                          <a:solidFill>
+                            <a:srgbClr val="1E2227"/>
+                          </a:solidFill>
+                          <a:latin typeface="맑은 고딕"/>
+                          <a:ea typeface="맑은 고딕"/>
+                        </a:rPr>
+                        <a:t>를</a:t>
+                      </a:r>
+                      <a:r>
+                        <a:rPr sz="1120" b="0" dirty="0">
+                          <a:solidFill>
+                            <a:srgbClr val="1E2227"/>
+                          </a:solidFill>
+                          <a:latin typeface="맑은 고딕"/>
+                          <a:ea typeface="맑은 고딕"/>
+                        </a:rPr>
+                        <a:t> </a:t>
+                      </a:r>
+                      <a:r>
+                        <a:rPr sz="1120" b="0" dirty="0" err="1">
+                          <a:solidFill>
+                            <a:srgbClr val="1E2227"/>
+                          </a:solidFill>
+                          <a:latin typeface="맑은 고딕"/>
+                          <a:ea typeface="맑은 고딕"/>
+                        </a:rPr>
+                        <a:t>측정합니다</a:t>
+                      </a:r>
+                      <a:r>
+                        <a:rPr sz="1120" b="0" dirty="0">
+                          <a:solidFill>
+                            <a:srgbClr val="1E2227"/>
+                          </a:solidFill>
+                          <a:latin typeface="맑은 고딕"/>
+                          <a:ea typeface="맑은 고딕"/>
+                        </a:rPr>
+                        <a:t>.</a:t>
                       </a:r>
                     </a:p>
                   </a:txBody>
@@ -26882,7 +27722,7 @@
     </p:spTree>
     <p:extLst>
       <p:ext uri="{BB962C8B-B14F-4D97-AF65-F5344CB8AC3E}">
-        <p14:creationId xmlns:p14="http://schemas.microsoft.com/office/powerpoint/2010/main" val="677998858"/>
+        <p14:creationId xmlns:p14="http://schemas.microsoft.com/office/powerpoint/2010/main" val="2122744758"/>
       </p:ext>
     </p:extLst>
   </p:cSld>
@@ -27184,7 +28024,7 @@
               </a:spcAft>
             </a:pPr>
             <a:r>
-              <a:rPr lang="ko-KR" sz="1300" b="1" dirty="0">
+              <a:rPr lang="ko-KR" sz="1200" b="1" dirty="0">
                 <a:solidFill>
                   <a:srgbClr val="273A52"/>
                 </a:solidFill>
@@ -27215,13 +28055,15 @@
             </a:r>
           </a:p>
           <a:p>
-            <a:pPr algn="l">
+            <a:pPr marL="171450" indent="-171450" algn="l">
               <a:lnSpc>
                 <a:spcPct val="136000"/>
               </a:lnSpc>
               <a:spcAft>
                 <a:spcPts val="450"/>
               </a:spcAft>
+              <a:buFont typeface="Arial" panose="020B0604020202020204" pitchFamily="34" charset="0"/>
+              <a:buChar char="•"/>
             </a:pPr>
             <a:r>
               <a:rPr lang="ko-KR" sz="1120" b="0" dirty="0">
@@ -27275,13 +28117,15 @@
             </a:r>
           </a:p>
           <a:p>
-            <a:pPr algn="l">
+            <a:pPr marL="171450" indent="-171450" algn="l">
               <a:lnSpc>
                 <a:spcPct val="136000"/>
               </a:lnSpc>
               <a:spcAft>
                 <a:spcPts val="0"/>
               </a:spcAft>
+              <a:buFont typeface="Arial" panose="020B0604020202020204" pitchFamily="34" charset="0"/>
+              <a:buChar char="•"/>
             </a:pPr>
             <a:r>
               <a:rPr lang="ko-KR" sz="1120" b="1" dirty="0">
@@ -27400,7 +28244,7 @@
               </a:spcAft>
             </a:pPr>
             <a:r>
-              <a:rPr lang="ko-KR" sz="1300" b="1" dirty="0">
+              <a:rPr lang="ko-KR" sz="1200" b="1" dirty="0">
                 <a:solidFill>
                   <a:srgbClr val="273A52"/>
                 </a:solidFill>
@@ -27431,13 +28275,15 @@
             </a:r>
           </a:p>
           <a:p>
-            <a:pPr algn="l">
+            <a:pPr marL="171450" indent="-171450" algn="l">
               <a:lnSpc>
                 <a:spcPct val="136000"/>
               </a:lnSpc>
               <a:spcAft>
                 <a:spcPts val="450"/>
               </a:spcAft>
+              <a:buFont typeface="Arial" panose="020B0604020202020204" pitchFamily="34" charset="0"/>
+              <a:buChar char="•"/>
             </a:pPr>
             <a:r>
               <a:rPr lang="ko-KR" sz="1120" b="1" dirty="0">
@@ -27461,13 +28307,15 @@
             </a:r>
           </a:p>
           <a:p>
-            <a:pPr algn="l">
+            <a:pPr marL="171450" indent="-171450" algn="l">
               <a:lnSpc>
                 <a:spcPct val="136000"/>
               </a:lnSpc>
               <a:spcAft>
                 <a:spcPts val="0"/>
               </a:spcAft>
+              <a:buFont typeface="Arial" panose="020B0604020202020204" pitchFamily="34" charset="0"/>
+              <a:buChar char="•"/>
             </a:pPr>
             <a:r>
               <a:rPr lang="ko-KR" sz="1120" b="0" dirty="0">
@@ -27596,7 +28444,7 @@
               </a:spcAft>
             </a:pPr>
             <a:r>
-              <a:rPr lang="ko-KR" sz="1300" b="1" dirty="0">
+              <a:rPr lang="ko-KR" sz="1200" b="1" dirty="0">
                 <a:solidFill>
                   <a:srgbClr val="273A52"/>
                 </a:solidFill>
@@ -27627,13 +28475,15 @@
             </a:r>
           </a:p>
           <a:p>
-            <a:pPr algn="l">
+            <a:pPr marL="171450" indent="-171450" algn="l">
               <a:lnSpc>
                 <a:spcPct val="136000"/>
               </a:lnSpc>
               <a:spcAft>
                 <a:spcPts val="450"/>
               </a:spcAft>
+              <a:buFont typeface="Arial" panose="020B0604020202020204" pitchFamily="34" charset="0"/>
+              <a:buChar char="•"/>
             </a:pPr>
             <a:r>
               <a:rPr lang="ko-KR" sz="1120" b="1" dirty="0">
@@ -27657,13 +28507,15 @@
             </a:r>
           </a:p>
           <a:p>
-            <a:pPr algn="l">
+            <a:pPr marL="171450" indent="-171450" algn="l">
               <a:lnSpc>
                 <a:spcPct val="136000"/>
               </a:lnSpc>
               <a:spcAft>
                 <a:spcPts val="0"/>
               </a:spcAft>
+              <a:buFont typeface="Arial" panose="020B0604020202020204" pitchFamily="34" charset="0"/>
+              <a:buChar char="•"/>
             </a:pPr>
             <a:r>
               <a:rPr lang="ko-KR" sz="1120" b="0" dirty="0">
@@ -27783,27 +28635,19 @@
             </a:r>
           </a:p>
           <a:p>
-            <a:pPr algn="l">
+            <a:pPr marL="285750" indent="-285750" algn="l">
               <a:lnSpc>
                 <a:spcPct val="144000"/>
               </a:lnSpc>
               <a:spcAft>
                 <a:spcPts val="450"/>
               </a:spcAft>
+              <a:buFont typeface="Arial" panose="020B0604020202020204" pitchFamily="34" charset="0"/>
+              <a:buChar char="•"/>
             </a:pPr>
             <a:r>
               <a:rPr lang="ko-KR" sz="1220" b="1" dirty="0">
                 <a:solidFill>
-                  <a:srgbClr val="273A52"/>
-                </a:solidFill>
-                <a:latin typeface="맑은 고딕"/>
-                <a:ea typeface="맑은 고딕"/>
-              </a:rPr>
-              <a:t>·  </a:t>
-            </a:r>
-            <a:r>
-              <a:rPr lang="ko-KR" sz="1220" b="1" dirty="0">
-                <a:solidFill>
                   <a:srgbClr val="1E2227"/>
                 </a:solidFill>
                 <a:latin typeface="맑은 고딕"/>
@@ -27823,27 +28667,19 @@
             </a:r>
           </a:p>
           <a:p>
-            <a:pPr algn="l">
+            <a:pPr marL="285750" indent="-285750" algn="l">
               <a:lnSpc>
                 <a:spcPct val="144000"/>
               </a:lnSpc>
               <a:spcAft>
                 <a:spcPts val="450"/>
               </a:spcAft>
+              <a:buFont typeface="Arial" panose="020B0604020202020204" pitchFamily="34" charset="0"/>
+              <a:buChar char="•"/>
             </a:pPr>
             <a:r>
               <a:rPr lang="ko-KR" sz="1220" b="1" dirty="0">
                 <a:solidFill>
-                  <a:srgbClr val="273A52"/>
-                </a:solidFill>
-                <a:latin typeface="맑은 고딕"/>
-                <a:ea typeface="맑은 고딕"/>
-              </a:rPr>
-              <a:t>·  </a:t>
-            </a:r>
-            <a:r>
-              <a:rPr lang="ko-KR" sz="1220" b="1" dirty="0">
-                <a:solidFill>
                   <a:srgbClr val="1E2227"/>
                 </a:solidFill>
                 <a:latin typeface="맑은 고딕"/>
@@ -27863,24 +28699,16 @@
             </a:r>
           </a:p>
           <a:p>
-            <a:pPr algn="l">
+            <a:pPr marL="285750" indent="-285750" algn="l">
               <a:lnSpc>
                 <a:spcPct val="144000"/>
               </a:lnSpc>
               <a:spcAft>
                 <a:spcPts val="0"/>
               </a:spcAft>
+              <a:buFont typeface="Arial" panose="020B0604020202020204" pitchFamily="34" charset="0"/>
+              <a:buChar char="•"/>
             </a:pPr>
-            <a:r>
-              <a:rPr lang="ko-KR" sz="1220" b="1" dirty="0">
-                <a:solidFill>
-                  <a:srgbClr val="273A52"/>
-                </a:solidFill>
-                <a:latin typeface="맑은 고딕"/>
-                <a:ea typeface="맑은 고딕"/>
-              </a:rPr>
-              <a:t>·  </a:t>
-            </a:r>
             <a:r>
               <a:rPr lang="ko-KR" sz="1220" b="1" dirty="0">
                 <a:solidFill>
@@ -28209,7 +29037,7 @@
               </a:spcAft>
             </a:pPr>
             <a:r>
-              <a:rPr lang="ko-KR" sz="1300" b="1" dirty="0">
+              <a:rPr lang="ko-KR" sz="1200" b="1" dirty="0">
                 <a:solidFill>
                   <a:srgbClr val="273A52"/>
                 </a:solidFill>
@@ -28425,7 +29253,7 @@
               </a:spcAft>
             </a:pPr>
             <a:r>
-              <a:rPr lang="ko-KR" sz="1300" b="1" dirty="0">
+              <a:rPr lang="ko-KR" sz="1200" b="1" dirty="0">
                 <a:solidFill>
                   <a:srgbClr val="273A52"/>
                 </a:solidFill>
@@ -28641,7 +29469,7 @@
               </a:spcAft>
             </a:pPr>
             <a:r>
-              <a:rPr lang="ko-KR" sz="1300" b="1" dirty="0">
+              <a:rPr lang="ko-KR" sz="1200" b="1" dirty="0">
                 <a:solidFill>
                   <a:srgbClr val="273A52"/>
                 </a:solidFill>

</xml_diff>

<commit_message>
refactor(data): group processed outputs into per-dataset folders
</commit_message>
<xml_diff>
--- a/docs/ThinkConflict_연구보고.pptx
+++ b/docs/ThinkConflict_연구보고.pptx
@@ -29,7 +29,7 @@
     <p:sldId id="686" r:id="rId20"/>
     <p:sldId id="687" r:id="rId21"/>
     <p:sldId id="698" r:id="rId22"/>
-    <p:sldId id="695" r:id="rId23"/>
+    <p:sldId id="702" r:id="rId23"/>
     <p:sldId id="440" r:id="rId24"/>
     <p:sldId id="441" r:id="rId25"/>
     <p:sldId id="443" r:id="rId26"/>
@@ -1078,6 +1078,90 @@
     <p:extLst>
       <p:ext uri="{BB962C8B-B14F-4D97-AF65-F5344CB8AC3E}">
         <p14:creationId xmlns:p14="http://schemas.microsoft.com/office/powerpoint/2010/main" val="4064272018"/>
+      </p:ext>
+    </p:extLst>
+  </p:cSld>
+  <p:clrMapOvr>
+    <a:masterClrMapping/>
+  </p:clrMapOvr>
+</p:notes>
+</file>
+
+<file path=ppt/notesSlides/notesSlide8.xml><?xml version="1.0" encoding="utf-8"?>
+<p:notes xmlns:a="http://schemas.openxmlformats.org/drawingml/2006/main" xmlns:r="http://schemas.openxmlformats.org/officeDocument/2006/relationships" xmlns:p="http://schemas.openxmlformats.org/presentationml/2006/main">
+  <p:cSld>
+    <p:spTree>
+      <p:nvGrpSpPr>
+        <p:cNvPr id="1" name=""/>
+        <p:cNvGrpSpPr/>
+        <p:nvPr/>
+      </p:nvGrpSpPr>
+      <p:grpSpPr>
+        <a:xfrm>
+          <a:off x="0" y="0"/>
+          <a:ext cx="0" cy="0"/>
+          <a:chOff x="0" y="0"/>
+          <a:chExt cx="0" cy="0"/>
+        </a:xfrm>
+      </p:grpSpPr>
+      <p:sp>
+        <p:nvSpPr>
+          <p:cNvPr id="2" name="슬라이드 이미지 개체 틀 1"/>
+          <p:cNvSpPr>
+            <a:spLocks noGrp="1" noRot="1" noChangeAspect="1"/>
+          </p:cNvSpPr>
+          <p:nvPr>
+            <p:ph type="sldImg"/>
+          </p:nvPr>
+        </p:nvSpPr>
+        <p:spPr/>
+      </p:sp>
+      <p:sp>
+        <p:nvSpPr>
+          <p:cNvPr id="3" name="슬라이드 노트 개체 틀 2"/>
+          <p:cNvSpPr>
+            <a:spLocks noGrp="1"/>
+          </p:cNvSpPr>
+          <p:nvPr>
+            <p:ph type="body" idx="1"/>
+          </p:nvPr>
+        </p:nvSpPr>
+        <p:spPr/>
+        <p:txBody>
+          <a:bodyPr/>
+          <a:lstStyle/>
+          <a:p>
+            <a:endParaRPr kumimoji="1" lang="ko-KR" altLang="en-US" dirty="0"/>
+          </a:p>
+        </p:txBody>
+      </p:sp>
+      <p:sp>
+        <p:nvSpPr>
+          <p:cNvPr id="4" name="슬라이드 번호 개체 틀 3"/>
+          <p:cNvSpPr>
+            <a:spLocks noGrp="1"/>
+          </p:cNvSpPr>
+          <p:nvPr>
+            <p:ph type="sldNum" sz="quarter" idx="5"/>
+          </p:nvPr>
+        </p:nvSpPr>
+        <p:spPr/>
+        <p:txBody>
+          <a:bodyPr/>
+          <a:lstStyle/>
+          <a:p>
+            <a:fld id="{79492483-278F-4C46-B567-3E1E49742A91}" type="slidenum">
+              <a:rPr kumimoji="1" lang="ko-KR" altLang="en-US" smtClean="0"/>
+              <a:t>22</a:t>
+            </a:fld>
+            <a:endParaRPr kumimoji="1" lang="ko-KR" altLang="en-US"/>
+          </a:p>
+        </p:txBody>
+      </p:sp>
+    </p:spTree>
+    <p:extLst>
+      <p:ext uri="{BB962C8B-B14F-4D97-AF65-F5344CB8AC3E}">
+        <p14:creationId xmlns:p14="http://schemas.microsoft.com/office/powerpoint/2010/main" val="2355646164"/>
       </p:ext>
     </p:extLst>
   </p:cSld>
@@ -26172,7 +26256,7 @@
         <p:spPr>
           <a:xfrm>
             <a:off x="548640" y="1270000"/>
-            <a:ext cx="11091672" cy="1208601"/>
+            <a:ext cx="11091672" cy="967060"/>
           </a:xfrm>
           <a:prstGeom prst="rect">
             <a:avLst/>
@@ -26198,7 +26282,7 @@
                 <a:latin typeface="맑은 고딕"/>
                 <a:ea typeface="맑은 고딕"/>
               </a:rPr>
-              <a:t>① 1단계 — 추론 켜고/끄기 비교(thinking on/off) · 진행 게이트(go/no-go)</a:t>
+              <a:t>① 1단계 — 추론 켜고/끄기 비교(thinking on/off)</a:t>
             </a:r>
           </a:p>
           <a:p>
@@ -26230,26 +26314,7 @@
                 <a:latin typeface="맑은 고딕"/>
                 <a:ea typeface="맑은 고딕"/>
               </a:rPr>
-              <a:t>같은 문항을 추론 OFF↔ON으로 돌려 답 변화를 전환 행렬(실험 1과 동일)로 짝지어 비교 </a:t>
-            </a:r>
-            <a:br>
-              <a:rPr lang="en-US" altLang="ko-KR" sz="1150" b="0" dirty="0">
-                <a:solidFill>
-                  <a:srgbClr val="1E2227"/>
-                </a:solidFill>
-                <a:latin typeface="맑은 고딕"/>
-                <a:ea typeface="맑은 고딕"/>
-              </a:rPr>
-            </a:br>
-            <a:r>
-              <a:rPr lang="ko-KR" sz="1150" b="0" dirty="0">
-                <a:solidFill>
-                  <a:srgbClr val="1E2227"/>
-                </a:solidFill>
-                <a:latin typeface="맑은 고딕"/>
-                <a:ea typeface="맑은 고딕"/>
-              </a:rPr>
-              <a:t>— (i) 충돌 해소↑(이득), (ii) 새 실패 </a:t>
+              <a:t>같은 문항을 추론 OFF↔ON으로 돌려 답 변화를 전환 행렬(실험 1과 동일)로 짝지어 비교 — (i) 충돌 해소↑(이득), (ii) 새 실패 </a:t>
             </a:r>
             <a:r>
               <a:rPr lang="ko-KR" sz="1150" b="1" dirty="0">
@@ -26291,7 +26356,7 @@
                 <a:latin typeface="맑은 고딕"/>
                 <a:ea typeface="맑은 고딕"/>
               </a:rPr>
-              <a:t>진행 게이트(go/no-go): </a:t>
+              <a:t>모델: </a:t>
             </a:r>
             <a:r>
               <a:rPr lang="ko-KR" sz="1150" b="0" dirty="0">
@@ -26301,39 +26366,7 @@
                 <a:latin typeface="맑은 고딕"/>
                 <a:ea typeface="맑은 고딕"/>
               </a:rPr>
-              <a:t>추론 과정(&lt;think&gt;)을 통째로 가려도 답이 안 바뀌면 추론은 겉치레 → 진단 중단(바뀌면 진행).</a:t>
-            </a:r>
-          </a:p>
-          <a:p>
-            <a:pPr marL="171450" indent="-171450" algn="l">
-              <a:lnSpc>
-                <a:spcPct val="122000"/>
-              </a:lnSpc>
-              <a:spcAft>
-                <a:spcPts val="200"/>
-              </a:spcAft>
-              <a:buFont typeface="Arial" panose="020B0604020202020204" pitchFamily="34" charset="0"/>
-              <a:buChar char="•"/>
-            </a:pPr>
-            <a:r>
-              <a:rPr lang="ko-KR" sz="1150" b="1" dirty="0">
-                <a:solidFill>
-                  <a:srgbClr val="1E2227"/>
-                </a:solidFill>
-                <a:latin typeface="맑은 고딕"/>
-                <a:ea typeface="맑은 고딕"/>
-              </a:rPr>
-              <a:t>모델: </a:t>
-            </a:r>
-            <a:r>
-              <a:rPr lang="ko-KR" sz="1150" b="0" dirty="0">
-                <a:solidFill>
-                  <a:srgbClr val="1E2227"/>
-                </a:solidFill>
-                <a:latin typeface="맑은 고딕"/>
-                <a:ea typeface="맑은 고딕"/>
-              </a:rPr>
-              <a:t>같은 모델을 가중치 그대로 두고 추론 스위치만 켜고/끔(하드 토글) — 주력 Qwen3.6-27B · 보조 gpt-oss-20b(참고용).</a:t>
+              <a:t>Qwen3.6-27B(동일 가중치 하드 토글) · 보조 gpt-oss-20b(참고용)</a:t>
             </a:r>
           </a:p>
         </p:txBody>
@@ -26346,8 +26379,8 @@
         </p:nvSpPr>
         <p:spPr>
           <a:xfrm>
-            <a:off x="548640" y="5472684"/>
-            <a:ext cx="11091672" cy="838200"/>
+            <a:off x="548640" y="5441188"/>
+            <a:ext cx="11091672" cy="889000"/>
           </a:xfrm>
           <a:prstGeom prst="rect">
             <a:avLst/>
@@ -26379,95 +26412,65 @@
           <a:p>
             <a:pPr marL="171450" indent="-171450" algn="l">
               <a:lnSpc>
-                <a:spcPct val="122000"/>
+                <a:spcPct val="112000"/>
               </a:lnSpc>
               <a:spcAft>
-                <a:spcPts val="200"/>
+                <a:spcPts val="100"/>
               </a:spcAft>
-              <a:buFont typeface="Arial" panose="020B0604020202020204" pitchFamily="34" charset="0"/>
+              <a:buFont typeface="Arial"/>
               <a:buChar char="•"/>
             </a:pPr>
             <a:r>
-              <a:rPr lang="ko-KR" sz="1150" b="1" dirty="0">
-                <a:solidFill>
-                  <a:srgbClr val="1E2227"/>
-                </a:solidFill>
-                <a:latin typeface="맑은 고딕"/>
-                <a:ea typeface="맑은 고딕"/>
-              </a:rPr>
-              <a:t>해석 규칙(사전등록). </a:t>
-            </a:r>
-            <a:r>
-              <a:rPr lang="en-US" sz="1150" b="0" dirty="0">
-                <a:solidFill>
-                  <a:srgbClr val="1E2227"/>
-                </a:solidFill>
-                <a:latin typeface="Cambria Math"/>
-                <a:ea typeface="맑은 고딕"/>
-              </a:rPr>
-              <a:t>인과 기여 = 절단 효과 − no-op 기준선</a:t>
-            </a:r>
-            <a:r>
-              <a:rPr lang="ko-KR" sz="1150" b="0" dirty="0">
-                <a:solidFill>
-                  <a:srgbClr val="1E2227"/>
-                </a:solidFill>
-                <a:latin typeface="맑은 고딕"/>
-                <a:ea typeface="맑은 고딕"/>
-              </a:rPr>
-              <a:t> — filler로 형식 교란 상한을 확인한 뒤에만 인과로 해석한다.</a:t>
+              <a:rPr lang="ko-KR" sz="1120" b="1" dirty="0">
+                <a:solidFill>
+                  <a:srgbClr val="1E2227"/>
+                </a:solidFill>
+                <a:latin typeface="맑은 고딕"/>
+                <a:ea typeface="맑은 고딕"/>
+              </a:rPr>
+              <a:t>해석 규칙(사전등록): </a:t>
+            </a:r>
+            <a:r>
+              <a:rPr lang="ko-KR" sz="1120" b="0" dirty="0">
+                <a:solidFill>
+                  <a:srgbClr val="1E2227"/>
+                </a:solidFill>
+                <a:latin typeface="맑은 고딕"/>
+                <a:ea typeface="맑은 고딕"/>
+              </a:rPr>
+              <a:t>절단 효과에서 ‘자르는 행위 자체’가 만든 변화(no-op 기준선)를 뺀 나머지만 인과 기여로 보고, filler 대조로 잰 형식 교란의 최대치를 넘는 효과만 인과로 해석한다.</a:t>
             </a:r>
           </a:p>
           <a:p>
             <a:pPr marL="171450" indent="-171450" algn="l">
               <a:lnSpc>
-                <a:spcPct val="122000"/>
+                <a:spcPct val="112000"/>
               </a:lnSpc>
               <a:spcAft>
-                <a:spcPts val="200"/>
+                <a:spcPts val="100"/>
               </a:spcAft>
-              <a:buFont typeface="Arial" panose="020B0604020202020204" pitchFamily="34" charset="0"/>
+              <a:buFont typeface="Arial"/>
               <a:buChar char="•"/>
             </a:pPr>
             <a:r>
-              <a:rPr lang="ko-KR" sz="1150" b="1" dirty="0">
-                <a:solidFill>
-                  <a:srgbClr val="1E2227"/>
-                </a:solidFill>
-                <a:latin typeface="맑은 고딕"/>
-                <a:ea typeface="맑은 고딕"/>
-              </a:rPr>
-              <a:t>경로별 취약성(RQ2 연계). </a:t>
-            </a:r>
-            <a:r>
-              <a:rPr lang="ko-KR" sz="1150" b="0" dirty="0">
-                <a:solidFill>
-                  <a:srgbClr val="1E2227"/>
-                </a:solidFill>
-                <a:latin typeface="맑은 고딕"/>
-                <a:ea typeface="맑은 고딕"/>
-              </a:rPr>
-              <a:t>정답 경로마다 동일 개입 → 뒤집힘 비율 비교. 취약 경로가 더 자주 뒤집히면 </a:t>
-            </a:r>
-            <a:r>
-              <a:rPr lang="ko-KR" sz="1150" b="1" dirty="0">
-                <a:solidFill>
-                  <a:srgbClr val="1E2227"/>
-                </a:solidFill>
-                <a:latin typeface="맑은 고딕"/>
-                <a:ea typeface="맑은 고딕"/>
-              </a:rPr>
-              <a:t>‘취약’은 인과적 성질</a:t>
-            </a:r>
-            <a:r>
-              <a:rPr lang="ko-KR" sz="1150" b="0" dirty="0">
-                <a:solidFill>
-                  <a:srgbClr val="1E2227"/>
-                </a:solidFill>
-                <a:latin typeface="맑은 고딕"/>
-                <a:ea typeface="맑은 고딕"/>
-              </a:rPr>
-              <a:t>이다.</a:t>
+              <a:rPr lang="ko-KR" sz="1120" b="1" dirty="0">
+                <a:solidFill>
+                  <a:srgbClr val="1E2227"/>
+                </a:solidFill>
+                <a:latin typeface="맑은 고딕"/>
+                <a:ea typeface="맑은 고딕"/>
+              </a:rPr>
+              <a:t>경로별 취약성(RQ2 연계): </a:t>
+            </a:r>
+            <a:r>
+              <a:rPr lang="ko-KR" sz="1120" b="0" dirty="0">
+                <a:solidFill>
+                  <a:srgbClr val="1E2227"/>
+                </a:solidFill>
+                <a:latin typeface="맑은 고딕"/>
+                <a:ea typeface="맑은 고딕"/>
+              </a:rPr>
+              <a:t>네 경로의 정답에 같은 개입을 가해 뒤집힘 비율을 비교한다 — 취약 경로(도약·불협)가 실제로 더 자주 뒤집히면 ‘취약’은 이름표가 아니라 인과적으로 확인된 성질이다.</a:t>
             </a:r>
           </a:p>
         </p:txBody>
@@ -26480,8 +26483,8 @@
         </p:nvSpPr>
         <p:spPr>
           <a:xfrm>
-            <a:off x="548640" y="2667000"/>
-            <a:ext cx="11087100" cy="254000"/>
+            <a:off x="548640" y="2431288"/>
+            <a:ext cx="11087100" cy="273008"/>
           </a:xfrm>
           <a:prstGeom prst="rect">
             <a:avLst/>
@@ -26517,14 +26520,14 @@
           <p:nvPr>
             <p:extLst>
               <p:ext uri="{D42A27DB-BD31-4B8C-83A1-F6EECF244321}">
-                <p14:modId xmlns:p14="http://schemas.microsoft.com/office/powerpoint/2010/main" val="1567363040"/>
+                <p14:modId xmlns:p14="http://schemas.microsoft.com/office/powerpoint/2010/main" val="1336106366"/>
               </p:ext>
             </p:extLst>
           </p:nvPr>
         </p:nvGraphicFramePr>
         <p:xfrm>
-          <a:off x="548640" y="3022600"/>
-          <a:ext cx="11091672" cy="2354070"/>
+          <a:off x="548640" y="2724404"/>
+          <a:ext cx="11091672" cy="2566923"/>
         </p:xfrm>
         <a:graphic>
           <a:graphicData uri="http://schemas.openxmlformats.org/drawingml/2006/table">
@@ -26555,7 +26558,7 @@
                   </a:extLst>
                 </a:gridCol>
               </a:tblGrid>
-              <a:tr h="416880">
+              <a:tr h="480933">
                 <a:tc>
                   <a:txBody>
                     <a:bodyPr/>
@@ -26655,7 +26658,7 @@
                   </a:ext>
                 </a:extLst>
               </a:tr>
-              <a:tr h="506770">
+              <a:tr h="327150">
                 <a:tc>
                   <a:txBody>
                     <a:bodyPr/>
@@ -26677,7 +26680,7 @@
                           <a:latin typeface="맑은 고딕"/>
                           <a:ea typeface="맑은 고딕"/>
                         </a:rPr>
-                        <a:t>Truncation</a:t>
+                        <a:t>전체 마스킹</a:t>
                       </a:r>
                     </a:p>
                   </a:txBody>
@@ -26701,14 +26704,14 @@
                         </a:spcAft>
                       </a:pPr>
                       <a:r>
-                        <a:rPr sz="1120" b="1">
-                          <a:solidFill>
-                            <a:srgbClr val="273A52"/>
-                          </a:solidFill>
-                          <a:latin typeface="맑은 고딕"/>
-                          <a:ea typeface="맑은 고딕"/>
-                        </a:rPr>
-                        <a:t>주력</a:t>
+                        <a:rPr sz="1100" b="0">
+                          <a:solidFill>
+                            <a:srgbClr val="6B7480"/>
+                          </a:solidFill>
+                          <a:latin typeface="맑은 고딕"/>
+                          <a:ea typeface="맑은 고딕"/>
+                        </a:rPr>
+                        <a:t>예비 점검</a:t>
                       </a:r>
                     </a:p>
                   </a:txBody>
@@ -26739,7 +26742,7 @@
                           <a:latin typeface="맑은 고딕"/>
                           <a:ea typeface="맑은 고딕"/>
                         </a:rPr>
-                        <a:t>여러 절단 지점에서 추론을 멈추고 즉시 답을 내도록 강제해, </a:t>
+                        <a:t>추론(&lt;think&gt;) 전체를 빈 내용·필러로 바꿔 답만 재생성 — </a:t>
                       </a:r>
                       <a:r>
                         <a:rPr sz="1120" b="1">
@@ -26749,7 +26752,7 @@
                           <a:latin typeface="맑은 고딕"/>
                           <a:ea typeface="맑은 고딕"/>
                         </a:rPr>
-                        <a:t>어느 지점부터 답이 고정되는지</a:t>
+                        <a:t>답이 그대로면 추론은 장식</a:t>
                       </a:r>
                       <a:r>
                         <a:rPr sz="1120" b="0">
@@ -26759,7 +26762,7 @@
                           <a:latin typeface="맑은 고딕"/>
                           <a:ea typeface="맑은 고딕"/>
                         </a:rPr>
-                        <a:t> 측정합니다 (Lanham ’23).</a:t>
+                        <a:t>.</a:t>
                       </a:r>
                     </a:p>
                   </a:txBody>
@@ -26775,7 +26778,127 @@
                   </a:ext>
                 </a:extLst>
               </a:tr>
-              <a:tr h="416880">
+              <a:tr h="477230">
+                <a:tc>
+                  <a:txBody>
+                    <a:bodyPr/>
+                    <a:lstStyle/>
+                    <a:p>
+                      <a:pPr algn="l">
+                        <a:lnSpc>
+                          <a:spcPct val="114000"/>
+                        </a:lnSpc>
+                        <a:spcAft>
+                          <a:spcPts val="200"/>
+                        </a:spcAft>
+                      </a:pPr>
+                      <a:r>
+                        <a:rPr sz="1120" b="1">
+                          <a:solidFill>
+                            <a:srgbClr val="1E2227"/>
+                          </a:solidFill>
+                          <a:latin typeface="맑은 고딕"/>
+                          <a:ea typeface="맑은 고딕"/>
+                        </a:rPr>
+                        <a:t>Truncation</a:t>
+                      </a:r>
+                    </a:p>
+                  </a:txBody>
+                  <a:tcPr marL="82296" marR="82296" marT="36576" marB="36576" anchor="ctr">
+                    <a:solidFill>
+                      <a:srgbClr val="FFFFFF"/>
+                    </a:solidFill>
+                  </a:tcPr>
+                </a:tc>
+                <a:tc>
+                  <a:txBody>
+                    <a:bodyPr/>
+                    <a:lstStyle/>
+                    <a:p>
+                      <a:pPr algn="l">
+                        <a:lnSpc>
+                          <a:spcPct val="114000"/>
+                        </a:lnSpc>
+                        <a:spcAft>
+                          <a:spcPts val="200"/>
+                        </a:spcAft>
+                      </a:pPr>
+                      <a:r>
+                        <a:rPr sz="1120" b="1">
+                          <a:solidFill>
+                            <a:srgbClr val="273A52"/>
+                          </a:solidFill>
+                          <a:latin typeface="맑은 고딕"/>
+                          <a:ea typeface="맑은 고딕"/>
+                        </a:rPr>
+                        <a:t>주력</a:t>
+                      </a:r>
+                    </a:p>
+                  </a:txBody>
+                  <a:tcPr marL="82296" marR="82296" marT="36576" marB="36576" anchor="ctr">
+                    <a:solidFill>
+                      <a:srgbClr val="FFFFFF"/>
+                    </a:solidFill>
+                  </a:tcPr>
+                </a:tc>
+                <a:tc>
+                  <a:txBody>
+                    <a:bodyPr/>
+                    <a:lstStyle/>
+                    <a:p>
+                      <a:pPr algn="l">
+                        <a:lnSpc>
+                          <a:spcPct val="114000"/>
+                        </a:lnSpc>
+                        <a:spcAft>
+                          <a:spcPts val="200"/>
+                        </a:spcAft>
+                      </a:pPr>
+                      <a:r>
+                        <a:rPr sz="1120" b="0">
+                          <a:solidFill>
+                            <a:srgbClr val="1E2227"/>
+                          </a:solidFill>
+                          <a:latin typeface="맑은 고딕"/>
+                          <a:ea typeface="맑은 고딕"/>
+                        </a:rPr>
+                        <a:t>여러 절단 지점에서 추론을 멈추고 즉시 답을 내도록 강제해, </a:t>
+                      </a:r>
+                      <a:r>
+                        <a:rPr sz="1120" b="1">
+                          <a:solidFill>
+                            <a:srgbClr val="1E2227"/>
+                          </a:solidFill>
+                          <a:latin typeface="맑은 고딕"/>
+                          <a:ea typeface="맑은 고딕"/>
+                        </a:rPr>
+                        <a:t>어느 지점부터 답이 고정되는지</a:t>
+                      </a:r>
+                      <a:r>
+                        <a:rPr sz="1120" b="0">
+                          <a:solidFill>
+                            <a:srgbClr val="1E2227"/>
+                          </a:solidFill>
+                          <a:latin typeface="맑은 고딕"/>
+                          <a:ea typeface="맑은 고딕"/>
+                        </a:rPr>
+                        <a:t> 측정합니다 (Lanham ’23).</a:t>
+                      </a:r>
+                    </a:p>
+                  </a:txBody>
+                  <a:tcPr marL="82296" marR="82296" marT="36576" marB="36576" anchor="ctr">
+                    <a:solidFill>
+                      <a:srgbClr val="FFFFFF"/>
+                    </a:solidFill>
+                  </a:tcPr>
+                </a:tc>
+                <a:extLst>
+                  <a:ext uri="{0D108BD9-81ED-4DB2-BD59-A6C34878D82A}">
+                    <a16:rowId xmlns:a16="http://schemas.microsoft.com/office/drawing/2014/main" val="1803315874"/>
+                  </a:ext>
+                </a:extLst>
+              </a:tr>
+              <a:tr h="327150">
                 <a:tc>
                   <a:txBody>
                     <a:bodyPr/>
@@ -26852,34 +26975,314 @@
                         </a:spcAft>
                       </a:pPr>
                       <a:r>
-                        <a:rPr sz="1120" b="0">
+                        <a:rPr sz="1120" b="0" dirty="0" err="1">
                           <a:solidFill>
                             <a:srgbClr val="1E2227"/>
                           </a:solidFill>
                           <a:latin typeface="맑은 고딕"/>
                           <a:ea typeface="맑은 고딕"/>
                         </a:rPr>
-                        <a:t>판정 문장(L2) 직후부터 답변을 여러 번 다시 생성해, </a:t>
-                      </a:r>
-                      <a:r>
-                        <a:rPr sz="1120" b="1">
+                        <a:t>판정</a:t>
+                      </a:r>
+                      <a:r>
+                        <a:rPr sz="1120" b="0" dirty="0">
                           <a:solidFill>
                             <a:srgbClr val="1E2227"/>
                           </a:solidFill>
                           <a:latin typeface="맑은 고딕"/>
                           <a:ea typeface="맑은 고딕"/>
                         </a:rPr>
-                        <a:t>그 판정이 최종 답을 좌우하는 정도</a:t>
-                      </a:r>
-                      <a:r>
-                        <a:rPr sz="1120" b="0">
+                        <a:t> </a:t>
+                      </a:r>
+                      <a:r>
+                        <a:rPr sz="1120" b="0" dirty="0" err="1">
                           <a:solidFill>
                             <a:srgbClr val="1E2227"/>
                           </a:solidFill>
                           <a:latin typeface="맑은 고딕"/>
                           <a:ea typeface="맑은 고딕"/>
                         </a:rPr>
-                        <a:t>를 추정합니다.</a:t>
+                        <a:t>문장</a:t>
+                      </a:r>
+                      <a:r>
+                        <a:rPr sz="1120" b="0" dirty="0">
+                          <a:solidFill>
+                            <a:srgbClr val="1E2227"/>
+                          </a:solidFill>
+                          <a:latin typeface="맑은 고딕"/>
+                          <a:ea typeface="맑은 고딕"/>
+                        </a:rPr>
+                        <a:t>(L2) </a:t>
+                      </a:r>
+                      <a:r>
+                        <a:rPr sz="1120" b="0" dirty="0" err="1">
+                          <a:solidFill>
+                            <a:srgbClr val="1E2227"/>
+                          </a:solidFill>
+                          <a:latin typeface="맑은 고딕"/>
+                          <a:ea typeface="맑은 고딕"/>
+                        </a:rPr>
+                        <a:t>직후부터</a:t>
+                      </a:r>
+                      <a:r>
+                        <a:rPr sz="1120" b="0" dirty="0">
+                          <a:solidFill>
+                            <a:srgbClr val="1E2227"/>
+                          </a:solidFill>
+                          <a:latin typeface="맑은 고딕"/>
+                          <a:ea typeface="맑은 고딕"/>
+                        </a:rPr>
+                        <a:t> </a:t>
+                      </a:r>
+                      <a:r>
+                        <a:rPr sz="1120" b="0" dirty="0" err="1">
+                          <a:solidFill>
+                            <a:srgbClr val="1E2227"/>
+                          </a:solidFill>
+                          <a:latin typeface="맑은 고딕"/>
+                          <a:ea typeface="맑은 고딕"/>
+                        </a:rPr>
+                        <a:t>답변을</a:t>
+                      </a:r>
+                      <a:r>
+                        <a:rPr sz="1120" b="0" dirty="0">
+                          <a:solidFill>
+                            <a:srgbClr val="1E2227"/>
+                          </a:solidFill>
+                          <a:latin typeface="맑은 고딕"/>
+                          <a:ea typeface="맑은 고딕"/>
+                        </a:rPr>
+                        <a:t> </a:t>
+                      </a:r>
+                      <a:r>
+                        <a:rPr sz="1120" b="0" dirty="0" err="1">
+                          <a:solidFill>
+                            <a:srgbClr val="1E2227"/>
+                          </a:solidFill>
+                          <a:latin typeface="맑은 고딕"/>
+                          <a:ea typeface="맑은 고딕"/>
+                        </a:rPr>
+                        <a:t>여러</a:t>
+                      </a:r>
+                      <a:r>
+                        <a:rPr sz="1120" b="0" dirty="0">
+                          <a:solidFill>
+                            <a:srgbClr val="1E2227"/>
+                          </a:solidFill>
+                          <a:latin typeface="맑은 고딕"/>
+                          <a:ea typeface="맑은 고딕"/>
+                        </a:rPr>
+                        <a:t> </a:t>
+                      </a:r>
+                      <a:r>
+                        <a:rPr sz="1120" b="0" dirty="0" err="1">
+                          <a:solidFill>
+                            <a:srgbClr val="1E2227"/>
+                          </a:solidFill>
+                          <a:latin typeface="맑은 고딕"/>
+                          <a:ea typeface="맑은 고딕"/>
+                        </a:rPr>
+                        <a:t>번</a:t>
+                      </a:r>
+                      <a:r>
+                        <a:rPr sz="1120" b="0" dirty="0">
+                          <a:solidFill>
+                            <a:srgbClr val="1E2227"/>
+                          </a:solidFill>
+                          <a:latin typeface="맑은 고딕"/>
+                          <a:ea typeface="맑은 고딕"/>
+                        </a:rPr>
+                        <a:t> </a:t>
+                      </a:r>
+                      <a:r>
+                        <a:rPr sz="1120" b="0" dirty="0" err="1">
+                          <a:solidFill>
+                            <a:srgbClr val="1E2227"/>
+                          </a:solidFill>
+                          <a:latin typeface="맑은 고딕"/>
+                          <a:ea typeface="맑은 고딕"/>
+                        </a:rPr>
+                        <a:t>다시</a:t>
+                      </a:r>
+                      <a:r>
+                        <a:rPr sz="1120" b="0" dirty="0">
+                          <a:solidFill>
+                            <a:srgbClr val="1E2227"/>
+                          </a:solidFill>
+                          <a:latin typeface="맑은 고딕"/>
+                          <a:ea typeface="맑은 고딕"/>
+                        </a:rPr>
+                        <a:t> </a:t>
+                      </a:r>
+                      <a:r>
+                        <a:rPr sz="1120" b="0" dirty="0" err="1">
+                          <a:solidFill>
+                            <a:srgbClr val="1E2227"/>
+                          </a:solidFill>
+                          <a:latin typeface="맑은 고딕"/>
+                          <a:ea typeface="맑은 고딕"/>
+                        </a:rPr>
+                        <a:t>생성해</a:t>
+                      </a:r>
+                      <a:r>
+                        <a:rPr sz="1120" b="0" dirty="0">
+                          <a:solidFill>
+                            <a:srgbClr val="1E2227"/>
+                          </a:solidFill>
+                          <a:latin typeface="맑은 고딕"/>
+                          <a:ea typeface="맑은 고딕"/>
+                        </a:rPr>
+                        <a:t>, </a:t>
+                      </a:r>
+                      <a:r>
+                        <a:rPr sz="1120" b="1" dirty="0" err="1">
+                          <a:solidFill>
+                            <a:srgbClr val="1E2227"/>
+                          </a:solidFill>
+                          <a:latin typeface="맑은 고딕"/>
+                          <a:ea typeface="맑은 고딕"/>
+                        </a:rPr>
+                        <a:t>그</a:t>
+                      </a:r>
+                      <a:r>
+                        <a:rPr sz="1120" b="1" dirty="0">
+                          <a:solidFill>
+                            <a:srgbClr val="1E2227"/>
+                          </a:solidFill>
+                          <a:latin typeface="맑은 고딕"/>
+                          <a:ea typeface="맑은 고딕"/>
+                        </a:rPr>
+                        <a:t> </a:t>
+                      </a:r>
+                      <a:r>
+                        <a:rPr sz="1120" b="1" dirty="0" err="1">
+                          <a:solidFill>
+                            <a:srgbClr val="1E2227"/>
+                          </a:solidFill>
+                          <a:latin typeface="맑은 고딕"/>
+                          <a:ea typeface="맑은 고딕"/>
+                        </a:rPr>
+                        <a:t>판정이</a:t>
+                      </a:r>
+                      <a:r>
+                        <a:rPr sz="1120" b="1" dirty="0">
+                          <a:solidFill>
+                            <a:srgbClr val="1E2227"/>
+                          </a:solidFill>
+                          <a:latin typeface="맑은 고딕"/>
+                          <a:ea typeface="맑은 고딕"/>
+                        </a:rPr>
+                        <a:t> </a:t>
+                      </a:r>
+                      <a:r>
+                        <a:rPr sz="1120" b="1" dirty="0" err="1">
+                          <a:solidFill>
+                            <a:srgbClr val="1E2227"/>
+                          </a:solidFill>
+                          <a:latin typeface="맑은 고딕"/>
+                          <a:ea typeface="맑은 고딕"/>
+                        </a:rPr>
+                        <a:t>최종</a:t>
+                      </a:r>
+                      <a:r>
+                        <a:rPr sz="1120" b="1" dirty="0">
+                          <a:solidFill>
+                            <a:srgbClr val="1E2227"/>
+                          </a:solidFill>
+                          <a:latin typeface="맑은 고딕"/>
+                          <a:ea typeface="맑은 고딕"/>
+                        </a:rPr>
+                        <a:t> </a:t>
+                      </a:r>
+                      <a:r>
+                        <a:rPr sz="1120" b="1" dirty="0" err="1">
+                          <a:solidFill>
+                            <a:srgbClr val="1E2227"/>
+                          </a:solidFill>
+                          <a:latin typeface="맑은 고딕"/>
+                          <a:ea typeface="맑은 고딕"/>
+                        </a:rPr>
+                        <a:t>답을</a:t>
+                      </a:r>
+                      <a:r>
+                        <a:rPr sz="1120" b="1" dirty="0">
+                          <a:solidFill>
+                            <a:srgbClr val="1E2227"/>
+                          </a:solidFill>
+                          <a:latin typeface="맑은 고딕"/>
+                          <a:ea typeface="맑은 고딕"/>
+                        </a:rPr>
+                        <a:t> </a:t>
+                      </a:r>
+                      <a:r>
+                        <a:rPr sz="1120" b="1" dirty="0" err="1">
+                          <a:solidFill>
+                            <a:srgbClr val="1E2227"/>
+                          </a:solidFill>
+                          <a:latin typeface="맑은 고딕"/>
+                          <a:ea typeface="맑은 고딕"/>
+                        </a:rPr>
+                        <a:t>좌우하는</a:t>
+                      </a:r>
+                      <a:r>
+                        <a:rPr sz="1120" b="1" dirty="0">
+                          <a:solidFill>
+                            <a:srgbClr val="1E2227"/>
+                          </a:solidFill>
+                          <a:latin typeface="맑은 고딕"/>
+                          <a:ea typeface="맑은 고딕"/>
+                        </a:rPr>
+                        <a:t> </a:t>
+                      </a:r>
+                      <a:r>
+                        <a:rPr sz="1120" b="1" dirty="0" err="1">
+                          <a:solidFill>
+                            <a:srgbClr val="1E2227"/>
+                          </a:solidFill>
+                          <a:latin typeface="맑은 고딕"/>
+                          <a:ea typeface="맑은 고딕"/>
+                        </a:rPr>
+                        <a:t>정도</a:t>
+                      </a:r>
+                      <a:r>
+                        <a:rPr sz="1120" b="0" dirty="0" err="1">
+                          <a:solidFill>
+                            <a:srgbClr val="1E2227"/>
+                          </a:solidFill>
+                          <a:latin typeface="맑은 고딕"/>
+                          <a:ea typeface="맑은 고딕"/>
+                        </a:rPr>
+                        <a:t>를</a:t>
+                      </a:r>
+                      <a:r>
+                        <a:rPr sz="1120" b="0" dirty="0">
+                          <a:solidFill>
+                            <a:srgbClr val="1E2227"/>
+                          </a:solidFill>
+                          <a:latin typeface="맑은 고딕"/>
+                          <a:ea typeface="맑은 고딕"/>
+                        </a:rPr>
+                        <a:t> </a:t>
+                      </a:r>
+                      <a:r>
+                        <a:rPr sz="1120" b="0" dirty="0" err="1">
+                          <a:solidFill>
+                            <a:srgbClr val="1E2227"/>
+                          </a:solidFill>
+                          <a:latin typeface="맑은 고딕"/>
+                          <a:ea typeface="맑은 고딕"/>
+                        </a:rPr>
+                        <a:t>추정합니다</a:t>
+                      </a:r>
+                      <a:r>
+                        <a:rPr sz="1120" b="0" dirty="0">
+                          <a:solidFill>
+                            <a:srgbClr val="1E2227"/>
+                          </a:solidFill>
+                          <a:latin typeface="맑은 고딕"/>
+                          <a:ea typeface="맑은 고딕"/>
+                        </a:rPr>
+                        <a:t>.</a:t>
                       </a:r>
                     </a:p>
                   </a:txBody>
@@ -26895,7 +27298,7 @@
                   </a:ext>
                 </a:extLst>
               </a:tr>
-              <a:tr h="506770">
+              <a:tr h="477230">
                 <a:tc>
                   <a:txBody>
                     <a:bodyPr/>
@@ -27275,7 +27678,7 @@
                   </a:ext>
                 </a:extLst>
               </a:tr>
-              <a:tr h="506770">
+              <a:tr h="477230">
                 <a:tc>
                   <a:txBody>
                     <a:bodyPr/>
@@ -27722,7 +28125,7 @@
     </p:spTree>
     <p:extLst>
       <p:ext uri="{BB962C8B-B14F-4D97-AF65-F5344CB8AC3E}">
-        <p14:creationId xmlns:p14="http://schemas.microsoft.com/office/powerpoint/2010/main" val="2122744758"/>
+        <p14:creationId xmlns:p14="http://schemas.microsoft.com/office/powerpoint/2010/main" val="3957266072"/>
       </p:ext>
     </p:extLst>
   </p:cSld>
@@ -28060,74 +28463,22 @@
                 <a:spcPct val="136000"/>
               </a:lnSpc>
               <a:spcAft>
-                <a:spcPts val="450"/>
-              </a:spcAft>
-              <a:buFont typeface="Arial" panose="020B0604020202020204" pitchFamily="34" charset="0"/>
-              <a:buChar char="•"/>
-            </a:pPr>
-            <a:r>
-              <a:rPr lang="ko-KR" sz="1120" b="0" dirty="0">
-                <a:solidFill>
-                  <a:srgbClr val="1E2227"/>
-                </a:solidFill>
-                <a:latin typeface="맑은 고딕"/>
-                <a:ea typeface="맑은 고딕"/>
-              </a:rPr>
-              <a:t>모델·환경별 </a:t>
-            </a:r>
-            <a:r>
-              <a:rPr lang="ko-KR" sz="1120" b="1" dirty="0">
-                <a:solidFill>
-                  <a:srgbClr val="1E2227"/>
-                </a:solidFill>
-                <a:latin typeface="맑은 고딕"/>
-                <a:ea typeface="맑은 고딕"/>
-              </a:rPr>
-              <a:t>전체 전환 행렬</a:t>
-            </a:r>
-            <a:r>
-              <a:rPr lang="ko-KR" sz="1120" b="0" dirty="0">
-                <a:solidFill>
-                  <a:srgbClr val="1E2227"/>
-                </a:solidFill>
-                <a:latin typeface="맑은 고딕"/>
-                <a:ea typeface="맑은 고딕"/>
-              </a:rPr>
-              <a:t>과, EM 상승분의 </a:t>
-            </a:r>
-            <a:r>
-              <a:rPr lang="ko-KR" sz="1120" b="1" dirty="0">
-                <a:solidFill>
-                  <a:srgbClr val="1E2227"/>
-                </a:solidFill>
-                <a:latin typeface="맑은 고딕"/>
-                <a:ea typeface="맑은 고딕"/>
-              </a:rPr>
-              <a:t>경로별 출처 분해</a:t>
-            </a:r>
-            <a:r>
-              <a:rPr lang="ko-KR" sz="1120" b="0" dirty="0">
-                <a:solidFill>
-                  <a:srgbClr val="1E2227"/>
-                </a:solidFill>
-                <a:latin typeface="맑은 고딕"/>
-                <a:ea typeface="맑은 고딕"/>
-              </a:rPr>
-              <a:t>입니다.</a:t>
-            </a:r>
-          </a:p>
-          <a:p>
-            <a:pPr marL="171450" indent="-171450" algn="l">
-              <a:lnSpc>
-                <a:spcPct val="136000"/>
-              </a:lnSpc>
-              <a:spcAft>
                 <a:spcPts val="0"/>
               </a:spcAft>
               <a:buFont typeface="Arial" panose="020B0604020202020204" pitchFamily="34" charset="0"/>
               <a:buChar char="•"/>
             </a:pPr>
             <a:r>
+              <a:rPr lang="ko-KR" altLang="en-US" sz="1120" b="1" dirty="0">
+                <a:solidFill>
+                  <a:srgbClr val="1E2227"/>
+                </a:solidFill>
+                <a:latin typeface="맑은 고딕"/>
+                <a:ea typeface="맑은 고딕"/>
+              </a:rPr>
+              <a:t>예상 결과</a:t>
+            </a:r>
+            <a:r>
               <a:rPr lang="ko-KR" sz="1120" b="1" dirty="0">
                 <a:solidFill>
                   <a:srgbClr val="1E2227"/>
@@ -28135,7 +28486,7 @@
                 <a:latin typeface="맑은 고딕"/>
                 <a:ea typeface="맑은 고딕"/>
               </a:rPr>
-              <a:t>가설: </a:t>
+              <a:t>: </a:t>
             </a:r>
             <a:r>
               <a:rPr lang="ko-KR" sz="1120" b="0" dirty="0">
@@ -28145,7 +28496,47 @@
                 <a:latin typeface="맑은 고딕"/>
                 <a:ea typeface="맑은 고딕"/>
               </a:rPr>
-              <a:t>완화 이득의 상당 부분이 정상 경로가 아니라 취약 경로에서 오는 경우가 있으며, 정답률 상승이 곧 추론 개선은 아님을 분해로 드러냅니다.</a:t>
+              <a:t>완화 이득</a:t>
+            </a:r>
+            <a:r>
+              <a:rPr lang="ko-KR" altLang="en-US" sz="1120" b="0" dirty="0">
+                <a:solidFill>
+                  <a:srgbClr val="1E2227"/>
+                </a:solidFill>
+                <a:latin typeface="맑은 고딕"/>
+                <a:ea typeface="맑은 고딕"/>
+              </a:rPr>
+              <a:t> 중</a:t>
+            </a:r>
+            <a:r>
+              <a:rPr lang="ko-KR" sz="1120" b="0" dirty="0">
+                <a:solidFill>
+                  <a:srgbClr val="1E2227"/>
+                </a:solidFill>
+                <a:latin typeface="맑은 고딕"/>
+                <a:ea typeface="맑은 고딕"/>
+              </a:rPr>
+              <a:t> </a:t>
+            </a:r>
+            <a:r>
+              <a:rPr lang="ko-KR" altLang="en-US" sz="1120" b="0" dirty="0">
+                <a:solidFill>
+                  <a:srgbClr val="1E2227"/>
+                </a:solidFill>
+                <a:latin typeface="맑은 고딕"/>
+                <a:ea typeface="맑은 고딕"/>
+              </a:rPr>
+              <a:t>일</a:t>
+            </a:r>
+            <a:r>
+              <a:rPr lang="ko-KR" sz="1120" b="0" dirty="0">
+                <a:solidFill>
+                  <a:srgbClr val="1E2227"/>
+                </a:solidFill>
+                <a:latin typeface="맑은 고딕"/>
+                <a:ea typeface="맑은 고딕"/>
+              </a:rPr>
+              <a:t>부분이 정상 경로가 아니라 취약 경로에서 오는 경우가 있으며, 정답률 상승이 곧 추론 개선은 아님을 분해로 드러냅니다.</a:t>
             </a:r>
           </a:p>
         </p:txBody>
@@ -28286,6 +28677,16 @@
               <a:buChar char="•"/>
             </a:pPr>
             <a:r>
+              <a:rPr lang="ko-KR" altLang="en-US" sz="1120" b="1" dirty="0">
+                <a:solidFill>
+                  <a:srgbClr val="1E2227"/>
+                </a:solidFill>
+                <a:latin typeface="맑은 고딕"/>
+                <a:ea typeface="맑은 고딕"/>
+              </a:rPr>
+              <a:t>예상 결과</a:t>
+            </a:r>
+            <a:r>
               <a:rPr lang="ko-KR" sz="1120" b="1" dirty="0">
                 <a:solidFill>
                   <a:srgbClr val="1E2227"/>
@@ -28293,7 +28694,7 @@
                 <a:latin typeface="맑은 고딕"/>
                 <a:ea typeface="맑은 고딕"/>
               </a:rPr>
-              <a:t>가설: </a:t>
+              <a:t>: </a:t>
             </a:r>
             <a:r>
               <a:rPr lang="ko-KR" sz="1120" b="0" dirty="0">
@@ -28305,18 +28706,16 @@
               </a:rPr>
               <a:t>AIR·특이 경로율이 충돌군에서 유의하게 높고(고유성),</a:t>
             </a:r>
-          </a:p>
-          <a:p>
-            <a:pPr marL="171450" indent="-171450" algn="l">
-              <a:lnSpc>
-                <a:spcPct val="136000"/>
-              </a:lnSpc>
-              <a:spcAft>
-                <a:spcPts val="0"/>
-              </a:spcAft>
-              <a:buFont typeface="Arial" panose="020B0604020202020204" pitchFamily="34" charset="0"/>
-              <a:buChar char="•"/>
-            </a:pPr>
+            <a:r>
+              <a:rPr lang="ko-KR" altLang="en-US" sz="1120" b="0" dirty="0">
+                <a:solidFill>
+                  <a:srgbClr val="1E2227"/>
+                </a:solidFill>
+                <a:latin typeface="맑은 고딕"/>
+                <a:ea typeface="맑은 고딕"/>
+              </a:rPr>
+              <a:t> </a:t>
+            </a:r>
             <a:r>
               <a:rPr lang="ko-KR" sz="1120" b="0" dirty="0">
                 <a:solidFill>
@@ -28486,6 +28885,16 @@
               <a:buChar char="•"/>
             </a:pPr>
             <a:r>
+              <a:rPr lang="ko-KR" altLang="en-US" sz="1120" b="1" dirty="0">
+                <a:solidFill>
+                  <a:srgbClr val="1E2227"/>
+                </a:solidFill>
+                <a:latin typeface="맑은 고딕"/>
+                <a:ea typeface="맑은 고딕"/>
+              </a:rPr>
+              <a:t>예상 결과</a:t>
+            </a:r>
+            <a:r>
               <a:rPr lang="ko-KR" sz="1120" b="1" dirty="0">
                 <a:solidFill>
                   <a:srgbClr val="1E2227"/>
@@ -28493,7 +28902,7 @@
                 <a:latin typeface="맑은 고딕"/>
                 <a:ea typeface="맑은 고딕"/>
               </a:rPr>
-              <a:t>가설: </a:t>
+              <a:t>: </a:t>
             </a:r>
             <a:r>
               <a:rPr lang="ko-KR" sz="1120" b="0" dirty="0">
@@ -28505,18 +28914,26 @@
               </a:rPr>
               <a:t>thinking-off에서 AIR·Shortcut이 사라지면 추론 채널이 원인이라는 증거가 되고,</a:t>
             </a:r>
-          </a:p>
-          <a:p>
-            <a:pPr marL="171450" indent="-171450" algn="l">
-              <a:lnSpc>
-                <a:spcPct val="136000"/>
-              </a:lnSpc>
-              <a:spcAft>
-                <a:spcPts val="0"/>
-              </a:spcAft>
-              <a:buFont typeface="Arial" panose="020B0604020202020204" pitchFamily="34" charset="0"/>
-              <a:buChar char="•"/>
-            </a:pPr>
+            <a:r>
+              <a:rPr lang="ko-KR" altLang="en-US" sz="1120" b="0" dirty="0">
+                <a:solidFill>
+                  <a:srgbClr val="1E2227"/>
+                </a:solidFill>
+                <a:latin typeface="맑은 고딕"/>
+                <a:ea typeface="맑은 고딕"/>
+              </a:rPr>
+              <a:t> </a:t>
+            </a:r>
+            <a:r>
+              <a:rPr lang="ko-KR" sz="1120" b="0" dirty="0" err="1">
+                <a:solidFill>
+                  <a:srgbClr val="1E2227"/>
+                </a:solidFill>
+                <a:latin typeface="맑은 고딕"/>
+                <a:ea typeface="맑은 고딕"/>
+              </a:rPr>
+              <a:t>Semantic</a:t>
+            </a:r>
             <a:r>
               <a:rPr lang="ko-KR" sz="1120" b="0" dirty="0">
                 <a:solidFill>
@@ -28525,7 +28942,7 @@
                 <a:latin typeface="맑은 고딕"/>
                 <a:ea typeface="맑은 고딕"/>
               </a:rPr>
-              <a:t>Semantic Shift·엔트로피 스파이크가 AIR 지점과 상관되면 개입 지점 후보가 됩니다.</a:t>
+              <a:t> Shift·엔트로피 스파이크가 AIR 지점과 상관되면 개입 지점 후보가 됩니다.</a:t>
             </a:r>
           </a:p>
         </p:txBody>

</xml_diff>